<commit_message>
Movilización: Zone 2 audit workbook, combined scenarios, deck updates
Co-Authored-By: Claude Opus 5.5 <noreply@anthropic.com>
Claude-Session: https://claude.ai/code/session_01BsMRKE8hArHddZxwmwcNWn
</commit_message>
<xml_diff>
--- a/movilizacion/entregables/Presentacion_Movilizacion_GRS110.pptx
+++ b/movilizacion/entregables/Presentacion_Movilizacion_GRS110.pptx
@@ -110,22 +110,22 @@
   <p:extLst>
     <p:ext uri="{521415D9-36F7-43E2-AB2F-B90AF26B5E84}">
       <p14:sectionLst xmlns:p14="http://schemas.microsoft.com/office/powerpoint/2010/main">
-        <p14:section name="Decisión" id="{cf601a1e-d06c-5123-ce06-894ecd32d2c7}">
+        <p14:section name="Decisión" id="{fecdad8c-344c-9e3c-d708-fa13f5ab07d9}">
           <p14:sldIdLst>
             <p14:sldId id="256"/>
           </p14:sldIdLst>
         </p14:section>
-        <p14:section name="Estructura de costo" id="{3da4cdd5-e736-06a4-332a-e75664cf8a09}">
+        <p14:section name="Estructura de costo" id="{5cfc5fcf-2dc1-61e2-44fb-87401ed19fd3}">
           <p14:sldIdLst>
             <p14:sldId id="257"/>
           </p14:sldIdLst>
         </p14:section>
-        <p14:section name="Frontera" id="{8b666fd5-4721-0221-cc7a-d3893d88822d}">
+        <p14:section name="Frontera" id="{7b57788f-1c0a-2971-9504-3ed5e73e095b}">
           <p14:sldIdLst>
             <p14:sldId id="258"/>
           </p14:sldIdLst>
         </p14:section>
-        <p14:section name="Pendientes" id="{bd7ca3f0-9307-836b-6429-4fb61953a932}">
+        <p14:section name="Pendientes" id="{56539297-460e-2279-9ab0-6bc14d91ff64}">
           <p14:sldIdLst>
             <p14:sldId id="259"/>
           </p14:sldIdLst>
@@ -6071,12 +6071,12 @@
               <a:buNone/>
             </a:pPr>
             <a:r>
-              <a:rPr lang="en-US" sz="1200" dirty="0">
+              <a:rPr lang="en-US" sz="1200" b="1" dirty="0">
                 <a:solidFill>
-                  <a:schemeClr val="tx2"/>
+                  <a:schemeClr val="accent5"/>
                 </a:solidFill>
               </a:rPr>
-              <a:t>Con horas reales del log: 2024 mejora y 2025 empeora (más horas de taladro).</a:t>
+              <a:t>Escenario prudente (frecuencia y mezcla de 2025, horas cotizadas por Petro Star): Petro Star −0,02 M y Ecotransur −0,01 M. Es el punto de equilibrio.</a:t>
             </a:r>
             <a:endParaRPr lang="en-US" sz="1200" dirty="0"/>
           </a:p>
@@ -8327,11 +8327,11 @@
         <p:spPr>
           <a:xfrm>
             <a:off x="8229600" y="1280160"/>
-            <a:ext cx="3383280" cy="3246120"/>
+            <a:ext cx="3383280" cy="4206240"/>
           </a:xfrm>
           <a:prstGeom prst="roundRect">
             <a:avLst>
-              <a:gd name="adj" fmla="val 2254"/>
+              <a:gd name="adj" fmla="val 2162"/>
             </a:avLst>
           </a:prstGeom>
           <a:solidFill>
@@ -8354,7 +8354,7 @@
         <p:spPr>
           <a:xfrm>
             <a:off x="8412480" y="1463040"/>
-            <a:ext cx="3017520" cy="2926080"/>
+            <a:ext cx="3017520" cy="3931920"/>
           </a:xfrm>
           <a:prstGeom prst="rect">
             <a:avLst/>
@@ -8392,7 +8392,7 @@
                   <a:schemeClr val="bg1"/>
                 </a:solidFill>
               </a:rPr>
-              <a:t>Seis de los siete pendientes, si se confirman en contra, reducen la ventaja del tercerizado; solo la diferencia de precios del Lump Sum la aumenta. Los valores de trabajo quedaron del lado favorable al tercerizado. Antes de cambiar el contrato hay que confirmar la frecuencia mensual esperada y el rango real de los pozos: son los dos datos que mueven la frontera.</a:t>
+              <a:t>Sesgo sistemático: casi todos los supuestos de la evaluación previa y de este caso base empujan hacia el tercerizado. Con la frecuencia y la mezcla de 2025 y las horas que cotizó Petro Star, el ahorro desaparece: Petro Star −0,02 M y Ecotransur −0,01 M. Antes de cambiar el contrato: confirmar la frecuencia mensual esperada, el rango real de los pozos y las horas que se pagarán al taladro.</a:t>
             </a:r>
             <a:endParaRPr lang="en-US" sz="1600" dirty="0"/>
           </a:p>

</xml_diff>

<commit_message>
Movilización: apply numbers and committee reviews (edge-case controls, empty-month fixed charge, scenarios generated in code, clearer labels, operational risks, TRM exposure)
Co-Authored-By: Claude Opus 5.5 <noreply@anthropic.com>
Claude-Session: https://claude.ai/code/session_01BsMRKE8hArHddZxwmwcNWn
</commit_message>
<xml_diff>
--- a/movilizacion/entregables/Presentacion_Movilizacion_GRS110.pptx
+++ b/movilizacion/entregables/Presentacion_Movilizacion_GRS110.pptx
@@ -110,22 +110,22 @@
   <p:extLst>
     <p:ext uri="{521415D9-36F7-43E2-AB2F-B90AF26B5E84}">
       <p14:sectionLst xmlns:p14="http://schemas.microsoft.com/office/powerpoint/2010/main">
-        <p14:section name="Decisión" id="{fecdad8c-344c-9e3c-d708-fa13f5ab07d9}">
+        <p14:section name="Decisión" id="{8014238a-a8d5-17b7-3deb-f345993eb452}">
           <p14:sldIdLst>
             <p14:sldId id="256"/>
           </p14:sldIdLst>
         </p14:section>
-        <p14:section name="Estructura de costo" id="{5cfc5fcf-2dc1-61e2-44fb-87401ed19fd3}">
+        <p14:section name="Estructura de costo" id="{998674bb-10da-3a6e-4ada-0031c4b08f8e}">
           <p14:sldIdLst>
             <p14:sldId id="257"/>
           </p14:sldIdLst>
         </p14:section>
-        <p14:section name="Frontera" id="{7b57788f-1c0a-2971-9504-3ed5e73e095b}">
+        <p14:section name="Frontera" id="{91978678-3ee4-8da8-8f6e-9f89ccc6dbfc}">
           <p14:sldIdLst>
             <p14:sldId id="258"/>
           </p14:sldIdLst>
         </p14:section>
-        <p14:section name="Pendientes" id="{56539297-460e-2279-9ab0-6bc14d91ff64}">
+        <p14:section name="Pendientes" id="{16a1ba24-25a4-8969-1abb-648b7a4ad8b8}">
           <p14:sldIdLst>
             <p14:sldId id="259"/>
           </p14:sldIdLst>
@@ -2357,7 +2357,7 @@
           <a:p>
             <a:r>
               <a:rPr lang="en-US" dirty="0"/>
-              <a:t>Gráfico: frecuencia constante; con 1 movilización por mes las pérdidas son de −4,2 a −5,8 M (fuera de escala). Tabla: hojas Real 2024 / Real 2025 del simulador, horas del Excel.</a:t>
+              <a:t>Gráfico: frecuencia constante; con 1 movilización por mes las pérdidas son de −4,2 a −5,8 M (fuera de escala). Los dientes (p. ej. de 9 a 10) vienen del último mes de la campaña, que queda por debajo de 6 y vuelve a pagar cargo fijo. Tabla: hojas Real 2024 / Real 2025 del simulador, horas del Excel.</a:t>
             </a:r>
             <a:endParaRPr lang="en-US" dirty="0"/>
           </a:p>
@@ -3056,7 +3056,7 @@
         <p:spPr>
           <a:xfrm>
             <a:off x="548640" y="1325880"/>
-            <a:ext cx="5669280" cy="3017520"/>
+            <a:ext cx="5669280" cy="3200400"/>
           </a:xfrm>
           <a:prstGeom prst="rect">
             <a:avLst/>
@@ -3079,24 +3079,24 @@
               </a:rPr>
               <a:t>Qué se decide</a:t>
             </a:r>
-            <a:endParaRPr lang="en-US" sz="1600" dirty="0"/>
+            <a:endParaRPr lang="en-US" sz="1300" dirty="0"/>
           </a:p>
           <a:p>
             <a:pPr indent="0" marL="0">
               <a:spcAft>
-                <a:spcPts val="1000"/>
+                <a:spcPts val="800"/>
               </a:spcAft>
               <a:buNone/>
             </a:pPr>
             <a:r>
-              <a:rPr lang="en-US" sz="1400" dirty="0">
+              <a:rPr lang="en-US" sz="1300" dirty="0">
                 <a:solidFill>
                   <a:schemeClr val="tx1"/>
                 </a:solidFill>
               </a:rPr>
-              <a:t>Mantener el Work Order (suma global por movilización, sin horas de taladro) o pasar a contratar directamente al transportador, pagando además el taladro por hora y un Truck Manager.</a:t>
+              <a:t>Mantener el Work Order (modelo directo: suma global por movilización, sin horas de taladro) o pasar al modelo tercerizado: SierraCol contrata aparte al transportador y paga además el taladro por hora durante la movilización y un coordinador de transporte (Truck Manager).</a:t>
             </a:r>
-            <a:endParaRPr lang="en-US" sz="1600" dirty="0"/>
+            <a:endParaRPr lang="en-US" sz="1300" dirty="0"/>
           </a:p>
           <a:p>
             <a:pPr indent="0" marL="0">
@@ -3110,24 +3110,24 @@
               </a:rPr>
               <a:t>Qué no se decide</a:t>
             </a:r>
-            <a:endParaRPr lang="en-US" sz="1600" dirty="0"/>
+            <a:endParaRPr lang="en-US" sz="1300" dirty="0"/>
           </a:p>
           <a:p>
             <a:pPr indent="0" marL="0">
               <a:spcAft>
-                <a:spcPts val="1000"/>
+                <a:spcPts val="800"/>
               </a:spcAft>
               <a:buNone/>
             </a:pPr>
             <a:r>
-              <a:rPr lang="en-US" sz="1400" dirty="0">
+              <a:rPr lang="en-US" sz="1300" dirty="0">
                 <a:solidFill>
                   <a:schemeClr val="tx1"/>
                 </a:solidFill>
               </a:rPr>
-              <a:t>No se adjudica proveedor ni se declara un ahorro único. Se evalúan tres ofertas: Petro Star tarifa normal, Petro Star Lump Sum y Ecotransur.</a:t>
+              <a:t>No se adjudica proveedor ni se declara un ahorro único. Se evalúan tres ofertas: Petro Star tarifa normal, Petro Star precio cerrado (Lump Sum) y Ecotransur.</a:t>
             </a:r>
-            <a:endParaRPr lang="en-US" sz="1600" dirty="0"/>
+            <a:endParaRPr lang="en-US" sz="1300" dirty="0"/>
           </a:p>
           <a:p>
             <a:pPr indent="0" marL="0">
@@ -3141,21 +3141,21 @@
               </a:rPr>
               <a:t>Por qué la respuesta es una frontera</a:t>
             </a:r>
-            <a:endParaRPr lang="en-US" sz="1600" dirty="0"/>
+            <a:endParaRPr lang="en-US" sz="1300" dirty="0"/>
           </a:p>
           <a:p>
             <a:pPr indent="0" marL="0">
               <a:buNone/>
             </a:pPr>
             <a:r>
-              <a:rPr lang="en-US" sz="1400" dirty="0">
+              <a:rPr lang="en-US" sz="1300" dirty="0">
                 <a:solidFill>
                   <a:schemeClr val="tx1"/>
                 </a:solidFill>
               </a:rPr>
               <a:t>El Work Order cuesta lo mismo por movilización haya 1 o 9 en el mes. El tercerizado cobra cargo fijo hasta la 4ª o 5ª movilización del mes y descuenta desde la 6ª: el resultado lo decide cuántas movilizaciones caen en cada mes, no el promedio.</a:t>
             </a:r>
-            <a:endParaRPr lang="en-US" sz="1600" dirty="0"/>
+            <a:endParaRPr lang="en-US" sz="1300" dirty="0"/>
           </a:p>
         </p:txBody>
       </p:sp>
@@ -3166,8 +3166,8 @@
           <p:nvPr/>
         </p:nvGraphicFramePr>
         <p:xfrm>
-          <a:off x="548640" y="4434840"/>
-          <a:ext cx="5669280" cy="1828800"/>
+          <a:off x="548640" y="4617720"/>
+          <a:ext cx="5669280" cy="1691640"/>
         </p:xfrm>
         <a:graphic xmlns:a="http://schemas.openxmlformats.org/drawingml/2006/main">
           <a:graphicData uri="http://schemas.openxmlformats.org/drawingml/2006/chart">
@@ -3503,7 +3503,7 @@
                   <a:schemeClr val="tx1"/>
                 </a:solidFill>
               </a:rPr>
-              <a:t>en ninguna frecuencia</a:t>
+              <a:t>con los precios del Excel</a:t>
             </a:r>
             <a:endParaRPr lang="en-US" sz="1400" dirty="0"/>
           </a:p>
@@ -3517,7 +3517,7 @@
                   <a:schemeClr val="tx2"/>
                 </a:solidFill>
               </a:rPr>
-              <a:t>Petro Star Lump Sum sin descuento: solo cruza con pozos en la misma localización</a:t>
+              <a:t>Petro Star Lump Sum sin descuento. Con los precios de la cotización 1255 sí cruzaría: pendiente de Compras (SCM)</a:t>
             </a:r>
             <a:endParaRPr lang="en-US" sz="1400" dirty="0"/>
           </a:p>
@@ -3531,8 +3531,8 @@
         </p:nvSpPr>
         <p:spPr>
           <a:xfrm>
-            <a:off x="6675120" y="5833872"/>
-            <a:ext cx="4937760" cy="457200"/>
+            <a:off x="6675120" y="5788152"/>
+            <a:ext cx="4937760" cy="548640"/>
           </a:xfrm>
           <a:prstGeom prst="rect">
             <a:avLst/>
@@ -3548,14 +3548,14 @@
               <a:buNone/>
             </a:pPr>
             <a:r>
-              <a:rPr lang="en-US" sz="1100" i="1" dirty="0">
+              <a:rPr lang="en-US" sz="1050" i="1" dirty="0">
                 <a:solidFill>
                   <a:schemeClr val="tx2"/>
                 </a:solidFill>
               </a:rPr>
-              <a:t>Evidencia de frecuencia (logs): 2024 tuvo 6 o más movilizaciones en 9 de 11 meses; 2025, en 4 de 9 meses, con meses de 1, 3 y 4.</a:t>
+              <a:t>Si los 20 pozos quedan a 5–10 km, la frontera sube a 6 (Petro Star) y 5 (Ecotransur) movilizaciones por mes. Logs: 2024 tuvo 6 o más en 9 de 11 meses; 2025, en 4 de 9.</a:t>
             </a:r>
-            <a:endParaRPr lang="en-US" sz="1100" dirty="0"/>
+            <a:endParaRPr lang="en-US" sz="1050" dirty="0"/>
           </a:p>
         </p:txBody>
       </p:sp>
@@ -5187,7 +5187,7 @@
                   <a:schemeClr val="tx1"/>
                 </a:solidFill>
               </a:rPr>
-              <a:t>Repetición de las campañas reales con cada modelo</a:t>
+              <a:t>Ilustración, no resultado: repetir 2024 y 2025 con cada modelo</a:t>
             </a:r>
             <a:endParaRPr lang="en-US" sz="1400" dirty="0"/>
           </a:p>
@@ -5238,7 +5238,7 @@
                           <a:ea typeface="Calibri" pitchFamily="34" charset="-122"/>
                           <a:cs typeface="Calibri" pitchFamily="34" charset="-120"/>
                         </a:rPr>
-                        <a:t>Ahorro vs WO (USD)</a:t>
+                        <a:t>+ = tercerizado más barato</a:t>
                       </a:r>
                       <a:endParaRPr lang="en-US" sz="1200" dirty="0">
                         <a:latin typeface="Calibri" charset="0"/>
@@ -6045,7 +6045,7 @@
                   <a:schemeClr val="tx2"/>
                 </a:solidFill>
               </a:rPr>
-              <a:t>2024: 70 movilizaciones, 6,4 por mes activo. 2025: 45, 5,0 por mes activo.</a:t>
+              <a:t>2024: 70 movilizaciones, 6,4 por mes con movilizaciones. 2025: 45, 5,0 por mes. Con el Truck Manager cobrado por mes (no prorrateado), el ahorro a 4–5 movs/mes es menor y la frontera no se mueve.</a:t>
             </a:r>
             <a:endParaRPr lang="en-US" sz="1200" dirty="0"/>
           </a:p>
@@ -6184,7 +6184,7 @@
                   <a:schemeClr val="tx1"/>
                 </a:solidFill>
               </a:rPr>
-              <a:t>Faltan siete datos y casi todos restan ventaja al tercerizado</a:t>
+              <a:t>Los pendientes que más pesan restan casi todos ventaja al tercerizado</a:t>
             </a:r>
             <a:endParaRPr lang="en-US" sz="2400" dirty="0"/>
           </a:p>
@@ -6214,9 +6214,9 @@
               <a:tblPr/>
               <a:tblGrid>
                 <a:gridCol w="3108960"/>
-                <a:gridCol w="1737360"/>
-                <a:gridCol w="1371600"/>
-                <a:gridCol w="1097280"/>
+                <a:gridCol w="1554480"/>
+                <a:gridCol w="1463040"/>
+                <a:gridCol w="1188720"/>
               </a:tblGrid>
               <a:tr h="384048">
                 <a:tc>
@@ -6228,7 +6228,7 @@
                         <a:buNone/>
                       </a:pPr>
                       <a:r>
-                        <a:rPr lang="en-US" sz="1200" b="1" dirty="0">
+                        <a:rPr lang="en-US" sz="1100" b="1" dirty="0">
                           <a:solidFill>
                             <a:srgbClr val="1F2A36"/>
                           </a:solidFill>
@@ -6238,7 +6238,7 @@
                         </a:rPr>
                         <a:t>Qué falta confirmar</a:t>
                       </a:r>
-                      <a:endParaRPr lang="en-US" sz="1200" dirty="0">
+                      <a:endParaRPr lang="en-US" sz="1100" dirty="0">
                         <a:latin typeface="Calibri" charset="0"/>
                         <a:ea typeface="Calibri" charset="0"/>
                         <a:cs typeface="Calibri" charset="0"/>
@@ -6293,7 +6293,7 @@
                         <a:buNone/>
                       </a:pPr>
                       <a:r>
-                        <a:rPr lang="en-US" sz="1200" b="1" dirty="0">
+                        <a:rPr lang="en-US" sz="1100" b="1" dirty="0">
                           <a:solidFill>
                             <a:srgbClr val="1F2A36"/>
                           </a:solidFill>
@@ -6303,7 +6303,7 @@
                         </a:rPr>
                         <a:t>Valor de trabajo</a:t>
                       </a:r>
-                      <a:endParaRPr lang="en-US" sz="1200" dirty="0">
+                      <a:endParaRPr lang="en-US" sz="1100" dirty="0">
                         <a:latin typeface="Calibri" charset="0"/>
                         <a:ea typeface="Calibri" charset="0"/>
                         <a:cs typeface="Calibri" charset="0"/>
@@ -6358,7 +6358,7 @@
                         <a:buNone/>
                       </a:pPr>
                       <a:r>
-                        <a:rPr lang="en-US" sz="1200" b="1" dirty="0">
+                        <a:rPr lang="en-US" sz="1100" b="1" dirty="0">
                           <a:solidFill>
                             <a:srgbClr val="1F2A36"/>
                           </a:solidFill>
@@ -6368,7 +6368,7 @@
                         </a:rPr>
                         <a:t>En juego (USD)</a:t>
                       </a:r>
-                      <a:endParaRPr lang="en-US" sz="1200" dirty="0">
+                      <a:endParaRPr lang="en-US" sz="1100" dirty="0">
                         <a:latin typeface="Calibri" charset="0"/>
                         <a:ea typeface="Calibri" charset="0"/>
                         <a:cs typeface="Calibri" charset="0"/>
@@ -6423,7 +6423,7 @@
                         <a:buNone/>
                       </a:pPr>
                       <a:r>
-                        <a:rPr lang="en-US" sz="1200" b="1" dirty="0">
+                        <a:rPr lang="en-US" sz="1100" b="1" dirty="0">
                           <a:solidFill>
                             <a:srgbClr val="1F2A36"/>
                           </a:solidFill>
@@ -6433,7 +6433,7 @@
                         </a:rPr>
                         <a:t>Quién</a:t>
                       </a:r>
-                      <a:endParaRPr lang="en-US" sz="1200" dirty="0">
+                      <a:endParaRPr lang="en-US" sz="1100" dirty="0">
                         <a:latin typeface="Calibri" charset="0"/>
                         <a:ea typeface="Calibri" charset="0"/>
                         <a:cs typeface="Calibri" charset="0"/>
@@ -6490,7 +6490,7 @@
                         <a:buNone/>
                       </a:pPr>
                       <a:r>
-                        <a:rPr lang="en-US" sz="1200" dirty="0">
+                        <a:rPr lang="en-US" sz="1100" dirty="0">
                           <a:solidFill>
                             <a:srgbClr val="1F2A36"/>
                           </a:solidFill>
@@ -6500,7 +6500,7 @@
                         </a:rPr>
                         <a:t>Rango real de los 20 pozos fuera de la locación</a:t>
                       </a:r>
-                      <a:endParaRPr lang="en-US" sz="1200" dirty="0">
+                      <a:endParaRPr lang="en-US" sz="1100" dirty="0">
                         <a:latin typeface="Calibri" charset="0"/>
                         <a:ea typeface="Calibri" charset="0"/>
                         <a:cs typeface="Calibri" charset="0"/>
@@ -6555,7 +6555,7 @@
                         <a:buNone/>
                       </a:pPr>
                       <a:r>
-                        <a:rPr lang="en-US" sz="1200" dirty="0">
+                        <a:rPr lang="en-US" sz="1100" dirty="0">
                           <a:solidFill>
                             <a:srgbClr val="1F2A36"/>
                           </a:solidFill>
@@ -6565,7 +6565,7 @@
                         </a:rPr>
                         <a:t>0,1–5 km</a:t>
                       </a:r>
-                      <a:endParaRPr lang="en-US" sz="1200" dirty="0">
+                      <a:endParaRPr lang="en-US" sz="1100" dirty="0">
                         <a:latin typeface="Calibri" charset="0"/>
                         <a:ea typeface="Calibri" charset="0"/>
                         <a:cs typeface="Calibri" charset="0"/>
@@ -6620,7 +6620,7 @@
                         <a:buNone/>
                       </a:pPr>
                       <a:r>
-                        <a:rPr lang="en-US" sz="1200" dirty="0">
+                        <a:rPr lang="en-US" sz="1100" dirty="0">
                           <a:solidFill>
                             <a:srgbClr val="B03A2E"/>
                           </a:solidFill>
@@ -6630,7 +6630,7 @@
                         </a:rPr>
                         <a:t>−0,18 M a −0,43 M</a:t>
                       </a:r>
-                      <a:endParaRPr lang="en-US" sz="1200" dirty="0">
+                      <a:endParaRPr lang="en-US" sz="1100" dirty="0">
                         <a:latin typeface="Calibri" charset="0"/>
                         <a:ea typeface="Calibri" charset="0"/>
                         <a:cs typeface="Calibri" charset="0"/>
@@ -6685,7 +6685,7 @@
                         <a:buNone/>
                       </a:pPr>
                       <a:r>
-                        <a:rPr lang="en-US" sz="1200" dirty="0">
+                        <a:rPr lang="en-US" sz="1100" dirty="0">
                           <a:solidFill>
                             <a:srgbClr val="1F2A36"/>
                           </a:solidFill>
@@ -6695,7 +6695,7 @@
                         </a:rPr>
                         <a:t>SierraCol</a:t>
                       </a:r>
-                      <a:endParaRPr lang="en-US" sz="1200" dirty="0">
+                      <a:endParaRPr lang="en-US" sz="1100" dirty="0">
                         <a:latin typeface="Calibri" charset="0"/>
                         <a:ea typeface="Calibri" charset="0"/>
                         <a:cs typeface="Calibri" charset="0"/>
@@ -6752,7 +6752,7 @@
                         <a:buNone/>
                       </a:pPr>
                       <a:r>
-                        <a:rPr lang="en-US" sz="1200" dirty="0">
+                        <a:rPr lang="en-US" sz="1100" dirty="0">
                           <a:solidFill>
                             <a:srgbClr val="1F2A36"/>
                           </a:solidFill>
@@ -6762,7 +6762,7 @@
                         </a:rPr>
                         <a:t>Horas de taladro por movilización (Excel vs Petro Star)</a:t>
                       </a:r>
-                      <a:endParaRPr lang="en-US" sz="1200" dirty="0">
+                      <a:endParaRPr lang="en-US" sz="1100" dirty="0">
                         <a:latin typeface="Calibri" charset="0"/>
                         <a:ea typeface="Calibri" charset="0"/>
                         <a:cs typeface="Calibri" charset="0"/>
@@ -6817,7 +6817,7 @@
                         <a:buNone/>
                       </a:pPr>
                       <a:r>
-                        <a:rPr lang="en-US" sz="1200" dirty="0">
+                        <a:rPr lang="en-US" sz="1100" dirty="0">
                           <a:solidFill>
                             <a:srgbClr val="1F2A36"/>
                           </a:solidFill>
@@ -6827,7 +6827,7 @@
                         </a:rPr>
                         <a:t>12/18/24/28 h</a:t>
                       </a:r>
-                      <a:endParaRPr lang="en-US" sz="1200" dirty="0">
+                      <a:endParaRPr lang="en-US" sz="1100" dirty="0">
                         <a:latin typeface="Calibri" charset="0"/>
                         <a:ea typeface="Calibri" charset="0"/>
                         <a:cs typeface="Calibri" charset="0"/>
@@ -6882,7 +6882,7 @@
                         <a:buNone/>
                       </a:pPr>
                       <a:r>
-                        <a:rPr lang="en-US" sz="1200" dirty="0">
+                        <a:rPr lang="en-US" sz="1100" dirty="0">
                           <a:solidFill>
                             <a:srgbClr val="B03A2E"/>
                           </a:solidFill>
@@ -6892,7 +6892,7 @@
                         </a:rPr>
                         <a:t>−0,17 M</a:t>
                       </a:r>
-                      <a:endParaRPr lang="en-US" sz="1200" dirty="0">
+                      <a:endParaRPr lang="en-US" sz="1100" dirty="0">
                         <a:latin typeface="Calibri" charset="0"/>
                         <a:ea typeface="Calibri" charset="0"/>
                         <a:cs typeface="Calibri" charset="0"/>
@@ -6947,7 +6947,7 @@
                         <a:buNone/>
                       </a:pPr>
                       <a:r>
-                        <a:rPr lang="en-US" sz="1200" dirty="0">
+                        <a:rPr lang="en-US" sz="1100" dirty="0">
                           <a:solidFill>
                             <a:srgbClr val="1F2A36"/>
                           </a:solidFill>
@@ -6957,7 +6957,7 @@
                         </a:rPr>
                         <a:t>SierraCol</a:t>
                       </a:r>
-                      <a:endParaRPr lang="en-US" sz="1200" dirty="0">
+                      <a:endParaRPr lang="en-US" sz="1100" dirty="0">
                         <a:latin typeface="Calibri" charset="0"/>
                         <a:ea typeface="Calibri" charset="0"/>
                         <a:cs typeface="Calibri" charset="0"/>
@@ -7014,7 +7014,7 @@
                         <a:buNone/>
                       </a:pPr>
                       <a:r>
-                        <a:rPr lang="en-US" sz="1200" dirty="0">
+                        <a:rPr lang="en-US" sz="1100" dirty="0">
                           <a:solidFill>
                             <a:srgbClr val="1F2A36"/>
                           </a:solidFill>
@@ -7024,7 +7024,7 @@
                         </a:rPr>
                         <a:t>¿Petro Star normal cobra aparte sus equipos adicionales?</a:t>
                       </a:r>
-                      <a:endParaRPr lang="en-US" sz="1200" dirty="0">
+                      <a:endParaRPr lang="en-US" sz="1100" dirty="0">
                         <a:latin typeface="Calibri" charset="0"/>
                         <a:ea typeface="Calibri" charset="0"/>
                         <a:cs typeface="Calibri" charset="0"/>
@@ -7079,7 +7079,7 @@
                         <a:buNone/>
                       </a:pPr>
                       <a:r>
-                        <a:rPr lang="en-US" sz="1200" dirty="0">
+                        <a:rPr lang="en-US" sz="1100" dirty="0">
                           <a:solidFill>
                             <a:srgbClr val="1F2A36"/>
                           </a:solidFill>
@@ -7089,7 +7089,7 @@
                         </a:rPr>
                         <a:t>No</a:t>
                       </a:r>
-                      <a:endParaRPr lang="en-US" sz="1200" dirty="0">
+                      <a:endParaRPr lang="en-US" sz="1100" dirty="0">
                         <a:latin typeface="Calibri" charset="0"/>
                         <a:ea typeface="Calibri" charset="0"/>
                         <a:cs typeface="Calibri" charset="0"/>
@@ -7144,7 +7144,7 @@
                         <a:buNone/>
                       </a:pPr>
                       <a:r>
-                        <a:rPr lang="en-US" sz="1200" dirty="0">
+                        <a:rPr lang="en-US" sz="1100" dirty="0">
                           <a:solidFill>
                             <a:srgbClr val="B03A2E"/>
                           </a:solidFill>
@@ -7154,7 +7154,7 @@
                         </a:rPr>
                         <a:t>−0,16 M</a:t>
                       </a:r>
-                      <a:endParaRPr lang="en-US" sz="1200" dirty="0">
+                      <a:endParaRPr lang="en-US" sz="1100" dirty="0">
                         <a:latin typeface="Calibri" charset="0"/>
                         <a:ea typeface="Calibri" charset="0"/>
                         <a:cs typeface="Calibri" charset="0"/>
@@ -7209,7 +7209,7 @@
                         <a:buNone/>
                       </a:pPr>
                       <a:r>
-                        <a:rPr lang="en-US" sz="1200" dirty="0">
+                        <a:rPr lang="en-US" sz="1100" dirty="0">
                           <a:solidFill>
                             <a:srgbClr val="1F2A36"/>
                           </a:solidFill>
@@ -7219,7 +7219,7 @@
                         </a:rPr>
                         <a:t>Petro Star</a:t>
                       </a:r>
-                      <a:endParaRPr lang="en-US" sz="1200" dirty="0">
+                      <a:endParaRPr lang="en-US" sz="1100" dirty="0">
                         <a:latin typeface="Calibri" charset="0"/>
                         <a:ea typeface="Calibri" charset="0"/>
                         <a:cs typeface="Calibri" charset="0"/>
@@ -7276,7 +7276,7 @@
                         <a:buNone/>
                       </a:pPr>
                       <a:r>
-                        <a:rPr lang="en-US" sz="1200" dirty="0">
+                        <a:rPr lang="en-US" sz="1100" dirty="0">
                           <a:solidFill>
                             <a:srgbClr val="1F2A36"/>
                           </a:solidFill>
@@ -7286,7 +7286,7 @@
                         </a:rPr>
                         <a:t>Cobro en un mes de campaña parada</a:t>
                       </a:r>
-                      <a:endParaRPr lang="en-US" sz="1200" dirty="0">
+                      <a:endParaRPr lang="en-US" sz="1100" dirty="0">
                         <a:latin typeface="Calibri" charset="0"/>
                         <a:ea typeface="Calibri" charset="0"/>
                         <a:cs typeface="Calibri" charset="0"/>
@@ -7341,7 +7341,7 @@
                         <a:buNone/>
                       </a:pPr>
                       <a:r>
-                        <a:rPr lang="en-US" sz="1200" dirty="0">
+                        <a:rPr lang="en-US" sz="1100" dirty="0">
                           <a:solidFill>
                             <a:srgbClr val="1F2A36"/>
                           </a:solidFill>
@@ -7351,7 +7351,7 @@
                         </a:rPr>
                         <a:t>No se cobra</a:t>
                       </a:r>
-                      <a:endParaRPr lang="en-US" sz="1200" dirty="0">
+                      <a:endParaRPr lang="en-US" sz="1100" dirty="0">
                         <a:latin typeface="Calibri" charset="0"/>
                         <a:ea typeface="Calibri" charset="0"/>
                         <a:cs typeface="Calibri" charset="0"/>
@@ -7406,7 +7406,7 @@
                         <a:buNone/>
                       </a:pPr>
                       <a:r>
-                        <a:rPr lang="en-US" sz="1200" dirty="0">
+                        <a:rPr lang="en-US" sz="1100" dirty="0">
                           <a:solidFill>
                             <a:srgbClr val="B03A2E"/>
                           </a:solidFill>
@@ -7414,9 +7414,9 @@
                           <a:ea typeface="Calibri" pitchFamily="34" charset="-122"/>
                           <a:cs typeface="Calibri" pitchFamily="34" charset="-120"/>
                         </a:rPr>
-                        <a:t>−0,16 M a −0,23 M c/mes</a:t>
+                        <a:t>−0,16 M a −0,23 M por mes</a:t>
                       </a:r>
-                      <a:endParaRPr lang="en-US" sz="1200" dirty="0">
+                      <a:endParaRPr lang="en-US" sz="1100" dirty="0">
                         <a:latin typeface="Calibri" charset="0"/>
                         <a:ea typeface="Calibri" charset="0"/>
                         <a:cs typeface="Calibri" charset="0"/>
@@ -7471,7 +7471,7 @@
                         <a:buNone/>
                       </a:pPr>
                       <a:r>
-                        <a:rPr lang="en-US" sz="1200" dirty="0">
+                        <a:rPr lang="en-US" sz="1100" dirty="0">
                           <a:solidFill>
                             <a:srgbClr val="1F2A36"/>
                           </a:solidFill>
@@ -7481,7 +7481,7 @@
                         </a:rPr>
                         <a:t>Contrato</a:t>
                       </a:r>
-                      <a:endParaRPr lang="en-US" sz="1200" dirty="0">
+                      <a:endParaRPr lang="en-US" sz="1100" dirty="0">
                         <a:latin typeface="Calibri" charset="0"/>
                         <a:ea typeface="Calibri" charset="0"/>
                         <a:cs typeface="Calibri" charset="0"/>
@@ -7538,7 +7538,7 @@
                         <a:buNone/>
                       </a:pPr>
                       <a:r>
-                        <a:rPr lang="en-US" sz="1200" dirty="0">
+                        <a:rPr lang="en-US" sz="1100" dirty="0">
                           <a:solidFill>
                             <a:srgbClr val="1F2A36"/>
                           </a:solidFill>
@@ -7546,9 +7546,9 @@
                           <a:ea typeface="Calibri" pitchFamily="34" charset="-122"/>
                           <a:cs typeface="Calibri" pitchFamily="34" charset="-120"/>
                         </a:rPr>
-                        <a:t>Demora no atribuible al transportador (cláusula 7)</a:t>
+                        <a:t>Demora no atribuible al transportador (cotización 1255, condición 7)</a:t>
                       </a:r>
-                      <a:endParaRPr lang="en-US" sz="1200" dirty="0">
+                      <a:endParaRPr lang="en-US" sz="1100" dirty="0">
                         <a:latin typeface="Calibri" charset="0"/>
                         <a:ea typeface="Calibri" charset="0"/>
                         <a:cs typeface="Calibri" charset="0"/>
@@ -7603,7 +7603,7 @@
                         <a:buNone/>
                       </a:pPr>
                       <a:r>
-                        <a:rPr lang="en-US" sz="1200" dirty="0">
+                        <a:rPr lang="en-US" sz="1100" dirty="0">
                           <a:solidFill>
                             <a:srgbClr val="1F2A36"/>
                           </a:solidFill>
@@ -7613,7 +7613,7 @@
                         </a:rPr>
                         <a:t>Sin demora</a:t>
                       </a:r>
-                      <a:endParaRPr lang="en-US" sz="1200" dirty="0">
+                      <a:endParaRPr lang="en-US" sz="1100" dirty="0">
                         <a:latin typeface="Calibri" charset="0"/>
                         <a:ea typeface="Calibri" charset="0"/>
                         <a:cs typeface="Calibri" charset="0"/>
@@ -7668,7 +7668,7 @@
                         <a:buNone/>
                       </a:pPr>
                       <a:r>
-                        <a:rPr lang="en-US" sz="1200" dirty="0">
+                        <a:rPr lang="en-US" sz="1100" dirty="0">
                           <a:solidFill>
                             <a:srgbClr val="B03A2E"/>
                           </a:solidFill>
@@ -7678,7 +7678,7 @@
                         </a:rPr>
                         <a:t>−2.813 por hora</a:t>
                       </a:r>
-                      <a:endParaRPr lang="en-US" sz="1200" dirty="0">
+                      <a:endParaRPr lang="en-US" sz="1100" dirty="0">
                         <a:latin typeface="Calibri" charset="0"/>
                         <a:ea typeface="Calibri" charset="0"/>
                         <a:cs typeface="Calibri" charset="0"/>
@@ -7733,7 +7733,7 @@
                         <a:buNone/>
                       </a:pPr>
                       <a:r>
-                        <a:rPr lang="en-US" sz="1200" dirty="0">
+                        <a:rPr lang="en-US" sz="1100" dirty="0">
                           <a:solidFill>
                             <a:srgbClr val="1F2A36"/>
                           </a:solidFill>
@@ -7743,7 +7743,7 @@
                         </a:rPr>
                         <a:t>Petro Star</a:t>
                       </a:r>
-                      <a:endParaRPr lang="en-US" sz="1200" dirty="0">
+                      <a:endParaRPr lang="en-US" sz="1100" dirty="0">
                         <a:latin typeface="Calibri" charset="0"/>
                         <a:ea typeface="Calibri" charset="0"/>
                         <a:cs typeface="Calibri" charset="0"/>
@@ -7800,7 +7800,7 @@
                         <a:buNone/>
                       </a:pPr>
                       <a:r>
-                        <a:rPr lang="en-US" sz="1200" dirty="0">
+                        <a:rPr lang="en-US" sz="1100" dirty="0">
                           <a:solidFill>
                             <a:srgbClr val="1F2A36"/>
                           </a:solidFill>
@@ -7808,9 +7808,9 @@
                           <a:ea typeface="Calibri" pitchFamily="34" charset="-122"/>
                           <a:cs typeface="Calibri" pitchFamily="34" charset="-120"/>
                         </a:rPr>
-                        <a:t>NPT de perforación (baja la frecuencia)</a:t>
+                        <a:t>Tiempo perdido en perforación (NPT) (baja la frecuencia)</a:t>
                       </a:r>
-                      <a:endParaRPr lang="en-US" sz="1200" dirty="0">
+                      <a:endParaRPr lang="en-US" sz="1100" dirty="0">
                         <a:latin typeface="Calibri" charset="0"/>
                         <a:ea typeface="Calibri" charset="0"/>
                         <a:cs typeface="Calibri" charset="0"/>
@@ -7865,7 +7865,7 @@
                         <a:buNone/>
                       </a:pPr>
                       <a:r>
-                        <a:rPr lang="en-US" sz="1200" dirty="0">
+                        <a:rPr lang="en-US" sz="1100" dirty="0">
                           <a:solidFill>
                             <a:srgbClr val="1F2A36"/>
                           </a:solidFill>
@@ -7875,7 +7875,7 @@
                         </a:rPr>
                         <a:t>0 %</a:t>
                       </a:r>
-                      <a:endParaRPr lang="en-US" sz="1200" dirty="0">
+                      <a:endParaRPr lang="en-US" sz="1100" dirty="0">
                         <a:latin typeface="Calibri" charset="0"/>
                         <a:ea typeface="Calibri" charset="0"/>
                         <a:cs typeface="Calibri" charset="0"/>
@@ -7930,7 +7930,7 @@
                         <a:buNone/>
                       </a:pPr>
                       <a:r>
-                        <a:rPr lang="en-US" sz="1200" dirty="0">
+                        <a:rPr lang="en-US" sz="1100" dirty="0">
                           <a:solidFill>
                             <a:srgbClr val="B03A2E"/>
                           </a:solidFill>
@@ -7940,7 +7940,7 @@
                         </a:rPr>
                         <a:t>−0,24 M con 20 %</a:t>
                       </a:r>
-                      <a:endParaRPr lang="en-US" sz="1200" dirty="0">
+                      <a:endParaRPr lang="en-US" sz="1100" dirty="0">
                         <a:latin typeface="Calibri" charset="0"/>
                         <a:ea typeface="Calibri" charset="0"/>
                         <a:cs typeface="Calibri" charset="0"/>
@@ -7995,7 +7995,7 @@
                         <a:buNone/>
                       </a:pPr>
                       <a:r>
-                        <a:rPr lang="en-US" sz="1200" dirty="0">
+                        <a:rPr lang="en-US" sz="1100" dirty="0">
                           <a:solidFill>
                             <a:srgbClr val="1F2A36"/>
                           </a:solidFill>
@@ -8005,7 +8005,7 @@
                         </a:rPr>
                         <a:t>SierraCol</a:t>
                       </a:r>
-                      <a:endParaRPr lang="en-US" sz="1200" dirty="0">
+                      <a:endParaRPr lang="en-US" sz="1100" dirty="0">
                         <a:latin typeface="Calibri" charset="0"/>
                         <a:ea typeface="Calibri" charset="0"/>
                         <a:cs typeface="Calibri" charset="0"/>
@@ -8062,7 +8062,7 @@
                         <a:buNone/>
                       </a:pPr>
                       <a:r>
-                        <a:rPr lang="en-US" sz="1200" dirty="0">
+                        <a:rPr lang="en-US" sz="1100" dirty="0">
                           <a:solidFill>
                             <a:srgbClr val="1F2A36"/>
                           </a:solidFill>
@@ -8070,9 +8070,9 @@
                           <a:ea typeface="Calibri" pitchFamily="34" charset="-122"/>
                           <a:cs typeface="Calibri" pitchFamily="34" charset="-120"/>
                         </a:rPr>
-                        <a:t>Lump Sum: valores del Excel vs Cot. 1255</a:t>
+                        <a:t>Lump Sum: valores del Excel vs cotización 1255</a:t>
                       </a:r>
-                      <a:endParaRPr lang="en-US" sz="1200" dirty="0">
+                      <a:endParaRPr lang="en-US" sz="1100" dirty="0">
                         <a:latin typeface="Calibri" charset="0"/>
                         <a:ea typeface="Calibri" charset="0"/>
                         <a:cs typeface="Calibri" charset="0"/>
@@ -8127,7 +8127,7 @@
                         <a:buNone/>
                       </a:pPr>
                       <a:r>
-                        <a:rPr lang="en-US" sz="1200" dirty="0">
+                        <a:rPr lang="en-US" sz="1100" dirty="0">
                           <a:solidFill>
                             <a:srgbClr val="1F2A36"/>
                           </a:solidFill>
@@ -8137,7 +8137,7 @@
                         </a:rPr>
                         <a:t>Excel</a:t>
                       </a:r>
-                      <a:endParaRPr lang="en-US" sz="1200" dirty="0">
+                      <a:endParaRPr lang="en-US" sz="1100" dirty="0">
                         <a:latin typeface="Calibri" charset="0"/>
                         <a:ea typeface="Calibri" charset="0"/>
                         <a:cs typeface="Calibri" charset="0"/>
@@ -8192,7 +8192,7 @@
                         <a:buNone/>
                       </a:pPr>
                       <a:r>
-                        <a:rPr lang="en-US" sz="1200" dirty="0">
+                        <a:rPr lang="en-US" sz="1100" dirty="0">
                           <a:solidFill>
                             <a:srgbClr val="2E7D5B"/>
                           </a:solidFill>
@@ -8202,7 +8202,7 @@
                         </a:rPr>
                         <a:t>+0,44 M</a:t>
                       </a:r>
-                      <a:endParaRPr lang="en-US" sz="1200" dirty="0">
+                      <a:endParaRPr lang="en-US" sz="1100" dirty="0">
                         <a:latin typeface="Calibri" charset="0"/>
                         <a:ea typeface="Calibri" charset="0"/>
                         <a:cs typeface="Calibri" charset="0"/>
@@ -8257,7 +8257,7 @@
                         <a:buNone/>
                       </a:pPr>
                       <a:r>
-                        <a:rPr lang="en-US" sz="1200" dirty="0">
+                        <a:rPr lang="en-US" sz="1100" dirty="0">
                           <a:solidFill>
                             <a:srgbClr val="1F2A36"/>
                           </a:solidFill>
@@ -8267,7 +8267,269 @@
                         </a:rPr>
                         <a:t>SCM</a:t>
                       </a:r>
-                      <a:endParaRPr lang="en-US" sz="1200" dirty="0">
+                      <a:endParaRPr lang="en-US" sz="1100" dirty="0">
+                        <a:latin typeface="Calibri" charset="0"/>
+                        <a:ea typeface="Calibri" charset="0"/>
+                        <a:cs typeface="Calibri" charset="0"/>
+                      </a:endParaRPr>
+                    </a:p>
+                  </a:txBody>
+                  <a:tcPr marL="91440" marR="91440" marT="45720" marB="45720" anchor="ctr">
+                    <a:lnL w="6350" cap="flat" cmpd="sng" algn="ctr">
+                      <a:solidFill>
+                        <a:srgbClr val="D5DBE1"/>
+                      </a:solidFill>
+                      <a:prstDash val="solid"/>
+                      <a:round/>
+                      <a:headEnd type="none" w="med" len="med"/>
+                      <a:tailEnd type="none" w="med" len="med"/>
+                    </a:lnL>
+                    <a:lnR w="6350" cap="flat" cmpd="sng" algn="ctr">
+                      <a:solidFill>
+                        <a:srgbClr val="D5DBE1"/>
+                      </a:solidFill>
+                      <a:prstDash val="solid"/>
+                      <a:round/>
+                      <a:headEnd type="none" w="med" len="med"/>
+                      <a:tailEnd type="none" w="med" len="med"/>
+                    </a:lnR>
+                    <a:lnT w="6350" cap="flat" cmpd="sng" algn="ctr">
+                      <a:solidFill>
+                        <a:srgbClr val="D5DBE1"/>
+                      </a:solidFill>
+                      <a:prstDash val="solid"/>
+                      <a:round/>
+                      <a:headEnd type="none" w="med" len="med"/>
+                      <a:tailEnd type="none" w="med" len="med"/>
+                    </a:lnT>
+                    <a:lnB w="6350" cap="flat" cmpd="sng" algn="ctr">
+                      <a:solidFill>
+                        <a:srgbClr val="D5DBE1"/>
+                      </a:solidFill>
+                      <a:prstDash val="solid"/>
+                      <a:round/>
+                      <a:headEnd type="none" w="med" len="med"/>
+                      <a:tailEnd type="none" w="med" len="med"/>
+                    </a:lnB>
+                  </a:tcPr>
+                </a:tc>
+              </a:tr>
+              <a:tr h="384048">
+                <a:tc>
+                  <a:txBody>
+                    <a:bodyPr/>
+                    <a:lstStyle/>
+                    <a:p>
+                      <a:pPr indent="0" marL="0">
+                        <a:buNone/>
+                      </a:pPr>
+                      <a:r>
+                        <a:rPr lang="en-US" sz="1100" dirty="0">
+                          <a:solidFill>
+                            <a:srgbClr val="1F2A36"/>
+                          </a:solidFill>
+                          <a:latin typeface="Calibri" pitchFamily="34" charset="0"/>
+                          <a:ea typeface="Calibri" pitchFamily="34" charset="-122"/>
+                          <a:cs typeface="Calibri" pitchFamily="34" charset="-120"/>
+                        </a:rPr>
+                        <a:t>Riesgos no cuantificados: coordinación taladro–transportador, HSE y daños, disponibilidad, plazo y salida, pago en COP</a:t>
+                      </a:r>
+                      <a:endParaRPr lang="en-US" sz="1100" dirty="0">
+                        <a:latin typeface="Calibri" charset="0"/>
+                        <a:ea typeface="Calibri" charset="0"/>
+                        <a:cs typeface="Calibri" charset="0"/>
+                      </a:endParaRPr>
+                    </a:p>
+                  </a:txBody>
+                  <a:tcPr marL="91440" marR="91440" marT="45720" marB="45720" anchor="ctr">
+                    <a:lnL w="6350" cap="flat" cmpd="sng" algn="ctr">
+                      <a:solidFill>
+                        <a:srgbClr val="D5DBE1"/>
+                      </a:solidFill>
+                      <a:prstDash val="solid"/>
+                      <a:round/>
+                      <a:headEnd type="none" w="med" len="med"/>
+                      <a:tailEnd type="none" w="med" len="med"/>
+                    </a:lnL>
+                    <a:lnR w="6350" cap="flat" cmpd="sng" algn="ctr">
+                      <a:solidFill>
+                        <a:srgbClr val="D5DBE1"/>
+                      </a:solidFill>
+                      <a:prstDash val="solid"/>
+                      <a:round/>
+                      <a:headEnd type="none" w="med" len="med"/>
+                      <a:tailEnd type="none" w="med" len="med"/>
+                    </a:lnR>
+                    <a:lnT w="6350" cap="flat" cmpd="sng" algn="ctr">
+                      <a:solidFill>
+                        <a:srgbClr val="D5DBE1"/>
+                      </a:solidFill>
+                      <a:prstDash val="solid"/>
+                      <a:round/>
+                      <a:headEnd type="none" w="med" len="med"/>
+                      <a:tailEnd type="none" w="med" len="med"/>
+                    </a:lnT>
+                    <a:lnB w="6350" cap="flat" cmpd="sng" algn="ctr">
+                      <a:solidFill>
+                        <a:srgbClr val="D5DBE1"/>
+                      </a:solidFill>
+                      <a:prstDash val="solid"/>
+                      <a:round/>
+                      <a:headEnd type="none" w="med" len="med"/>
+                      <a:tailEnd type="none" w="med" len="med"/>
+                    </a:lnB>
+                  </a:tcPr>
+                </a:tc>
+                <a:tc>
+                  <a:txBody>
+                    <a:bodyPr/>
+                    <a:lstStyle/>
+                    <a:p>
+                      <a:pPr indent="0" marL="0">
+                        <a:buNone/>
+                      </a:pPr>
+                      <a:r>
+                        <a:rPr lang="en-US" sz="1100" dirty="0">
+                          <a:solidFill>
+                            <a:srgbClr val="1F2A36"/>
+                          </a:solidFill>
+                          <a:latin typeface="Calibri" pitchFamily="34" charset="0"/>
+                          <a:ea typeface="Calibri" pitchFamily="34" charset="-122"/>
+                          <a:cs typeface="Calibri" pitchFamily="34" charset="-120"/>
+                        </a:rPr>
+                        <a:t>Sin valorar</a:t>
+                      </a:r>
+                      <a:endParaRPr lang="en-US" sz="1100" dirty="0">
+                        <a:latin typeface="Calibri" charset="0"/>
+                        <a:ea typeface="Calibri" charset="0"/>
+                        <a:cs typeface="Calibri" charset="0"/>
+                      </a:endParaRPr>
+                    </a:p>
+                  </a:txBody>
+                  <a:tcPr marL="91440" marR="91440" marT="45720" marB="45720" anchor="ctr">
+                    <a:lnL w="6350" cap="flat" cmpd="sng" algn="ctr">
+                      <a:solidFill>
+                        <a:srgbClr val="D5DBE1"/>
+                      </a:solidFill>
+                      <a:prstDash val="solid"/>
+                      <a:round/>
+                      <a:headEnd type="none" w="med" len="med"/>
+                      <a:tailEnd type="none" w="med" len="med"/>
+                    </a:lnL>
+                    <a:lnR w="6350" cap="flat" cmpd="sng" algn="ctr">
+                      <a:solidFill>
+                        <a:srgbClr val="D5DBE1"/>
+                      </a:solidFill>
+                      <a:prstDash val="solid"/>
+                      <a:round/>
+                      <a:headEnd type="none" w="med" len="med"/>
+                      <a:tailEnd type="none" w="med" len="med"/>
+                    </a:lnR>
+                    <a:lnT w="6350" cap="flat" cmpd="sng" algn="ctr">
+                      <a:solidFill>
+                        <a:srgbClr val="D5DBE1"/>
+                      </a:solidFill>
+                      <a:prstDash val="solid"/>
+                      <a:round/>
+                      <a:headEnd type="none" w="med" len="med"/>
+                      <a:tailEnd type="none" w="med" len="med"/>
+                    </a:lnT>
+                    <a:lnB w="6350" cap="flat" cmpd="sng" algn="ctr">
+                      <a:solidFill>
+                        <a:srgbClr val="D5DBE1"/>
+                      </a:solidFill>
+                      <a:prstDash val="solid"/>
+                      <a:round/>
+                      <a:headEnd type="none" w="med" len="med"/>
+                      <a:tailEnd type="none" w="med" len="med"/>
+                    </a:lnB>
+                  </a:tcPr>
+                </a:tc>
+                <a:tc>
+                  <a:txBody>
+                    <a:bodyPr/>
+                    <a:lstStyle/>
+                    <a:p>
+                      <a:pPr algn="r" indent="0" marL="0">
+                        <a:buNone/>
+                      </a:pPr>
+                      <a:r>
+                        <a:rPr lang="en-US" sz="1100" dirty="0">
+                          <a:solidFill>
+                            <a:srgbClr val="B03A2E"/>
+                          </a:solidFill>
+                          <a:latin typeface="Calibri" pitchFamily="34" charset="0"/>
+                          <a:ea typeface="Calibri" pitchFamily="34" charset="-122"/>
+                          <a:cs typeface="Calibri" pitchFamily="34" charset="-120"/>
+                        </a:rPr>
+                        <a:t>No cuantificado</a:t>
+                      </a:r>
+                      <a:endParaRPr lang="en-US" sz="1100" dirty="0">
+                        <a:latin typeface="Calibri" charset="0"/>
+                        <a:ea typeface="Calibri" charset="0"/>
+                        <a:cs typeface="Calibri" charset="0"/>
+                      </a:endParaRPr>
+                    </a:p>
+                  </a:txBody>
+                  <a:tcPr marL="91440" marR="91440" marT="45720" marB="45720" anchor="ctr">
+                    <a:lnL w="6350" cap="flat" cmpd="sng" algn="ctr">
+                      <a:solidFill>
+                        <a:srgbClr val="D5DBE1"/>
+                      </a:solidFill>
+                      <a:prstDash val="solid"/>
+                      <a:round/>
+                      <a:headEnd type="none" w="med" len="med"/>
+                      <a:tailEnd type="none" w="med" len="med"/>
+                    </a:lnL>
+                    <a:lnR w="6350" cap="flat" cmpd="sng" algn="ctr">
+                      <a:solidFill>
+                        <a:srgbClr val="D5DBE1"/>
+                      </a:solidFill>
+                      <a:prstDash val="solid"/>
+                      <a:round/>
+                      <a:headEnd type="none" w="med" len="med"/>
+                      <a:tailEnd type="none" w="med" len="med"/>
+                    </a:lnR>
+                    <a:lnT w="6350" cap="flat" cmpd="sng" algn="ctr">
+                      <a:solidFill>
+                        <a:srgbClr val="D5DBE1"/>
+                      </a:solidFill>
+                      <a:prstDash val="solid"/>
+                      <a:round/>
+                      <a:headEnd type="none" w="med" len="med"/>
+                      <a:tailEnd type="none" w="med" len="med"/>
+                    </a:lnT>
+                    <a:lnB w="6350" cap="flat" cmpd="sng" algn="ctr">
+                      <a:solidFill>
+                        <a:srgbClr val="D5DBE1"/>
+                      </a:solidFill>
+                      <a:prstDash val="solid"/>
+                      <a:round/>
+                      <a:headEnd type="none" w="med" len="med"/>
+                      <a:tailEnd type="none" w="med" len="med"/>
+                    </a:lnB>
+                  </a:tcPr>
+                </a:tc>
+                <a:tc>
+                  <a:txBody>
+                    <a:bodyPr/>
+                    <a:lstStyle/>
+                    <a:p>
+                      <a:pPr indent="0" marL="0">
+                        <a:buNone/>
+                      </a:pPr>
+                      <a:r>
+                        <a:rPr lang="en-US" sz="1100" dirty="0">
+                          <a:solidFill>
+                            <a:srgbClr val="1F2A36"/>
+                          </a:solidFill>
+                          <a:latin typeface="Calibri" pitchFamily="34" charset="0"/>
+                          <a:ea typeface="Calibri" pitchFamily="34" charset="-122"/>
+                          <a:cs typeface="Calibri" pitchFamily="34" charset="-120"/>
+                        </a:rPr>
+                        <a:t>Contratos / HSE</a:t>
+                      </a:r>
+                      <a:endParaRPr lang="en-US" sz="1100" dirty="0">
                         <a:latin typeface="Calibri" charset="0"/>
                         <a:ea typeface="Calibri" charset="0"/>
                         <a:cs typeface="Calibri" charset="0"/>
@@ -8327,7 +8589,7 @@
         <p:spPr>
           <a:xfrm>
             <a:off x="8229600" y="1280160"/>
-            <a:ext cx="3383280" cy="4206240"/>
+            <a:ext cx="3383280" cy="3749040"/>
           </a:xfrm>
           <a:prstGeom prst="roundRect">
             <a:avLst>
@@ -8354,7 +8616,7 @@
         <p:spPr>
           <a:xfrm>
             <a:off x="8412480" y="1463040"/>
-            <a:ext cx="3017520" cy="3931920"/>
+            <a:ext cx="3017520" cy="3474720"/>
           </a:xfrm>
           <a:prstGeom prst="rect">
             <a:avLst/>
@@ -8392,7 +8654,7 @@
                   <a:schemeClr val="bg1"/>
                 </a:solidFill>
               </a:rPr>
-              <a:t>Sesgo sistemático: casi todos los supuestos de la evaluación previa y de este caso base empujan hacia el tercerizado. Con la frecuencia y la mezcla de 2025 y las horas que cotizó Petro Star, el ahorro desaparece: Petro Star −0,02 M y Ecotransur −0,01 M. Antes de cambiar el contrato: confirmar la frecuencia mensual esperada, el rango real de los pozos y las horas que se pagarán al taladro.</a:t>
+              <a:t>Sesgo sistemático: casi todos los supuestos empujan hacia el tercerizado; las excepciones son los precios del Lump Sum (+0,44 M) y el cargo fijo de Petro Star con 5 movilizaciones (+0,08 M). Con la frecuencia y la mezcla de 2025 y las horas que cotizó Petro Star, el ahorro desaparece (Petro Star −0,02 M; Ecotransur −0,01 M). Antes de cambiar el contrato: confirmar la frecuencia mensual esperada, el rango real de los pozos y la exposición a la tasa de cambio (TRM ±10 % mueve ±0,3 M).</a:t>
             </a:r>
             <a:endParaRPr lang="en-US" sz="1600" dirty="0"/>
           </a:p>

</xml_diff>

<commit_message>
Movilización: base 5–6 movs/mes, overtime-hour equipment charges, blocked months, WO bonus parameter, per-well metrics, break-even table, line-by-line Excel verification
Co-Authored-By: Claude Opus 5.5 <noreply@anthropic.com>
Claude-Session: https://claude.ai/code/session_01BsMRKE8hArHddZxwmwcNWn
</commit_message>
<xml_diff>
--- a/movilizacion/entregables/Presentacion_Movilizacion_GRS110.pptx
+++ b/movilizacion/entregables/Presentacion_Movilizacion_GRS110.pptx
@@ -110,22 +110,22 @@
   <p:extLst>
     <p:ext uri="{521415D9-36F7-43E2-AB2F-B90AF26B5E84}">
       <p14:sectionLst xmlns:p14="http://schemas.microsoft.com/office/powerpoint/2010/main">
-        <p14:section name="Decisión" id="{8014238a-a8d5-17b7-3deb-f345993eb452}">
+        <p14:section name="Decisión" id="{c1eafc6c-2fbe-c2c4-0f8e-7e4542a9f3ba}">
           <p14:sldIdLst>
             <p14:sldId id="256"/>
           </p14:sldIdLst>
         </p14:section>
-        <p14:section name="Estructura de costo" id="{998674bb-10da-3a6e-4ada-0031c4b08f8e}">
+        <p14:section name="Estructura de costo" id="{57cd9278-a18e-e4e5-3109-afe9e591052c}">
           <p14:sldIdLst>
             <p14:sldId id="257"/>
           </p14:sldIdLst>
         </p14:section>
-        <p14:section name="Frontera" id="{91978678-3ee4-8da8-8f6e-9f89ccc6dbfc}">
+        <p14:section name="Frontera" id="{d9ba0ae3-c6c2-b0ce-a96a-cd6a38fa17c7}">
           <p14:sldIdLst>
             <p14:sldId id="258"/>
           </p14:sldIdLst>
         </p14:section>
-        <p14:section name="Pendientes" id="{16a1ba24-25a4-8969-1abb-648b7a4ad8b8}">
+        <p14:section name="Pendientes" id="{1ff4f43f-eb30-3710-c101-2463e05d3c19}">
           <p14:sldIdLst>
             <p14:sldId id="259"/>
           </p14:sldIdLst>
@@ -1148,7 +1148,7 @@
                 </a:solidFill>
                 <a:latin typeface="+mn-lt"/>
               </a:rPr>
-              <a:t>Ahorro de la campaña 15 + 20 pozos frente al Work Order, según movilizaciones por mes (USD)</a:t>
+              <a:t>Ahorro de la campaña 15 + 20 pozos frente al Work Order (USD; + = tercerizado más barato)</a:t>
             </a:r>
           </a:p>
         </c:rich>
@@ -1232,36 +1232,33 @@
           </c:marker>
           <c:cat>
             <c:multiLvlStrRef>
-              <c:f>Sheet1!$A$2:$A$10</c:f>
+              <c:f>Sheet1!$A$2:$A$9</c:f>
               <c:multiLvlStrCache>
-                <c:ptCount val="9"/>
+                <c:ptCount val="8"/>
                 <c:lvl>
                   <c:pt idx="0">
-                    <c:v>2</c:v>
+                    <c:v>4</c:v>
                   </c:pt>
                   <c:pt idx="1">
-                    <c:v>3</c:v>
+                    <c:v>4,5</c:v>
                   </c:pt>
                   <c:pt idx="2">
-                    <c:v>4</c:v>
+                    <c:v>5</c:v>
                   </c:pt>
                   <c:pt idx="3">
-                    <c:v>5</c:v>
+                    <c:v>5,5</c:v>
                   </c:pt>
                   <c:pt idx="4">
                     <c:v>6</c:v>
                   </c:pt>
                   <c:pt idx="5">
+                    <c:v>6,5</c:v>
+                  </c:pt>
+                  <c:pt idx="6">
                     <c:v>7</c:v>
                   </c:pt>
-                  <c:pt idx="6">
+                  <c:pt idx="7">
                     <c:v>8</c:v>
-                  </c:pt>
-                  <c:pt idx="7">
-                    <c:v>9</c:v>
-                  </c:pt>
-                  <c:pt idx="8">
-                    <c:v>10</c:v>
                   </c:pt>
                 </c:lvl>
               </c:multiLvlStrCache>
@@ -1269,36 +1266,33 @@
           </c:cat>
           <c:val>
             <c:numRef>
-              <c:f>Sheet1!$B$2:$B$10</c:f>
+              <c:f>Sheet1!$B$2:$B$9</c:f>
               <c:numCache>
                 <c:formatCode>General</c:formatCode>
-                <c:ptCount val="9"/>
+                <c:ptCount val="8"/>
                 <c:pt idx="0">
-                  <c:v>-1264695</c:v>
+                  <c:v>-35057.83378378302</c:v>
                 </c:pt>
                 <c:pt idx="1">
-                  <c:v>-376051</c:v>
+                  <c:v>81238.02756756824</c:v>
                 </c:pt>
                 <c:pt idx="2">
-                  <c:v>-35058</c:v>
+                  <c:v>199754.31567567633</c:v>
                 </c:pt>
                 <c:pt idx="3">
-                  <c:v>199754</c:v>
+                  <c:v>347086.30716216285</c:v>
                 </c:pt>
                 <c:pt idx="4">
-                  <c:v>572947</c:v>
+                  <c:v>572946.5894594598</c:v>
                 </c:pt>
                 <c:pt idx="5">
-                  <c:v>730502</c:v>
+                  <c:v>592957.5331081082</c:v>
                 </c:pt>
                 <c:pt idx="6">
-                  <c:v>731309</c:v>
+                  <c:v>730502.1668918924</c:v>
                 </c:pt>
                 <c:pt idx="7">
-                  <c:v>868853</c:v>
-                </c:pt>
-                <c:pt idx="8">
-                  <c:v>827901</c:v>
+                  <c:v>731308.5840540547</c:v>
                 </c:pt>
               </c:numCache>
             </c:numRef>
@@ -1376,36 +1370,33 @@
           </c:marker>
           <c:cat>
             <c:multiLvlStrRef>
-              <c:f>Sheet1!$A$2:$A$10</c:f>
+              <c:f>Sheet1!$A$2:$A$9</c:f>
               <c:multiLvlStrCache>
-                <c:ptCount val="9"/>
+                <c:ptCount val="8"/>
                 <c:lvl>
                   <c:pt idx="0">
-                    <c:v>2</c:v>
+                    <c:v>4</c:v>
                   </c:pt>
                   <c:pt idx="1">
-                    <c:v>3</c:v>
+                    <c:v>4,5</c:v>
                   </c:pt>
                   <c:pt idx="2">
-                    <c:v>4</c:v>
+                    <c:v>5</c:v>
                   </c:pt>
                   <c:pt idx="3">
-                    <c:v>5</c:v>
+                    <c:v>5,5</c:v>
                   </c:pt>
                   <c:pt idx="4">
                     <c:v>6</c:v>
                   </c:pt>
                   <c:pt idx="5">
+                    <c:v>6,5</c:v>
+                  </c:pt>
+                  <c:pt idx="6">
                     <c:v>7</c:v>
                   </c:pt>
-                  <c:pt idx="6">
+                  <c:pt idx="7">
                     <c:v>8</c:v>
-                  </c:pt>
-                  <c:pt idx="7">
-                    <c:v>9</c:v>
-                  </c:pt>
-                  <c:pt idx="8">
-                    <c:v>10</c:v>
                   </c:pt>
                 </c:lvl>
               </c:multiLvlStrCache>
@@ -1413,36 +1404,33 @@
           </c:cat>
           <c:val>
             <c:numRef>
-              <c:f>Sheet1!$C$2:$C$10</c:f>
+              <c:f>Sheet1!$C$2:$C$9</c:f>
               <c:numCache>
                 <c:formatCode>General</c:formatCode>
-                <c:ptCount val="9"/>
+                <c:ptCount val="8"/>
                 <c:pt idx="0">
-                  <c:v>-1931371</c:v>
+                  <c:v>105486.55675675627</c:v>
                 </c:pt>
                 <c:pt idx="1">
-                  <c:v>-573466</c:v>
+                  <c:v>331804.0797297298</c:v>
                 </c:pt>
                 <c:pt idx="2">
-                  <c:v>105487</c:v>
+                  <c:v>558121.6027027033</c:v>
                 </c:pt>
                 <c:pt idx="3">
-                  <c:v>558122</c:v>
+                  <c:v>472628.1175675681</c:v>
                 </c:pt>
                 <c:pt idx="4">
-                  <c:v>635872</c:v>
+                  <c:v>635871.6054054066</c:v>
                 </c:pt>
                 <c:pt idx="5">
-                  <c:v>695386</c:v>
+                  <c:v>572797.5702702715</c:v>
                 </c:pt>
                 <c:pt idx="6">
-                  <c:v>668783</c:v>
+                  <c:v>695386.4729729742</c:v>
                 </c:pt>
                 <c:pt idx="7">
-                  <c:v>791372</c:v>
-                </c:pt>
-                <c:pt idx="8">
-                  <c:v>791372</c:v>
+                  <c:v>668782.7081081085</c:v>
                 </c:pt>
               </c:numCache>
             </c:numRef>
@@ -1520,36 +1508,33 @@
           </c:marker>
           <c:cat>
             <c:multiLvlStrRef>
-              <c:f>Sheet1!$A$2:$A$10</c:f>
+              <c:f>Sheet1!$A$2:$A$9</c:f>
               <c:multiLvlStrCache>
-                <c:ptCount val="9"/>
+                <c:ptCount val="8"/>
                 <c:lvl>
                   <c:pt idx="0">
-                    <c:v>2</c:v>
+                    <c:v>4</c:v>
                   </c:pt>
                   <c:pt idx="1">
-                    <c:v>3</c:v>
+                    <c:v>4,5</c:v>
                   </c:pt>
                   <c:pt idx="2">
-                    <c:v>4</c:v>
+                    <c:v>5</c:v>
                   </c:pt>
                   <c:pt idx="3">
-                    <c:v>5</c:v>
+                    <c:v>5,5</c:v>
                   </c:pt>
                   <c:pt idx="4">
                     <c:v>6</c:v>
                   </c:pt>
                   <c:pt idx="5">
+                    <c:v>6,5</c:v>
+                  </c:pt>
+                  <c:pt idx="6">
                     <c:v>7</c:v>
                   </c:pt>
-                  <c:pt idx="6">
+                  <c:pt idx="7">
                     <c:v>8</c:v>
-                  </c:pt>
-                  <c:pt idx="7">
-                    <c:v>9</c:v>
-                  </c:pt>
-                  <c:pt idx="8">
-                    <c:v>10</c:v>
                   </c:pt>
                 </c:lvl>
               </c:multiLvlStrCache>
@@ -1557,36 +1542,33 @@
           </c:cat>
           <c:val>
             <c:numRef>
-              <c:f>Sheet1!$D$2:$D$10</c:f>
+              <c:f>Sheet1!$D$2:$D$9</c:f>
               <c:numCache>
                 <c:formatCode>General</c:formatCode>
-                <c:ptCount val="9"/>
+                <c:ptCount val="8"/>
                 <c:pt idx="0">
-                  <c:v>-1869644</c:v>
+                  <c:v>-640006.1527027027</c:v>
                 </c:pt>
                 <c:pt idx="1">
-                  <c:v>-980999</c:v>
+                  <c:v>-523710.2913513514</c:v>
                 </c:pt>
                 <c:pt idx="2">
-                  <c:v>-640006</c:v>
+                  <c:v>-405194.0032432433</c:v>
                 </c:pt>
                 <c:pt idx="3">
-                  <c:v>-405194</c:v>
+                  <c:v>-336523.04000000004</c:v>
                 </c:pt>
                 <c:pt idx="4">
-                  <c:v>-159479</c:v>
+                  <c:v>-159478.77459459472</c:v>
                 </c:pt>
                 <c:pt idx="5">
-                  <c:v>-118526</c:v>
+                  <c:v>-188283.84783783788</c:v>
                 </c:pt>
                 <c:pt idx="6">
-                  <c:v>-188284</c:v>
+                  <c:v>-118526.23648648662</c:v>
                 </c:pt>
                 <c:pt idx="7">
-                  <c:v>-118526</c:v>
-                </c:pt>
-                <c:pt idx="8">
-                  <c:v>-159479</c:v>
+                  <c:v>-188283.84783783788</c:v>
                 </c:pt>
               </c:numCache>
             </c:numRef>
@@ -1650,7 +1632,7 @@
                     </a:solidFill>
                     <a:latin typeface="Arial"/>
                   </a:rPr>
-                  <a:t>Movilizaciones por mes (constante)</a:t>
+                  <a:t>Movilizaciones por mes (esperado: 5 a 6)</a:t>
                 </a:r>
               </a:p>
             </c:rich>
@@ -2357,7 +2339,7 @@
           <a:p>
             <a:r>
               <a:rPr lang="en-US" dirty="0"/>
-              <a:t>Gráfico: frecuencia constante; con 1 movilización por mes las pérdidas son de −4,2 a −5,8 M (fuera de escala). Los dientes (p. ej. de 9 a 10) vienen del último mes de la campaña, que queda por debajo de 6 y vuelve a pagar cargo fijo. Tabla: hojas Real 2024 / Real 2025 del simulador, horas del Excel.</a:t>
+              <a:t>Gráfico: hoja Sensibilidad, sección 1 (horas del Excel). Los dientes vienen del último mes de la campaña, que queda corto y vuelve a pagar cargo fijo. Tabla: hoja Sensibilidad, sección 3, y hojas Real 2024 / Real 2025.</a:t>
             </a:r>
             <a:endParaRPr lang="en-US" dirty="0"/>
           </a:p>
@@ -2445,7 +2427,7 @@
           <a:p>
             <a:r>
               <a:rPr lang="en-US" dirty="0"/>
-              <a:t>Detalle completo con valor de trabajo, alternativa y monto en juego por perfil de frecuencia: hoja Pendientes del simulador. Auditoría de la evaluación previa: archivo Auditoria_Evaluacion_Previa.xlsx.</a:t>
+              <a:t>Puntos de quiebre: hoja Sensibilidad, sección 2. Pendientes completos con montos: hoja Pendientes. Auditoría de la evaluación previa: Auditoria_Evaluacion_Previa.xlsx.</a:t>
             </a:r>
             <a:endParaRPr lang="en-US" dirty="0"/>
           </a:p>
@@ -3041,7 +3023,7 @@
                   <a:schemeClr val="tx1"/>
                 </a:solidFill>
               </a:rPr>
-              <a:t>Tercerizar solo conviene si la frecuencia se sostiene todos los meses</a:t>
+              <a:t>Tercerizar ahorra poco y solo si se sostienen 5–6 movilizaciones y los tiempos</a:t>
             </a:r>
             <a:endParaRPr lang="en-US" sz="2400" dirty="0"/>
           </a:p>
@@ -3227,7 +3209,7 @@
               <a:buNone/>
             </a:pPr>
             <a:r>
-              <a:rPr lang="en-US" sz="4000" b="1" dirty="0">
+              <a:rPr lang="en-US" sz="2600" b="1" dirty="0">
                 <a:solidFill>
                   <a:schemeClr val="accent4"/>
                 </a:solidFill>
@@ -3235,9 +3217,9 @@
                 <a:ea typeface="Cambria" pitchFamily="34" charset="-122"/>
                 <a:cs typeface="Cambria" pitchFamily="34" charset="-120"/>
               </a:rPr>
-              <a:t>≥ 5</a:t>
+              <a:t>1–3 %</a:t>
             </a:r>
-            <a:endParaRPr lang="en-US" sz="4000" dirty="0"/>
+            <a:endParaRPr lang="en-US" sz="2600" dirty="0"/>
           </a:p>
         </p:txBody>
       </p:sp>
@@ -3271,7 +3253,7 @@
                   <a:schemeClr val="tx1"/>
                 </a:solidFill>
               </a:rPr>
-              <a:t>movilizaciones todos los meses</a:t>
+              <a:t>del costo de cada pozo</a:t>
             </a:r>
             <a:endParaRPr lang="en-US" sz="1400" dirty="0"/>
           </a:p>
@@ -3285,7 +3267,7 @@
                   <a:schemeClr val="tx2"/>
                 </a:solidFill>
               </a:rPr>
-              <a:t>Petro Star tarifa normal deja de perder frente al Work Order (campaña 15 + 20 pozos en 0,1–5 km)</a:t>
+              <a:t>Ahorro por pozo con 5–6 movs/mes: Petro Star normal 6–16 k USD, Ecotransur 16–18 k USD (pozo de 500–600 k)</a:t>
             </a:r>
             <a:endParaRPr lang="en-US" sz="1400" dirty="0"/>
           </a:p>
@@ -3343,17 +3325,17 @@
               <a:buNone/>
             </a:pPr>
             <a:r>
-              <a:rPr lang="en-US" sz="4000" b="1" dirty="0">
+              <a:rPr lang="en-US" sz="3600" b="1" dirty="0">
                 <a:solidFill>
-                  <a:schemeClr val="accent4"/>
+                  <a:schemeClr val="accent5"/>
                 </a:solidFill>
                 <a:latin typeface="Cambria" pitchFamily="34" charset="0"/>
                 <a:ea typeface="Cambria" pitchFamily="34" charset="-122"/>
                 <a:cs typeface="Cambria" pitchFamily="34" charset="-120"/>
               </a:rPr>
-              <a:t>≥ 4</a:t>
+              <a:t>2 h</a:t>
             </a:r>
-            <a:endParaRPr lang="en-US" sz="4000" dirty="0"/>
+            <a:endParaRPr lang="en-US" sz="3600" dirty="0"/>
           </a:p>
         </p:txBody>
       </p:sp>
@@ -3387,7 +3369,7 @@
                   <a:schemeClr val="tx1"/>
                 </a:solidFill>
               </a:rPr>
-              <a:t>movilizaciones todos los meses</a:t>
+              <a:t>de más por movilización</a:t>
             </a:r>
             <a:endParaRPr lang="en-US" sz="1400" dirty="0"/>
           </a:p>
@@ -3401,7 +3383,7 @@
                   <a:schemeClr val="tx2"/>
                 </a:solidFill>
               </a:rPr>
-              <a:t>Ecotransur deja de perder frente al Work Order (misma campaña)</a:t>
+              <a:t>sobre el tiempo cotizado borran el ahorro de Petro Star con 5 movs/mes; con 6, unas 6 h (taladro + equipos)</a:t>
             </a:r>
             <a:endParaRPr lang="en-US" sz="1400" dirty="0"/>
           </a:p>
@@ -3553,7 +3535,7 @@
                   <a:schemeClr val="tx2"/>
                 </a:solidFill>
               </a:rPr>
-              <a:t>Si los 20 pozos quedan a 5–10 km, la frontera sube a 6 (Petro Star) y 5 (Ecotransur) movilizaciones por mes. Logs: 2024 tuvo 6 o más en 9 de 11 meses; 2025, en 4 de 9.</a:t>
+              <a:t>Campaña 15 + 20 pozos (0,1–5 km), frecuencia esperada 5–6 movs/mes, TRM 3.700. Con 4 movs/mes Petro Star ya pierde. Logs: 2024 tuvo 6 o más en 9 de 11 meses; 2025, en 4 de 9.</a:t>
             </a:r>
             <a:endParaRPr lang="en-US" sz="1050" dirty="0"/>
           </a:p>
@@ -5108,7 +5090,7 @@
                   <a:schemeClr val="tx1"/>
                 </a:solidFill>
               </a:rPr>
-              <a:t>La frontera está entre 4 y 5 movilizaciones por mes, sostenidas</a:t>
+              <a:t>Entre 5 y 6 movilizaciones por mes está el escalón que más pesa</a:t>
             </a:r>
             <a:endParaRPr lang="en-US" sz="2400" dirty="0"/>
           </a:p>
@@ -5187,7 +5169,7 @@
                   <a:schemeClr val="tx1"/>
                 </a:solidFill>
               </a:rPr>
-              <a:t>Ilustración, no resultado: repetir 2024 y 2025 con cada modelo</a:t>
+              <a:t>Ilustración, no resultado: 2024 y 2025 repetidas con horas reales</a:t>
             </a:r>
             <a:endParaRPr lang="en-US" sz="1400" dirty="0"/>
           </a:p>
@@ -5500,7 +5482,7 @@
                           <a:ea typeface="Calibri" pitchFamily="34" charset="-122"/>
                           <a:cs typeface="Calibri" pitchFamily="34" charset="-120"/>
                         </a:rPr>
-                        <a:t>+1,03 M</a:t>
+                        <a:t>+1,13 M</a:t>
                       </a:r>
                       <a:endParaRPr lang="en-US" sz="1200" dirty="0">
                         <a:latin typeface="Calibri" charset="0"/>
@@ -5559,13 +5541,13 @@
                       <a:r>
                         <a:rPr lang="en-US" sz="1200" dirty="0">
                           <a:solidFill>
-                            <a:srgbClr val="2E7D5B"/>
+                            <a:srgbClr val="B03A2E"/>
                           </a:solidFill>
                           <a:latin typeface="Calibri" pitchFamily="34" charset="0"/>
                           <a:ea typeface="Calibri" pitchFamily="34" charset="-122"/>
                           <a:cs typeface="Calibri" pitchFamily="34" charset="-120"/>
                         </a:rPr>
-                        <a:t>+0,19 M</a:t>
+                        <a:t>−0,05 M</a:t>
                       </a:r>
                       <a:endParaRPr lang="en-US" sz="1200" dirty="0">
                         <a:latin typeface="Calibri" charset="0"/>
@@ -5697,7 +5679,7 @@
                           <a:ea typeface="Calibri" pitchFamily="34" charset="-122"/>
                           <a:cs typeface="Calibri" pitchFamily="34" charset="-120"/>
                         </a:rPr>
-                        <a:t>+0,90 M</a:t>
+                        <a:t>+0,99 M</a:t>
                       </a:r>
                       <a:endParaRPr lang="en-US" sz="1200" dirty="0">
                         <a:latin typeface="Calibri" charset="0"/>
@@ -5756,13 +5738,13 @@
                       <a:r>
                         <a:rPr lang="en-US" sz="1200" dirty="0">
                           <a:solidFill>
-                            <a:srgbClr val="2E7D5B"/>
+                            <a:srgbClr val="B03A2E"/>
                           </a:solidFill>
                           <a:latin typeface="Calibri" pitchFamily="34" charset="0"/>
                           <a:ea typeface="Calibri" pitchFamily="34" charset="-122"/>
                           <a:cs typeface="Calibri" pitchFamily="34" charset="-120"/>
                         </a:rPr>
-                        <a:t>+0,18 M</a:t>
+                        <a:t>−0,05 M</a:t>
                       </a:r>
                       <a:endParaRPr lang="en-US" sz="1200" dirty="0">
                         <a:latin typeface="Calibri" charset="0"/>
@@ -5894,7 +5876,7 @@
                           <a:ea typeface="Calibri" pitchFamily="34" charset="-122"/>
                           <a:cs typeface="Calibri" pitchFamily="34" charset="-120"/>
                         </a:rPr>
-                        <a:t>−1,07 M</a:t>
+                        <a:t>−0,98 M</a:t>
                       </a:r>
                       <a:endParaRPr lang="en-US" sz="1200" dirty="0">
                         <a:latin typeface="Calibri" charset="0"/>
@@ -5959,7 +5941,7 @@
                           <a:ea typeface="Calibri" pitchFamily="34" charset="-122"/>
                           <a:cs typeface="Calibri" pitchFamily="34" charset="-120"/>
                         </a:rPr>
-                        <a:t>−1,19 M</a:t>
+                        <a:t>−1,42 M</a:t>
                       </a:r>
                       <a:endParaRPr lang="en-US" sz="1200" dirty="0">
                         <a:latin typeface="Calibri" charset="0"/>
@@ -6045,7 +6027,7 @@
                   <a:schemeClr val="tx2"/>
                 </a:solidFill>
               </a:rPr>
-              <a:t>2024: 70 movilizaciones, 6,4 por mes con movilizaciones. 2025: 45, 5,0 por mes. Con el Truck Manager cobrado por mes (no prorrateado), el ahorro a 4–5 movs/mes es menor y la frontera no se mueve.</a:t>
+              <a:t>Taladro por horas reales y equipos por cada hora sobre el tiempo cotizado.</a:t>
             </a:r>
             <a:endParaRPr lang="en-US" sz="1200" dirty="0"/>
           </a:p>
@@ -6062,7 +6044,7 @@
                   <a:schemeClr val="tx1"/>
                 </a:solidFill>
               </a:rPr>
-              <a:t>En 2025 los meses de 1, 3 y 4 movilizaciones se comieron casi todo lo que ganaron los meses de 6 y 7.</a:t>
+              <a:t>2025: 15 movilizaciones se pasaron del tiempo (94 h). Con eso el tercerizado habría costado más que el Work Order.</a:t>
             </a:r>
             <a:endParaRPr lang="en-US" sz="1200" dirty="0"/>
           </a:p>
@@ -6071,12 +6053,12 @@
               <a:buNone/>
             </a:pPr>
             <a:r>
-              <a:rPr lang="en-US" sz="1200" b="1" dirty="0">
+              <a:rPr lang="en-US" sz="1200" dirty="0">
                 <a:solidFill>
-                  <a:schemeClr val="accent5"/>
+                  <a:schemeClr val="tx2"/>
                 </a:solidFill>
               </a:rPr>
-              <a:t>Escenario prudente (frecuencia y mezcla de 2025, horas cotizadas por Petro Star): Petro Star −0,02 M y Ecotransur −0,01 M. Es el punto de equilibrio.</a:t>
+              <a:t>2024 se movió más rápido que lo supuesto en el Excel y el ahorro se mantiene, aun con 10 excesos (66 h).</a:t>
             </a:r>
             <a:endParaRPr lang="en-US" sz="1200" dirty="0"/>
           </a:p>
@@ -6184,7 +6166,7 @@
                   <a:schemeClr val="tx1"/>
                 </a:solidFill>
               </a:rPr>
-              <a:t>Los pendientes que más pesan restan casi todos ventaja al tercerizado</a:t>
+              <a:t>El margen se pierde con pocas horas de más o un mes sin mover</a:t>
             </a:r>
             <a:endParaRPr lang="en-US" sz="2400" dirty="0"/>
           </a:p>
@@ -6213,10 +6195,11 @@
             <a:tbl>
               <a:tblPr/>
               <a:tblGrid>
-                <a:gridCol w="3108960"/>
-                <a:gridCol w="1554480"/>
-                <a:gridCol w="1463040"/>
-                <a:gridCol w="1188720"/>
+                <a:gridCol w="3291840"/>
+                <a:gridCol w="1005840"/>
+                <a:gridCol w="1005840"/>
+                <a:gridCol w="1005840"/>
+                <a:gridCol w="1005840"/>
               </a:tblGrid>
               <a:tr h="384048">
                 <a:tc>
@@ -6228,7 +6211,7 @@
                         <a:buNone/>
                       </a:pPr>
                       <a:r>
-                        <a:rPr lang="en-US" sz="1100" b="1" dirty="0">
+                        <a:rPr lang="en-US" sz="1200" b="1" dirty="0">
                           <a:solidFill>
                             <a:srgbClr val="1F2A36"/>
                           </a:solidFill>
@@ -6236,74 +6219,9 @@
                           <a:ea typeface="Calibri" pitchFamily="34" charset="-122"/>
                           <a:cs typeface="Calibri" pitchFamily="34" charset="-120"/>
                         </a:rPr>
-                        <a:t>Qué falta confirmar</a:t>
+                        <a:t>Qué borra el ahorro</a:t>
                       </a:r>
-                      <a:endParaRPr lang="en-US" sz="1100" dirty="0">
-                        <a:latin typeface="Calibri" charset="0"/>
-                        <a:ea typeface="Calibri" charset="0"/>
-                        <a:cs typeface="Calibri" charset="0"/>
-                      </a:endParaRPr>
-                    </a:p>
-                  </a:txBody>
-                  <a:tcPr marL="91440" marR="91440" marT="45720" marB="45720" anchor="ctr">
-                    <a:lnL w="6350" cap="flat" cmpd="sng" algn="ctr">
-                      <a:solidFill>
-                        <a:srgbClr val="D5DBE1"/>
-                      </a:solidFill>
-                      <a:prstDash val="solid"/>
-                      <a:round/>
-                      <a:headEnd type="none" w="med" len="med"/>
-                      <a:tailEnd type="none" w="med" len="med"/>
-                    </a:lnL>
-                    <a:lnR w="6350" cap="flat" cmpd="sng" algn="ctr">
-                      <a:solidFill>
-                        <a:srgbClr val="D5DBE1"/>
-                      </a:solidFill>
-                      <a:prstDash val="solid"/>
-                      <a:round/>
-                      <a:headEnd type="none" w="med" len="med"/>
-                      <a:tailEnd type="none" w="med" len="med"/>
-                    </a:lnR>
-                    <a:lnT w="6350" cap="flat" cmpd="sng" algn="ctr">
-                      <a:solidFill>
-                        <a:srgbClr val="D5DBE1"/>
-                      </a:solidFill>
-                      <a:prstDash val="solid"/>
-                      <a:round/>
-                      <a:headEnd type="none" w="med" len="med"/>
-                      <a:tailEnd type="none" w="med" len="med"/>
-                    </a:lnT>
-                    <a:lnB w="6350" cap="flat" cmpd="sng" algn="ctr">
-                      <a:solidFill>
-                        <a:srgbClr val="D5DBE1"/>
-                      </a:solidFill>
-                      <a:prstDash val="solid"/>
-                      <a:round/>
-                      <a:headEnd type="none" w="med" len="med"/>
-                      <a:tailEnd type="none" w="med" len="med"/>
-                    </a:lnB>
-                  </a:tcPr>
-                </a:tc>
-                <a:tc>
-                  <a:txBody>
-                    <a:bodyPr/>
-                    <a:lstStyle/>
-                    <a:p>
-                      <a:pPr indent="0" marL="0">
-                        <a:buNone/>
-                      </a:pPr>
-                      <a:r>
-                        <a:rPr lang="en-US" sz="1100" b="1" dirty="0">
-                          <a:solidFill>
-                            <a:srgbClr val="1F2A36"/>
-                          </a:solidFill>
-                          <a:latin typeface="Calibri" pitchFamily="34" charset="0"/>
-                          <a:ea typeface="Calibri" pitchFamily="34" charset="-122"/>
-                          <a:cs typeface="Calibri" pitchFamily="34" charset="-120"/>
-                        </a:rPr>
-                        <a:t>Valor de trabajo</a:t>
-                      </a:r>
-                      <a:endParaRPr lang="en-US" sz="1100" dirty="0">
+                      <a:endParaRPr lang="en-US" sz="1200" dirty="0">
                         <a:latin typeface="Calibri" charset="0"/>
                         <a:ea typeface="Calibri" charset="0"/>
                         <a:cs typeface="Calibri" charset="0"/>
@@ -6358,7 +6276,7 @@
                         <a:buNone/>
                       </a:pPr>
                       <a:r>
-                        <a:rPr lang="en-US" sz="1100" b="1" dirty="0">
+                        <a:rPr lang="en-US" sz="1200" b="1" dirty="0">
                           <a:solidFill>
                             <a:srgbClr val="1F2A36"/>
                           </a:solidFill>
@@ -6366,9 +6284,9 @@
                           <a:ea typeface="Calibri" pitchFamily="34" charset="-122"/>
                           <a:cs typeface="Calibri" pitchFamily="34" charset="-120"/>
                         </a:rPr>
-                        <a:t>En juego (USD)</a:t>
+                        <a:t>PS · 5/mes</a:t>
                       </a:r>
-                      <a:endParaRPr lang="en-US" sz="1100" dirty="0">
+                      <a:endParaRPr lang="en-US" sz="1200" dirty="0">
                         <a:latin typeface="Calibri" charset="0"/>
                         <a:ea typeface="Calibri" charset="0"/>
                         <a:cs typeface="Calibri" charset="0"/>
@@ -6419,11 +6337,11 @@
                     <a:bodyPr/>
                     <a:lstStyle/>
                     <a:p>
-                      <a:pPr indent="0" marL="0">
+                      <a:pPr algn="r" indent="0" marL="0">
                         <a:buNone/>
                       </a:pPr>
                       <a:r>
-                        <a:rPr lang="en-US" sz="1100" b="1" dirty="0">
+                        <a:rPr lang="en-US" sz="1200" b="1" dirty="0">
                           <a:solidFill>
                             <a:srgbClr val="1F2A36"/>
                           </a:solidFill>
@@ -6431,9 +6349,139 @@
                           <a:ea typeface="Calibri" pitchFamily="34" charset="-122"/>
                           <a:cs typeface="Calibri" pitchFamily="34" charset="-120"/>
                         </a:rPr>
-                        <a:t>Quién</a:t>
+                        <a:t>PS · 6/mes</a:t>
                       </a:r>
-                      <a:endParaRPr lang="en-US" sz="1100" dirty="0">
+                      <a:endParaRPr lang="en-US" sz="1200" dirty="0">
+                        <a:latin typeface="Calibri" charset="0"/>
+                        <a:ea typeface="Calibri" charset="0"/>
+                        <a:cs typeface="Calibri" charset="0"/>
+                      </a:endParaRPr>
+                    </a:p>
+                  </a:txBody>
+                  <a:tcPr marL="91440" marR="91440" marT="45720" marB="45720" anchor="ctr">
+                    <a:lnL w="6350" cap="flat" cmpd="sng" algn="ctr">
+                      <a:solidFill>
+                        <a:srgbClr val="D5DBE1"/>
+                      </a:solidFill>
+                      <a:prstDash val="solid"/>
+                      <a:round/>
+                      <a:headEnd type="none" w="med" len="med"/>
+                      <a:tailEnd type="none" w="med" len="med"/>
+                    </a:lnL>
+                    <a:lnR w="6350" cap="flat" cmpd="sng" algn="ctr">
+                      <a:solidFill>
+                        <a:srgbClr val="D5DBE1"/>
+                      </a:solidFill>
+                      <a:prstDash val="solid"/>
+                      <a:round/>
+                      <a:headEnd type="none" w="med" len="med"/>
+                      <a:tailEnd type="none" w="med" len="med"/>
+                    </a:lnR>
+                    <a:lnT w="6350" cap="flat" cmpd="sng" algn="ctr">
+                      <a:solidFill>
+                        <a:srgbClr val="D5DBE1"/>
+                      </a:solidFill>
+                      <a:prstDash val="solid"/>
+                      <a:round/>
+                      <a:headEnd type="none" w="med" len="med"/>
+                      <a:tailEnd type="none" w="med" len="med"/>
+                    </a:lnT>
+                    <a:lnB w="6350" cap="flat" cmpd="sng" algn="ctr">
+                      <a:solidFill>
+                        <a:srgbClr val="D5DBE1"/>
+                      </a:solidFill>
+                      <a:prstDash val="solid"/>
+                      <a:round/>
+                      <a:headEnd type="none" w="med" len="med"/>
+                      <a:tailEnd type="none" w="med" len="med"/>
+                    </a:lnB>
+                  </a:tcPr>
+                </a:tc>
+                <a:tc>
+                  <a:txBody>
+                    <a:bodyPr/>
+                    <a:lstStyle/>
+                    <a:p>
+                      <a:pPr algn="r" indent="0" marL="0">
+                        <a:buNone/>
+                      </a:pPr>
+                      <a:r>
+                        <a:rPr lang="en-US" sz="1200" b="1" dirty="0">
+                          <a:solidFill>
+                            <a:srgbClr val="1F2A36"/>
+                          </a:solidFill>
+                          <a:latin typeface="Calibri" pitchFamily="34" charset="0"/>
+                          <a:ea typeface="Calibri" pitchFamily="34" charset="-122"/>
+                          <a:cs typeface="Calibri" pitchFamily="34" charset="-120"/>
+                        </a:rPr>
+                        <a:t>Eco · 5/mes</a:t>
+                      </a:r>
+                      <a:endParaRPr lang="en-US" sz="1200" dirty="0">
+                        <a:latin typeface="Calibri" charset="0"/>
+                        <a:ea typeface="Calibri" charset="0"/>
+                        <a:cs typeface="Calibri" charset="0"/>
+                      </a:endParaRPr>
+                    </a:p>
+                  </a:txBody>
+                  <a:tcPr marL="91440" marR="91440" marT="45720" marB="45720" anchor="ctr">
+                    <a:lnL w="6350" cap="flat" cmpd="sng" algn="ctr">
+                      <a:solidFill>
+                        <a:srgbClr val="D5DBE1"/>
+                      </a:solidFill>
+                      <a:prstDash val="solid"/>
+                      <a:round/>
+                      <a:headEnd type="none" w="med" len="med"/>
+                      <a:tailEnd type="none" w="med" len="med"/>
+                    </a:lnL>
+                    <a:lnR w="6350" cap="flat" cmpd="sng" algn="ctr">
+                      <a:solidFill>
+                        <a:srgbClr val="D5DBE1"/>
+                      </a:solidFill>
+                      <a:prstDash val="solid"/>
+                      <a:round/>
+                      <a:headEnd type="none" w="med" len="med"/>
+                      <a:tailEnd type="none" w="med" len="med"/>
+                    </a:lnR>
+                    <a:lnT w="6350" cap="flat" cmpd="sng" algn="ctr">
+                      <a:solidFill>
+                        <a:srgbClr val="D5DBE1"/>
+                      </a:solidFill>
+                      <a:prstDash val="solid"/>
+                      <a:round/>
+                      <a:headEnd type="none" w="med" len="med"/>
+                      <a:tailEnd type="none" w="med" len="med"/>
+                    </a:lnT>
+                    <a:lnB w="6350" cap="flat" cmpd="sng" algn="ctr">
+                      <a:solidFill>
+                        <a:srgbClr val="D5DBE1"/>
+                      </a:solidFill>
+                      <a:prstDash val="solid"/>
+                      <a:round/>
+                      <a:headEnd type="none" w="med" len="med"/>
+                      <a:tailEnd type="none" w="med" len="med"/>
+                    </a:lnB>
+                  </a:tcPr>
+                </a:tc>
+                <a:tc>
+                  <a:txBody>
+                    <a:bodyPr/>
+                    <a:lstStyle/>
+                    <a:p>
+                      <a:pPr algn="r" indent="0" marL="0">
+                        <a:buNone/>
+                      </a:pPr>
+                      <a:r>
+                        <a:rPr lang="en-US" sz="1200" b="1" dirty="0">
+                          <a:solidFill>
+                            <a:srgbClr val="1F2A36"/>
+                          </a:solidFill>
+                          <a:latin typeface="Calibri" pitchFamily="34" charset="0"/>
+                          <a:ea typeface="Calibri" pitchFamily="34" charset="-122"/>
+                          <a:cs typeface="Calibri" pitchFamily="34" charset="-120"/>
+                        </a:rPr>
+                        <a:t>Eco · 6/mes</a:t>
+                      </a:r>
+                      <a:endParaRPr lang="en-US" sz="1200" dirty="0">
                         <a:latin typeface="Calibri" charset="0"/>
                         <a:ea typeface="Calibri" charset="0"/>
                         <a:cs typeface="Calibri" charset="0"/>
@@ -6490,7 +6538,7 @@
                         <a:buNone/>
                       </a:pPr>
                       <a:r>
-                        <a:rPr lang="en-US" sz="1100" dirty="0">
+                        <a:rPr lang="en-US" sz="1200" dirty="0">
                           <a:solidFill>
                             <a:srgbClr val="1F2A36"/>
                           </a:solidFill>
@@ -6498,74 +6546,9 @@
                           <a:ea typeface="Calibri" pitchFamily="34" charset="-122"/>
                           <a:cs typeface="Calibri" pitchFamily="34" charset="-120"/>
                         </a:rPr>
-                        <a:t>Rango real de los 20 pozos fuera de la locación</a:t>
+                        <a:t>Ahorro de la campaña (USD)</a:t>
                       </a:r>
-                      <a:endParaRPr lang="en-US" sz="1100" dirty="0">
-                        <a:latin typeface="Calibri" charset="0"/>
-                        <a:ea typeface="Calibri" charset="0"/>
-                        <a:cs typeface="Calibri" charset="0"/>
-                      </a:endParaRPr>
-                    </a:p>
-                  </a:txBody>
-                  <a:tcPr marL="91440" marR="91440" marT="45720" marB="45720" anchor="ctr">
-                    <a:lnL w="6350" cap="flat" cmpd="sng" algn="ctr">
-                      <a:solidFill>
-                        <a:srgbClr val="D5DBE1"/>
-                      </a:solidFill>
-                      <a:prstDash val="solid"/>
-                      <a:round/>
-                      <a:headEnd type="none" w="med" len="med"/>
-                      <a:tailEnd type="none" w="med" len="med"/>
-                    </a:lnL>
-                    <a:lnR w="6350" cap="flat" cmpd="sng" algn="ctr">
-                      <a:solidFill>
-                        <a:srgbClr val="D5DBE1"/>
-                      </a:solidFill>
-                      <a:prstDash val="solid"/>
-                      <a:round/>
-                      <a:headEnd type="none" w="med" len="med"/>
-                      <a:tailEnd type="none" w="med" len="med"/>
-                    </a:lnR>
-                    <a:lnT w="6350" cap="flat" cmpd="sng" algn="ctr">
-                      <a:solidFill>
-                        <a:srgbClr val="D5DBE1"/>
-                      </a:solidFill>
-                      <a:prstDash val="solid"/>
-                      <a:round/>
-                      <a:headEnd type="none" w="med" len="med"/>
-                      <a:tailEnd type="none" w="med" len="med"/>
-                    </a:lnT>
-                    <a:lnB w="6350" cap="flat" cmpd="sng" algn="ctr">
-                      <a:solidFill>
-                        <a:srgbClr val="D5DBE1"/>
-                      </a:solidFill>
-                      <a:prstDash val="solid"/>
-                      <a:round/>
-                      <a:headEnd type="none" w="med" len="med"/>
-                      <a:tailEnd type="none" w="med" len="med"/>
-                    </a:lnB>
-                  </a:tcPr>
-                </a:tc>
-                <a:tc>
-                  <a:txBody>
-                    <a:bodyPr/>
-                    <a:lstStyle/>
-                    <a:p>
-                      <a:pPr indent="0" marL="0">
-                        <a:buNone/>
-                      </a:pPr>
-                      <a:r>
-                        <a:rPr lang="en-US" sz="1100" dirty="0">
-                          <a:solidFill>
-                            <a:srgbClr val="1F2A36"/>
-                          </a:solidFill>
-                          <a:latin typeface="Calibri" pitchFamily="34" charset="0"/>
-                          <a:ea typeface="Calibri" pitchFamily="34" charset="-122"/>
-                          <a:cs typeface="Calibri" pitchFamily="34" charset="-120"/>
-                        </a:rPr>
-                        <a:t>0,1–5 km</a:t>
-                      </a:r>
-                      <a:endParaRPr lang="en-US" sz="1100" dirty="0">
+                      <a:endParaRPr lang="en-US" sz="1200" dirty="0">
                         <a:latin typeface="Calibri" charset="0"/>
                         <a:ea typeface="Calibri" charset="0"/>
                         <a:cs typeface="Calibri" charset="0"/>
@@ -6620,17 +6603,17 @@
                         <a:buNone/>
                       </a:pPr>
                       <a:r>
-                        <a:rPr lang="en-US" sz="1100" dirty="0">
+                        <a:rPr lang="en-US" sz="1200" dirty="0">
                           <a:solidFill>
-                            <a:srgbClr val="B03A2E"/>
+                            <a:srgbClr val="1F2A36"/>
                           </a:solidFill>
                           <a:latin typeface="Calibri" pitchFamily="34" charset="0"/>
                           <a:ea typeface="Calibri" pitchFamily="34" charset="-122"/>
                           <a:cs typeface="Calibri" pitchFamily="34" charset="-120"/>
                         </a:rPr>
-                        <a:t>−0,18 M a −0,43 M</a:t>
+                        <a:t>+0,20 M</a:t>
                       </a:r>
-                      <a:endParaRPr lang="en-US" sz="1100" dirty="0">
+                      <a:endParaRPr lang="en-US" sz="1200" dirty="0">
                         <a:latin typeface="Calibri" charset="0"/>
                         <a:ea typeface="Calibri" charset="0"/>
                         <a:cs typeface="Calibri" charset="0"/>
@@ -6681,11 +6664,11 @@
                     <a:bodyPr/>
                     <a:lstStyle/>
                     <a:p>
-                      <a:pPr indent="0" marL="0">
+                      <a:pPr algn="r" indent="0" marL="0">
                         <a:buNone/>
                       </a:pPr>
                       <a:r>
-                        <a:rPr lang="en-US" sz="1100" dirty="0">
+                        <a:rPr lang="en-US" sz="1200" dirty="0">
                           <a:solidFill>
                             <a:srgbClr val="1F2A36"/>
                           </a:solidFill>
@@ -6693,9 +6676,139 @@
                           <a:ea typeface="Calibri" pitchFamily="34" charset="-122"/>
                           <a:cs typeface="Calibri" pitchFamily="34" charset="-120"/>
                         </a:rPr>
-                        <a:t>SierraCol</a:t>
+                        <a:t>+0,57 M</a:t>
                       </a:r>
-                      <a:endParaRPr lang="en-US" sz="1100" dirty="0">
+                      <a:endParaRPr lang="en-US" sz="1200" dirty="0">
+                        <a:latin typeface="Calibri" charset="0"/>
+                        <a:ea typeface="Calibri" charset="0"/>
+                        <a:cs typeface="Calibri" charset="0"/>
+                      </a:endParaRPr>
+                    </a:p>
+                  </a:txBody>
+                  <a:tcPr marL="91440" marR="91440" marT="45720" marB="45720" anchor="ctr">
+                    <a:lnL w="6350" cap="flat" cmpd="sng" algn="ctr">
+                      <a:solidFill>
+                        <a:srgbClr val="D5DBE1"/>
+                      </a:solidFill>
+                      <a:prstDash val="solid"/>
+                      <a:round/>
+                      <a:headEnd type="none" w="med" len="med"/>
+                      <a:tailEnd type="none" w="med" len="med"/>
+                    </a:lnL>
+                    <a:lnR w="6350" cap="flat" cmpd="sng" algn="ctr">
+                      <a:solidFill>
+                        <a:srgbClr val="D5DBE1"/>
+                      </a:solidFill>
+                      <a:prstDash val="solid"/>
+                      <a:round/>
+                      <a:headEnd type="none" w="med" len="med"/>
+                      <a:tailEnd type="none" w="med" len="med"/>
+                    </a:lnR>
+                    <a:lnT w="6350" cap="flat" cmpd="sng" algn="ctr">
+                      <a:solidFill>
+                        <a:srgbClr val="D5DBE1"/>
+                      </a:solidFill>
+                      <a:prstDash val="solid"/>
+                      <a:round/>
+                      <a:headEnd type="none" w="med" len="med"/>
+                      <a:tailEnd type="none" w="med" len="med"/>
+                    </a:lnT>
+                    <a:lnB w="6350" cap="flat" cmpd="sng" algn="ctr">
+                      <a:solidFill>
+                        <a:srgbClr val="D5DBE1"/>
+                      </a:solidFill>
+                      <a:prstDash val="solid"/>
+                      <a:round/>
+                      <a:headEnd type="none" w="med" len="med"/>
+                      <a:tailEnd type="none" w="med" len="med"/>
+                    </a:lnB>
+                  </a:tcPr>
+                </a:tc>
+                <a:tc>
+                  <a:txBody>
+                    <a:bodyPr/>
+                    <a:lstStyle/>
+                    <a:p>
+                      <a:pPr algn="r" indent="0" marL="0">
+                        <a:buNone/>
+                      </a:pPr>
+                      <a:r>
+                        <a:rPr lang="en-US" sz="1200" dirty="0">
+                          <a:solidFill>
+                            <a:srgbClr val="1F2A36"/>
+                          </a:solidFill>
+                          <a:latin typeface="Calibri" pitchFamily="34" charset="0"/>
+                          <a:ea typeface="Calibri" pitchFamily="34" charset="-122"/>
+                          <a:cs typeface="Calibri" pitchFamily="34" charset="-120"/>
+                        </a:rPr>
+                        <a:t>+0,56 M</a:t>
+                      </a:r>
+                      <a:endParaRPr lang="en-US" sz="1200" dirty="0">
+                        <a:latin typeface="Calibri" charset="0"/>
+                        <a:ea typeface="Calibri" charset="0"/>
+                        <a:cs typeface="Calibri" charset="0"/>
+                      </a:endParaRPr>
+                    </a:p>
+                  </a:txBody>
+                  <a:tcPr marL="91440" marR="91440" marT="45720" marB="45720" anchor="ctr">
+                    <a:lnL w="6350" cap="flat" cmpd="sng" algn="ctr">
+                      <a:solidFill>
+                        <a:srgbClr val="D5DBE1"/>
+                      </a:solidFill>
+                      <a:prstDash val="solid"/>
+                      <a:round/>
+                      <a:headEnd type="none" w="med" len="med"/>
+                      <a:tailEnd type="none" w="med" len="med"/>
+                    </a:lnL>
+                    <a:lnR w="6350" cap="flat" cmpd="sng" algn="ctr">
+                      <a:solidFill>
+                        <a:srgbClr val="D5DBE1"/>
+                      </a:solidFill>
+                      <a:prstDash val="solid"/>
+                      <a:round/>
+                      <a:headEnd type="none" w="med" len="med"/>
+                      <a:tailEnd type="none" w="med" len="med"/>
+                    </a:lnR>
+                    <a:lnT w="6350" cap="flat" cmpd="sng" algn="ctr">
+                      <a:solidFill>
+                        <a:srgbClr val="D5DBE1"/>
+                      </a:solidFill>
+                      <a:prstDash val="solid"/>
+                      <a:round/>
+                      <a:headEnd type="none" w="med" len="med"/>
+                      <a:tailEnd type="none" w="med" len="med"/>
+                    </a:lnT>
+                    <a:lnB w="6350" cap="flat" cmpd="sng" algn="ctr">
+                      <a:solidFill>
+                        <a:srgbClr val="D5DBE1"/>
+                      </a:solidFill>
+                      <a:prstDash val="solid"/>
+                      <a:round/>
+                      <a:headEnd type="none" w="med" len="med"/>
+                      <a:tailEnd type="none" w="med" len="med"/>
+                    </a:lnB>
+                  </a:tcPr>
+                </a:tc>
+                <a:tc>
+                  <a:txBody>
+                    <a:bodyPr/>
+                    <a:lstStyle/>
+                    <a:p>
+                      <a:pPr algn="r" indent="0" marL="0">
+                        <a:buNone/>
+                      </a:pPr>
+                      <a:r>
+                        <a:rPr lang="en-US" sz="1200" dirty="0">
+                          <a:solidFill>
+                            <a:srgbClr val="1F2A36"/>
+                          </a:solidFill>
+                          <a:latin typeface="Calibri" pitchFamily="34" charset="0"/>
+                          <a:ea typeface="Calibri" pitchFamily="34" charset="-122"/>
+                          <a:cs typeface="Calibri" pitchFamily="34" charset="-120"/>
+                        </a:rPr>
+                        <a:t>+0,64 M</a:t>
+                      </a:r>
+                      <a:endParaRPr lang="en-US" sz="1200" dirty="0">
                         <a:latin typeface="Calibri" charset="0"/>
                         <a:ea typeface="Calibri" charset="0"/>
                         <a:cs typeface="Calibri" charset="0"/>
@@ -6752,7 +6865,7 @@
                         <a:buNone/>
                       </a:pPr>
                       <a:r>
-                        <a:rPr lang="en-US" sz="1100" dirty="0">
+                        <a:rPr lang="en-US" sz="1200" dirty="0">
                           <a:solidFill>
                             <a:srgbClr val="1F2A36"/>
                           </a:solidFill>
@@ -6760,74 +6873,9 @@
                           <a:ea typeface="Calibri" pitchFamily="34" charset="-122"/>
                           <a:cs typeface="Calibri" pitchFamily="34" charset="-120"/>
                         </a:rPr>
-                        <a:t>Horas de taladro por movilización (Excel vs Petro Star)</a:t>
+                        <a:t>Ahorro por pozo (% de un pozo de 550 k)</a:t>
                       </a:r>
-                      <a:endParaRPr lang="en-US" sz="1100" dirty="0">
-                        <a:latin typeface="Calibri" charset="0"/>
-                        <a:ea typeface="Calibri" charset="0"/>
-                        <a:cs typeface="Calibri" charset="0"/>
-                      </a:endParaRPr>
-                    </a:p>
-                  </a:txBody>
-                  <a:tcPr marL="91440" marR="91440" marT="45720" marB="45720" anchor="ctr">
-                    <a:lnL w="6350" cap="flat" cmpd="sng" algn="ctr">
-                      <a:solidFill>
-                        <a:srgbClr val="D5DBE1"/>
-                      </a:solidFill>
-                      <a:prstDash val="solid"/>
-                      <a:round/>
-                      <a:headEnd type="none" w="med" len="med"/>
-                      <a:tailEnd type="none" w="med" len="med"/>
-                    </a:lnL>
-                    <a:lnR w="6350" cap="flat" cmpd="sng" algn="ctr">
-                      <a:solidFill>
-                        <a:srgbClr val="D5DBE1"/>
-                      </a:solidFill>
-                      <a:prstDash val="solid"/>
-                      <a:round/>
-                      <a:headEnd type="none" w="med" len="med"/>
-                      <a:tailEnd type="none" w="med" len="med"/>
-                    </a:lnR>
-                    <a:lnT w="6350" cap="flat" cmpd="sng" algn="ctr">
-                      <a:solidFill>
-                        <a:srgbClr val="D5DBE1"/>
-                      </a:solidFill>
-                      <a:prstDash val="solid"/>
-                      <a:round/>
-                      <a:headEnd type="none" w="med" len="med"/>
-                      <a:tailEnd type="none" w="med" len="med"/>
-                    </a:lnT>
-                    <a:lnB w="6350" cap="flat" cmpd="sng" algn="ctr">
-                      <a:solidFill>
-                        <a:srgbClr val="D5DBE1"/>
-                      </a:solidFill>
-                      <a:prstDash val="solid"/>
-                      <a:round/>
-                      <a:headEnd type="none" w="med" len="med"/>
-                      <a:tailEnd type="none" w="med" len="med"/>
-                    </a:lnB>
-                  </a:tcPr>
-                </a:tc>
-                <a:tc>
-                  <a:txBody>
-                    <a:bodyPr/>
-                    <a:lstStyle/>
-                    <a:p>
-                      <a:pPr indent="0" marL="0">
-                        <a:buNone/>
-                      </a:pPr>
-                      <a:r>
-                        <a:rPr lang="en-US" sz="1100" dirty="0">
-                          <a:solidFill>
-                            <a:srgbClr val="1F2A36"/>
-                          </a:solidFill>
-                          <a:latin typeface="Calibri" pitchFamily="34" charset="0"/>
-                          <a:ea typeface="Calibri" pitchFamily="34" charset="-122"/>
-                          <a:cs typeface="Calibri" pitchFamily="34" charset="-120"/>
-                        </a:rPr>
-                        <a:t>12/18/24/28 h</a:t>
-                      </a:r>
-                      <a:endParaRPr lang="en-US" sz="1100" dirty="0">
+                      <a:endParaRPr lang="en-US" sz="1200" dirty="0">
                         <a:latin typeface="Calibri" charset="0"/>
                         <a:ea typeface="Calibri" charset="0"/>
                         <a:cs typeface="Calibri" charset="0"/>
@@ -6882,17 +6930,17 @@
                         <a:buNone/>
                       </a:pPr>
                       <a:r>
-                        <a:rPr lang="en-US" sz="1100" dirty="0">
+                        <a:rPr lang="en-US" sz="1200" dirty="0">
                           <a:solidFill>
-                            <a:srgbClr val="B03A2E"/>
+                            <a:srgbClr val="1F2A36"/>
                           </a:solidFill>
                           <a:latin typeface="Calibri" pitchFamily="34" charset="0"/>
                           <a:ea typeface="Calibri" pitchFamily="34" charset="-122"/>
                           <a:cs typeface="Calibri" pitchFamily="34" charset="-120"/>
                         </a:rPr>
-                        <a:t>−0,17 M</a:t>
+                        <a:t>1,0 %</a:t>
                       </a:r>
-                      <a:endParaRPr lang="en-US" sz="1100" dirty="0">
+                      <a:endParaRPr lang="en-US" sz="1200" dirty="0">
                         <a:latin typeface="Calibri" charset="0"/>
                         <a:ea typeface="Calibri" charset="0"/>
                         <a:cs typeface="Calibri" charset="0"/>
@@ -6943,11 +6991,11 @@
                     <a:bodyPr/>
                     <a:lstStyle/>
                     <a:p>
-                      <a:pPr indent="0" marL="0">
+                      <a:pPr algn="r" indent="0" marL="0">
                         <a:buNone/>
                       </a:pPr>
                       <a:r>
-                        <a:rPr lang="en-US" sz="1100" dirty="0">
+                        <a:rPr lang="en-US" sz="1200" dirty="0">
                           <a:solidFill>
                             <a:srgbClr val="1F2A36"/>
                           </a:solidFill>
@@ -6955,9 +7003,139 @@
                           <a:ea typeface="Calibri" pitchFamily="34" charset="-122"/>
                           <a:cs typeface="Calibri" pitchFamily="34" charset="-120"/>
                         </a:rPr>
-                        <a:t>SierraCol</a:t>
+                        <a:t>3,0 %</a:t>
                       </a:r>
-                      <a:endParaRPr lang="en-US" sz="1100" dirty="0">
+                      <a:endParaRPr lang="en-US" sz="1200" dirty="0">
+                        <a:latin typeface="Calibri" charset="0"/>
+                        <a:ea typeface="Calibri" charset="0"/>
+                        <a:cs typeface="Calibri" charset="0"/>
+                      </a:endParaRPr>
+                    </a:p>
+                  </a:txBody>
+                  <a:tcPr marL="91440" marR="91440" marT="45720" marB="45720" anchor="ctr">
+                    <a:lnL w="6350" cap="flat" cmpd="sng" algn="ctr">
+                      <a:solidFill>
+                        <a:srgbClr val="D5DBE1"/>
+                      </a:solidFill>
+                      <a:prstDash val="solid"/>
+                      <a:round/>
+                      <a:headEnd type="none" w="med" len="med"/>
+                      <a:tailEnd type="none" w="med" len="med"/>
+                    </a:lnL>
+                    <a:lnR w="6350" cap="flat" cmpd="sng" algn="ctr">
+                      <a:solidFill>
+                        <a:srgbClr val="D5DBE1"/>
+                      </a:solidFill>
+                      <a:prstDash val="solid"/>
+                      <a:round/>
+                      <a:headEnd type="none" w="med" len="med"/>
+                      <a:tailEnd type="none" w="med" len="med"/>
+                    </a:lnR>
+                    <a:lnT w="6350" cap="flat" cmpd="sng" algn="ctr">
+                      <a:solidFill>
+                        <a:srgbClr val="D5DBE1"/>
+                      </a:solidFill>
+                      <a:prstDash val="solid"/>
+                      <a:round/>
+                      <a:headEnd type="none" w="med" len="med"/>
+                      <a:tailEnd type="none" w="med" len="med"/>
+                    </a:lnT>
+                    <a:lnB w="6350" cap="flat" cmpd="sng" algn="ctr">
+                      <a:solidFill>
+                        <a:srgbClr val="D5DBE1"/>
+                      </a:solidFill>
+                      <a:prstDash val="solid"/>
+                      <a:round/>
+                      <a:headEnd type="none" w="med" len="med"/>
+                      <a:tailEnd type="none" w="med" len="med"/>
+                    </a:lnB>
+                  </a:tcPr>
+                </a:tc>
+                <a:tc>
+                  <a:txBody>
+                    <a:bodyPr/>
+                    <a:lstStyle/>
+                    <a:p>
+                      <a:pPr algn="r" indent="0" marL="0">
+                        <a:buNone/>
+                      </a:pPr>
+                      <a:r>
+                        <a:rPr lang="en-US" sz="1200" dirty="0">
+                          <a:solidFill>
+                            <a:srgbClr val="1F2A36"/>
+                          </a:solidFill>
+                          <a:latin typeface="Calibri" pitchFamily="34" charset="0"/>
+                          <a:ea typeface="Calibri" pitchFamily="34" charset="-122"/>
+                          <a:cs typeface="Calibri" pitchFamily="34" charset="-120"/>
+                        </a:rPr>
+                        <a:t>2,9 %</a:t>
+                      </a:r>
+                      <a:endParaRPr lang="en-US" sz="1200" dirty="0">
+                        <a:latin typeface="Calibri" charset="0"/>
+                        <a:ea typeface="Calibri" charset="0"/>
+                        <a:cs typeface="Calibri" charset="0"/>
+                      </a:endParaRPr>
+                    </a:p>
+                  </a:txBody>
+                  <a:tcPr marL="91440" marR="91440" marT="45720" marB="45720" anchor="ctr">
+                    <a:lnL w="6350" cap="flat" cmpd="sng" algn="ctr">
+                      <a:solidFill>
+                        <a:srgbClr val="D5DBE1"/>
+                      </a:solidFill>
+                      <a:prstDash val="solid"/>
+                      <a:round/>
+                      <a:headEnd type="none" w="med" len="med"/>
+                      <a:tailEnd type="none" w="med" len="med"/>
+                    </a:lnL>
+                    <a:lnR w="6350" cap="flat" cmpd="sng" algn="ctr">
+                      <a:solidFill>
+                        <a:srgbClr val="D5DBE1"/>
+                      </a:solidFill>
+                      <a:prstDash val="solid"/>
+                      <a:round/>
+                      <a:headEnd type="none" w="med" len="med"/>
+                      <a:tailEnd type="none" w="med" len="med"/>
+                    </a:lnR>
+                    <a:lnT w="6350" cap="flat" cmpd="sng" algn="ctr">
+                      <a:solidFill>
+                        <a:srgbClr val="D5DBE1"/>
+                      </a:solidFill>
+                      <a:prstDash val="solid"/>
+                      <a:round/>
+                      <a:headEnd type="none" w="med" len="med"/>
+                      <a:tailEnd type="none" w="med" len="med"/>
+                    </a:lnT>
+                    <a:lnB w="6350" cap="flat" cmpd="sng" algn="ctr">
+                      <a:solidFill>
+                        <a:srgbClr val="D5DBE1"/>
+                      </a:solidFill>
+                      <a:prstDash val="solid"/>
+                      <a:round/>
+                      <a:headEnd type="none" w="med" len="med"/>
+                      <a:tailEnd type="none" w="med" len="med"/>
+                    </a:lnB>
+                  </a:tcPr>
+                </a:tc>
+                <a:tc>
+                  <a:txBody>
+                    <a:bodyPr/>
+                    <a:lstStyle/>
+                    <a:p>
+                      <a:pPr algn="r" indent="0" marL="0">
+                        <a:buNone/>
+                      </a:pPr>
+                      <a:r>
+                        <a:rPr lang="en-US" sz="1200" dirty="0">
+                          <a:solidFill>
+                            <a:srgbClr val="1F2A36"/>
+                          </a:solidFill>
+                          <a:latin typeface="Calibri" pitchFamily="34" charset="0"/>
+                          <a:ea typeface="Calibri" pitchFamily="34" charset="-122"/>
+                          <a:cs typeface="Calibri" pitchFamily="34" charset="-120"/>
+                        </a:rPr>
+                        <a:t>3,3 %</a:t>
+                      </a:r>
+                      <a:endParaRPr lang="en-US" sz="1200" dirty="0">
                         <a:latin typeface="Calibri" charset="0"/>
                         <a:ea typeface="Calibri" charset="0"/>
                         <a:cs typeface="Calibri" charset="0"/>
@@ -7014,7 +7192,7 @@
                         <a:buNone/>
                       </a:pPr>
                       <a:r>
-                        <a:rPr lang="en-US" sz="1100" dirty="0">
+                        <a:rPr lang="en-US" sz="1200" dirty="0">
                           <a:solidFill>
                             <a:srgbClr val="1F2A36"/>
                           </a:solidFill>
@@ -7022,74 +7200,9 @@
                           <a:ea typeface="Calibri" pitchFamily="34" charset="-122"/>
                           <a:cs typeface="Calibri" pitchFamily="34" charset="-120"/>
                         </a:rPr>
-                        <a:t>¿Petro Star normal cobra aparte sus equipos adicionales?</a:t>
+                        <a:t>Horas extra de taladro por movilización</a:t>
                       </a:r>
-                      <a:endParaRPr lang="en-US" sz="1100" dirty="0">
-                        <a:latin typeface="Calibri" charset="0"/>
-                        <a:ea typeface="Calibri" charset="0"/>
-                        <a:cs typeface="Calibri" charset="0"/>
-                      </a:endParaRPr>
-                    </a:p>
-                  </a:txBody>
-                  <a:tcPr marL="91440" marR="91440" marT="45720" marB="45720" anchor="ctr">
-                    <a:lnL w="6350" cap="flat" cmpd="sng" algn="ctr">
-                      <a:solidFill>
-                        <a:srgbClr val="D5DBE1"/>
-                      </a:solidFill>
-                      <a:prstDash val="solid"/>
-                      <a:round/>
-                      <a:headEnd type="none" w="med" len="med"/>
-                      <a:tailEnd type="none" w="med" len="med"/>
-                    </a:lnL>
-                    <a:lnR w="6350" cap="flat" cmpd="sng" algn="ctr">
-                      <a:solidFill>
-                        <a:srgbClr val="D5DBE1"/>
-                      </a:solidFill>
-                      <a:prstDash val="solid"/>
-                      <a:round/>
-                      <a:headEnd type="none" w="med" len="med"/>
-                      <a:tailEnd type="none" w="med" len="med"/>
-                    </a:lnR>
-                    <a:lnT w="6350" cap="flat" cmpd="sng" algn="ctr">
-                      <a:solidFill>
-                        <a:srgbClr val="D5DBE1"/>
-                      </a:solidFill>
-                      <a:prstDash val="solid"/>
-                      <a:round/>
-                      <a:headEnd type="none" w="med" len="med"/>
-                      <a:tailEnd type="none" w="med" len="med"/>
-                    </a:lnT>
-                    <a:lnB w="6350" cap="flat" cmpd="sng" algn="ctr">
-                      <a:solidFill>
-                        <a:srgbClr val="D5DBE1"/>
-                      </a:solidFill>
-                      <a:prstDash val="solid"/>
-                      <a:round/>
-                      <a:headEnd type="none" w="med" len="med"/>
-                      <a:tailEnd type="none" w="med" len="med"/>
-                    </a:lnB>
-                  </a:tcPr>
-                </a:tc>
-                <a:tc>
-                  <a:txBody>
-                    <a:bodyPr/>
-                    <a:lstStyle/>
-                    <a:p>
-                      <a:pPr indent="0" marL="0">
-                        <a:buNone/>
-                      </a:pPr>
-                      <a:r>
-                        <a:rPr lang="en-US" sz="1100" dirty="0">
-                          <a:solidFill>
-                            <a:srgbClr val="1F2A36"/>
-                          </a:solidFill>
-                          <a:latin typeface="Calibri" pitchFamily="34" charset="0"/>
-                          <a:ea typeface="Calibri" pitchFamily="34" charset="-122"/>
-                          <a:cs typeface="Calibri" pitchFamily="34" charset="-120"/>
-                        </a:rPr>
-                        <a:t>No</a:t>
-                      </a:r>
-                      <a:endParaRPr lang="en-US" sz="1100" dirty="0">
+                      <a:endParaRPr lang="en-US" sz="1200" dirty="0">
                         <a:latin typeface="Calibri" charset="0"/>
                         <a:ea typeface="Calibri" charset="0"/>
                         <a:cs typeface="Calibri" charset="0"/>
@@ -7144,17 +7257,17 @@
                         <a:buNone/>
                       </a:pPr>
                       <a:r>
-                        <a:rPr lang="en-US" sz="1100" dirty="0">
+                        <a:rPr lang="en-US" sz="1200" dirty="0">
                           <a:solidFill>
-                            <a:srgbClr val="B03A2E"/>
+                            <a:srgbClr val="1F2A36"/>
                           </a:solidFill>
                           <a:latin typeface="Calibri" pitchFamily="34" charset="0"/>
                           <a:ea typeface="Calibri" pitchFamily="34" charset="-122"/>
                           <a:cs typeface="Calibri" pitchFamily="34" charset="-120"/>
                         </a:rPr>
-                        <a:t>−0,16 M</a:t>
+                        <a:t>3,9 h</a:t>
                       </a:r>
-                      <a:endParaRPr lang="en-US" sz="1100" dirty="0">
+                      <a:endParaRPr lang="en-US" sz="1200" dirty="0">
                         <a:latin typeface="Calibri" charset="0"/>
                         <a:ea typeface="Calibri" charset="0"/>
                         <a:cs typeface="Calibri" charset="0"/>
@@ -7205,11 +7318,11 @@
                     <a:bodyPr/>
                     <a:lstStyle/>
                     <a:p>
-                      <a:pPr indent="0" marL="0">
+                      <a:pPr algn="r" indent="0" marL="0">
                         <a:buNone/>
                       </a:pPr>
                       <a:r>
-                        <a:rPr lang="en-US" sz="1100" dirty="0">
+                        <a:rPr lang="en-US" sz="1200" dirty="0">
                           <a:solidFill>
                             <a:srgbClr val="1F2A36"/>
                           </a:solidFill>
@@ -7217,9 +7330,139 @@
                           <a:ea typeface="Calibri" pitchFamily="34" charset="-122"/>
                           <a:cs typeface="Calibri" pitchFamily="34" charset="-120"/>
                         </a:rPr>
-                        <a:t>Petro Star</a:t>
+                        <a:t>11,2 h</a:t>
                       </a:r>
-                      <a:endParaRPr lang="en-US" sz="1100" dirty="0">
+                      <a:endParaRPr lang="en-US" sz="1200" dirty="0">
+                        <a:latin typeface="Calibri" charset="0"/>
+                        <a:ea typeface="Calibri" charset="0"/>
+                        <a:cs typeface="Calibri" charset="0"/>
+                      </a:endParaRPr>
+                    </a:p>
+                  </a:txBody>
+                  <a:tcPr marL="91440" marR="91440" marT="45720" marB="45720" anchor="ctr">
+                    <a:lnL w="6350" cap="flat" cmpd="sng" algn="ctr">
+                      <a:solidFill>
+                        <a:srgbClr val="D5DBE1"/>
+                      </a:solidFill>
+                      <a:prstDash val="solid"/>
+                      <a:round/>
+                      <a:headEnd type="none" w="med" len="med"/>
+                      <a:tailEnd type="none" w="med" len="med"/>
+                    </a:lnL>
+                    <a:lnR w="6350" cap="flat" cmpd="sng" algn="ctr">
+                      <a:solidFill>
+                        <a:srgbClr val="D5DBE1"/>
+                      </a:solidFill>
+                      <a:prstDash val="solid"/>
+                      <a:round/>
+                      <a:headEnd type="none" w="med" len="med"/>
+                      <a:tailEnd type="none" w="med" len="med"/>
+                    </a:lnR>
+                    <a:lnT w="6350" cap="flat" cmpd="sng" algn="ctr">
+                      <a:solidFill>
+                        <a:srgbClr val="D5DBE1"/>
+                      </a:solidFill>
+                      <a:prstDash val="solid"/>
+                      <a:round/>
+                      <a:headEnd type="none" w="med" len="med"/>
+                      <a:tailEnd type="none" w="med" len="med"/>
+                    </a:lnT>
+                    <a:lnB w="6350" cap="flat" cmpd="sng" algn="ctr">
+                      <a:solidFill>
+                        <a:srgbClr val="D5DBE1"/>
+                      </a:solidFill>
+                      <a:prstDash val="solid"/>
+                      <a:round/>
+                      <a:headEnd type="none" w="med" len="med"/>
+                      <a:tailEnd type="none" w="med" len="med"/>
+                    </a:lnB>
+                  </a:tcPr>
+                </a:tc>
+                <a:tc>
+                  <a:txBody>
+                    <a:bodyPr/>
+                    <a:lstStyle/>
+                    <a:p>
+                      <a:pPr algn="r" indent="0" marL="0">
+                        <a:buNone/>
+                      </a:pPr>
+                      <a:r>
+                        <a:rPr lang="en-US" sz="1200" dirty="0">
+                          <a:solidFill>
+                            <a:srgbClr val="1F2A36"/>
+                          </a:solidFill>
+                          <a:latin typeface="Calibri" pitchFamily="34" charset="0"/>
+                          <a:ea typeface="Calibri" pitchFamily="34" charset="-122"/>
+                          <a:cs typeface="Calibri" pitchFamily="34" charset="-120"/>
+                        </a:rPr>
+                        <a:t>11,0 h</a:t>
+                      </a:r>
+                      <a:endParaRPr lang="en-US" sz="1200" dirty="0">
+                        <a:latin typeface="Calibri" charset="0"/>
+                        <a:ea typeface="Calibri" charset="0"/>
+                        <a:cs typeface="Calibri" charset="0"/>
+                      </a:endParaRPr>
+                    </a:p>
+                  </a:txBody>
+                  <a:tcPr marL="91440" marR="91440" marT="45720" marB="45720" anchor="ctr">
+                    <a:lnL w="6350" cap="flat" cmpd="sng" algn="ctr">
+                      <a:solidFill>
+                        <a:srgbClr val="D5DBE1"/>
+                      </a:solidFill>
+                      <a:prstDash val="solid"/>
+                      <a:round/>
+                      <a:headEnd type="none" w="med" len="med"/>
+                      <a:tailEnd type="none" w="med" len="med"/>
+                    </a:lnL>
+                    <a:lnR w="6350" cap="flat" cmpd="sng" algn="ctr">
+                      <a:solidFill>
+                        <a:srgbClr val="D5DBE1"/>
+                      </a:solidFill>
+                      <a:prstDash val="solid"/>
+                      <a:round/>
+                      <a:headEnd type="none" w="med" len="med"/>
+                      <a:tailEnd type="none" w="med" len="med"/>
+                    </a:lnR>
+                    <a:lnT w="6350" cap="flat" cmpd="sng" algn="ctr">
+                      <a:solidFill>
+                        <a:srgbClr val="D5DBE1"/>
+                      </a:solidFill>
+                      <a:prstDash val="solid"/>
+                      <a:round/>
+                      <a:headEnd type="none" w="med" len="med"/>
+                      <a:tailEnd type="none" w="med" len="med"/>
+                    </a:lnT>
+                    <a:lnB w="6350" cap="flat" cmpd="sng" algn="ctr">
+                      <a:solidFill>
+                        <a:srgbClr val="D5DBE1"/>
+                      </a:solidFill>
+                      <a:prstDash val="solid"/>
+                      <a:round/>
+                      <a:headEnd type="none" w="med" len="med"/>
+                      <a:tailEnd type="none" w="med" len="med"/>
+                    </a:lnB>
+                  </a:tcPr>
+                </a:tc>
+                <a:tc>
+                  <a:txBody>
+                    <a:bodyPr/>
+                    <a:lstStyle/>
+                    <a:p>
+                      <a:pPr algn="r" indent="0" marL="0">
+                        <a:buNone/>
+                      </a:pPr>
+                      <a:r>
+                        <a:rPr lang="en-US" sz="1200" dirty="0">
+                          <a:solidFill>
+                            <a:srgbClr val="1F2A36"/>
+                          </a:solidFill>
+                          <a:latin typeface="Calibri" pitchFamily="34" charset="0"/>
+                          <a:ea typeface="Calibri" pitchFamily="34" charset="-122"/>
+                          <a:cs typeface="Calibri" pitchFamily="34" charset="-120"/>
+                        </a:rPr>
+                        <a:t>12,5 h</a:t>
+                      </a:r>
+                      <a:endParaRPr lang="en-US" sz="1200" dirty="0">
                         <a:latin typeface="Calibri" charset="0"/>
                         <a:ea typeface="Calibri" charset="0"/>
                         <a:cs typeface="Calibri" charset="0"/>
@@ -7276,7 +7519,7 @@
                         <a:buNone/>
                       </a:pPr>
                       <a:r>
-                        <a:rPr lang="en-US" sz="1100" dirty="0">
+                        <a:rPr lang="en-US" sz="1200" dirty="0">
                           <a:solidFill>
                             <a:srgbClr val="1F2A36"/>
                           </a:solidFill>
@@ -7284,74 +7527,9 @@
                           <a:ea typeface="Calibri" pitchFamily="34" charset="-122"/>
                           <a:cs typeface="Calibri" pitchFamily="34" charset="-120"/>
                         </a:rPr>
-                        <a:t>Cobro en un mes de campaña parada</a:t>
+                        <a:t>Horas sobre el tiempo cotizado (taladro + equipos)</a:t>
                       </a:r>
-                      <a:endParaRPr lang="en-US" sz="1100" dirty="0">
-                        <a:latin typeface="Calibri" charset="0"/>
-                        <a:ea typeface="Calibri" charset="0"/>
-                        <a:cs typeface="Calibri" charset="0"/>
-                      </a:endParaRPr>
-                    </a:p>
-                  </a:txBody>
-                  <a:tcPr marL="91440" marR="91440" marT="45720" marB="45720" anchor="ctr">
-                    <a:lnL w="6350" cap="flat" cmpd="sng" algn="ctr">
-                      <a:solidFill>
-                        <a:srgbClr val="D5DBE1"/>
-                      </a:solidFill>
-                      <a:prstDash val="solid"/>
-                      <a:round/>
-                      <a:headEnd type="none" w="med" len="med"/>
-                      <a:tailEnd type="none" w="med" len="med"/>
-                    </a:lnL>
-                    <a:lnR w="6350" cap="flat" cmpd="sng" algn="ctr">
-                      <a:solidFill>
-                        <a:srgbClr val="D5DBE1"/>
-                      </a:solidFill>
-                      <a:prstDash val="solid"/>
-                      <a:round/>
-                      <a:headEnd type="none" w="med" len="med"/>
-                      <a:tailEnd type="none" w="med" len="med"/>
-                    </a:lnR>
-                    <a:lnT w="6350" cap="flat" cmpd="sng" algn="ctr">
-                      <a:solidFill>
-                        <a:srgbClr val="D5DBE1"/>
-                      </a:solidFill>
-                      <a:prstDash val="solid"/>
-                      <a:round/>
-                      <a:headEnd type="none" w="med" len="med"/>
-                      <a:tailEnd type="none" w="med" len="med"/>
-                    </a:lnT>
-                    <a:lnB w="6350" cap="flat" cmpd="sng" algn="ctr">
-                      <a:solidFill>
-                        <a:srgbClr val="D5DBE1"/>
-                      </a:solidFill>
-                      <a:prstDash val="solid"/>
-                      <a:round/>
-                      <a:headEnd type="none" w="med" len="med"/>
-                      <a:tailEnd type="none" w="med" len="med"/>
-                    </a:lnB>
-                  </a:tcPr>
-                </a:tc>
-                <a:tc>
-                  <a:txBody>
-                    <a:bodyPr/>
-                    <a:lstStyle/>
-                    <a:p>
-                      <a:pPr indent="0" marL="0">
-                        <a:buNone/>
-                      </a:pPr>
-                      <a:r>
-                        <a:rPr lang="en-US" sz="1100" dirty="0">
-                          <a:solidFill>
-                            <a:srgbClr val="1F2A36"/>
-                          </a:solidFill>
-                          <a:latin typeface="Calibri" pitchFamily="34" charset="0"/>
-                          <a:ea typeface="Calibri" pitchFamily="34" charset="-122"/>
-                          <a:cs typeface="Calibri" pitchFamily="34" charset="-120"/>
-                        </a:rPr>
-                        <a:t>No se cobra</a:t>
-                      </a:r>
-                      <a:endParaRPr lang="en-US" sz="1100" dirty="0">
+                      <a:endParaRPr lang="en-US" sz="1200" dirty="0">
                         <a:latin typeface="Calibri" charset="0"/>
                         <a:ea typeface="Calibri" charset="0"/>
                         <a:cs typeface="Calibri" charset="0"/>
@@ -7406,17 +7584,17 @@
                         <a:buNone/>
                       </a:pPr>
                       <a:r>
-                        <a:rPr lang="en-US" sz="1100" dirty="0">
+                        <a:rPr lang="en-US" sz="1200" dirty="0">
                           <a:solidFill>
-                            <a:srgbClr val="B03A2E"/>
+                            <a:srgbClr val="1F2A36"/>
                           </a:solidFill>
                           <a:latin typeface="Calibri" pitchFamily="34" charset="0"/>
                           <a:ea typeface="Calibri" pitchFamily="34" charset="-122"/>
                           <a:cs typeface="Calibri" pitchFamily="34" charset="-120"/>
                         </a:rPr>
-                        <a:t>−0,16 M a −0,23 M por mes</a:t>
+                        <a:t>2,0 h</a:t>
                       </a:r>
-                      <a:endParaRPr lang="en-US" sz="1100" dirty="0">
+                      <a:endParaRPr lang="en-US" sz="1200" dirty="0">
                         <a:latin typeface="Calibri" charset="0"/>
                         <a:ea typeface="Calibri" charset="0"/>
                         <a:cs typeface="Calibri" charset="0"/>
@@ -7467,11 +7645,11 @@
                     <a:bodyPr/>
                     <a:lstStyle/>
                     <a:p>
-                      <a:pPr indent="0" marL="0">
+                      <a:pPr algn="r" indent="0" marL="0">
                         <a:buNone/>
                       </a:pPr>
                       <a:r>
-                        <a:rPr lang="en-US" sz="1100" dirty="0">
+                        <a:rPr lang="en-US" sz="1200" dirty="0">
                           <a:solidFill>
                             <a:srgbClr val="1F2A36"/>
                           </a:solidFill>
@@ -7479,9 +7657,139 @@
                           <a:ea typeface="Calibri" pitchFamily="34" charset="-122"/>
                           <a:cs typeface="Calibri" pitchFamily="34" charset="-120"/>
                         </a:rPr>
-                        <a:t>Contrato</a:t>
+                        <a:t>5,8 h</a:t>
                       </a:r>
-                      <a:endParaRPr lang="en-US" sz="1100" dirty="0">
+                      <a:endParaRPr lang="en-US" sz="1200" dirty="0">
+                        <a:latin typeface="Calibri" charset="0"/>
+                        <a:ea typeface="Calibri" charset="0"/>
+                        <a:cs typeface="Calibri" charset="0"/>
+                      </a:endParaRPr>
+                    </a:p>
+                  </a:txBody>
+                  <a:tcPr marL="91440" marR="91440" marT="45720" marB="45720" anchor="ctr">
+                    <a:lnL w="6350" cap="flat" cmpd="sng" algn="ctr">
+                      <a:solidFill>
+                        <a:srgbClr val="D5DBE1"/>
+                      </a:solidFill>
+                      <a:prstDash val="solid"/>
+                      <a:round/>
+                      <a:headEnd type="none" w="med" len="med"/>
+                      <a:tailEnd type="none" w="med" len="med"/>
+                    </a:lnL>
+                    <a:lnR w="6350" cap="flat" cmpd="sng" algn="ctr">
+                      <a:solidFill>
+                        <a:srgbClr val="D5DBE1"/>
+                      </a:solidFill>
+                      <a:prstDash val="solid"/>
+                      <a:round/>
+                      <a:headEnd type="none" w="med" len="med"/>
+                      <a:tailEnd type="none" w="med" len="med"/>
+                    </a:lnR>
+                    <a:lnT w="6350" cap="flat" cmpd="sng" algn="ctr">
+                      <a:solidFill>
+                        <a:srgbClr val="D5DBE1"/>
+                      </a:solidFill>
+                      <a:prstDash val="solid"/>
+                      <a:round/>
+                      <a:headEnd type="none" w="med" len="med"/>
+                      <a:tailEnd type="none" w="med" len="med"/>
+                    </a:lnT>
+                    <a:lnB w="6350" cap="flat" cmpd="sng" algn="ctr">
+                      <a:solidFill>
+                        <a:srgbClr val="D5DBE1"/>
+                      </a:solidFill>
+                      <a:prstDash val="solid"/>
+                      <a:round/>
+                      <a:headEnd type="none" w="med" len="med"/>
+                      <a:tailEnd type="none" w="med" len="med"/>
+                    </a:lnB>
+                  </a:tcPr>
+                </a:tc>
+                <a:tc>
+                  <a:txBody>
+                    <a:bodyPr/>
+                    <a:lstStyle/>
+                    <a:p>
+                      <a:pPr algn="r" indent="0" marL="0">
+                        <a:buNone/>
+                      </a:pPr>
+                      <a:r>
+                        <a:rPr lang="en-US" sz="1200" dirty="0">
+                          <a:solidFill>
+                            <a:srgbClr val="1F2A36"/>
+                          </a:solidFill>
+                          <a:latin typeface="Calibri" pitchFamily="34" charset="0"/>
+                          <a:ea typeface="Calibri" pitchFamily="34" charset="-122"/>
+                          <a:cs typeface="Calibri" pitchFamily="34" charset="-120"/>
+                        </a:rPr>
+                        <a:t>5,7 h</a:t>
+                      </a:r>
+                      <a:endParaRPr lang="en-US" sz="1200" dirty="0">
+                        <a:latin typeface="Calibri" charset="0"/>
+                        <a:ea typeface="Calibri" charset="0"/>
+                        <a:cs typeface="Calibri" charset="0"/>
+                      </a:endParaRPr>
+                    </a:p>
+                  </a:txBody>
+                  <a:tcPr marL="91440" marR="91440" marT="45720" marB="45720" anchor="ctr">
+                    <a:lnL w="6350" cap="flat" cmpd="sng" algn="ctr">
+                      <a:solidFill>
+                        <a:srgbClr val="D5DBE1"/>
+                      </a:solidFill>
+                      <a:prstDash val="solid"/>
+                      <a:round/>
+                      <a:headEnd type="none" w="med" len="med"/>
+                      <a:tailEnd type="none" w="med" len="med"/>
+                    </a:lnL>
+                    <a:lnR w="6350" cap="flat" cmpd="sng" algn="ctr">
+                      <a:solidFill>
+                        <a:srgbClr val="D5DBE1"/>
+                      </a:solidFill>
+                      <a:prstDash val="solid"/>
+                      <a:round/>
+                      <a:headEnd type="none" w="med" len="med"/>
+                      <a:tailEnd type="none" w="med" len="med"/>
+                    </a:lnR>
+                    <a:lnT w="6350" cap="flat" cmpd="sng" algn="ctr">
+                      <a:solidFill>
+                        <a:srgbClr val="D5DBE1"/>
+                      </a:solidFill>
+                      <a:prstDash val="solid"/>
+                      <a:round/>
+                      <a:headEnd type="none" w="med" len="med"/>
+                      <a:tailEnd type="none" w="med" len="med"/>
+                    </a:lnT>
+                    <a:lnB w="6350" cap="flat" cmpd="sng" algn="ctr">
+                      <a:solidFill>
+                        <a:srgbClr val="D5DBE1"/>
+                      </a:solidFill>
+                      <a:prstDash val="solid"/>
+                      <a:round/>
+                      <a:headEnd type="none" w="med" len="med"/>
+                      <a:tailEnd type="none" w="med" len="med"/>
+                    </a:lnB>
+                  </a:tcPr>
+                </a:tc>
+                <a:tc>
+                  <a:txBody>
+                    <a:bodyPr/>
+                    <a:lstStyle/>
+                    <a:p>
+                      <a:pPr algn="r" indent="0" marL="0">
+                        <a:buNone/>
+                      </a:pPr>
+                      <a:r>
+                        <a:rPr lang="en-US" sz="1200" dirty="0">
+                          <a:solidFill>
+                            <a:srgbClr val="1F2A36"/>
+                          </a:solidFill>
+                          <a:latin typeface="Calibri" pitchFamily="34" charset="0"/>
+                          <a:ea typeface="Calibri" pitchFamily="34" charset="-122"/>
+                          <a:cs typeface="Calibri" pitchFamily="34" charset="-120"/>
+                        </a:rPr>
+                        <a:t>6,5 h</a:t>
+                      </a:r>
+                      <a:endParaRPr lang="en-US" sz="1200" dirty="0">
                         <a:latin typeface="Calibri" charset="0"/>
                         <a:ea typeface="Calibri" charset="0"/>
                         <a:cs typeface="Calibri" charset="0"/>
@@ -7538,7 +7846,7 @@
                         <a:buNone/>
                       </a:pPr>
                       <a:r>
-                        <a:rPr lang="en-US" sz="1100" dirty="0">
+                        <a:rPr lang="en-US" sz="1200" dirty="0">
                           <a:solidFill>
                             <a:srgbClr val="1F2A36"/>
                           </a:solidFill>
@@ -7546,74 +7854,9 @@
                           <a:ea typeface="Calibri" pitchFamily="34" charset="-122"/>
                           <a:cs typeface="Calibri" pitchFamily="34" charset="-120"/>
                         </a:rPr>
-                        <a:t>Demora no atribuible al transportador (cotización 1255, condición 7)</a:t>
+                        <a:t>Días de taladro de demora en toda la campaña</a:t>
                       </a:r>
-                      <a:endParaRPr lang="en-US" sz="1100" dirty="0">
-                        <a:latin typeface="Calibri" charset="0"/>
-                        <a:ea typeface="Calibri" charset="0"/>
-                        <a:cs typeface="Calibri" charset="0"/>
-                      </a:endParaRPr>
-                    </a:p>
-                  </a:txBody>
-                  <a:tcPr marL="91440" marR="91440" marT="45720" marB="45720" anchor="ctr">
-                    <a:lnL w="6350" cap="flat" cmpd="sng" algn="ctr">
-                      <a:solidFill>
-                        <a:srgbClr val="D5DBE1"/>
-                      </a:solidFill>
-                      <a:prstDash val="solid"/>
-                      <a:round/>
-                      <a:headEnd type="none" w="med" len="med"/>
-                      <a:tailEnd type="none" w="med" len="med"/>
-                    </a:lnL>
-                    <a:lnR w="6350" cap="flat" cmpd="sng" algn="ctr">
-                      <a:solidFill>
-                        <a:srgbClr val="D5DBE1"/>
-                      </a:solidFill>
-                      <a:prstDash val="solid"/>
-                      <a:round/>
-                      <a:headEnd type="none" w="med" len="med"/>
-                      <a:tailEnd type="none" w="med" len="med"/>
-                    </a:lnR>
-                    <a:lnT w="6350" cap="flat" cmpd="sng" algn="ctr">
-                      <a:solidFill>
-                        <a:srgbClr val="D5DBE1"/>
-                      </a:solidFill>
-                      <a:prstDash val="solid"/>
-                      <a:round/>
-                      <a:headEnd type="none" w="med" len="med"/>
-                      <a:tailEnd type="none" w="med" len="med"/>
-                    </a:lnT>
-                    <a:lnB w="6350" cap="flat" cmpd="sng" algn="ctr">
-                      <a:solidFill>
-                        <a:srgbClr val="D5DBE1"/>
-                      </a:solidFill>
-                      <a:prstDash val="solid"/>
-                      <a:round/>
-                      <a:headEnd type="none" w="med" len="med"/>
-                      <a:tailEnd type="none" w="med" len="med"/>
-                    </a:lnB>
-                  </a:tcPr>
-                </a:tc>
-                <a:tc>
-                  <a:txBody>
-                    <a:bodyPr/>
-                    <a:lstStyle/>
-                    <a:p>
-                      <a:pPr indent="0" marL="0">
-                        <a:buNone/>
-                      </a:pPr>
-                      <a:r>
-                        <a:rPr lang="en-US" sz="1100" dirty="0">
-                          <a:solidFill>
-                            <a:srgbClr val="1F2A36"/>
-                          </a:solidFill>
-                          <a:latin typeface="Calibri" pitchFamily="34" charset="0"/>
-                          <a:ea typeface="Calibri" pitchFamily="34" charset="-122"/>
-                          <a:cs typeface="Calibri" pitchFamily="34" charset="-120"/>
-                        </a:rPr>
-                        <a:t>Sin demora</a:t>
-                      </a:r>
-                      <a:endParaRPr lang="en-US" sz="1100" dirty="0">
+                      <a:endParaRPr lang="en-US" sz="1200" dirty="0">
                         <a:latin typeface="Calibri" charset="0"/>
                         <a:ea typeface="Calibri" charset="0"/>
                         <a:cs typeface="Calibri" charset="0"/>
@@ -7668,17 +7911,17 @@
                         <a:buNone/>
                       </a:pPr>
                       <a:r>
-                        <a:rPr lang="en-US" sz="1100" dirty="0">
+                        <a:rPr lang="en-US" sz="1200" dirty="0">
                           <a:solidFill>
-                            <a:srgbClr val="B03A2E"/>
+                            <a:srgbClr val="1F2A36"/>
                           </a:solidFill>
                           <a:latin typeface="Calibri" pitchFamily="34" charset="0"/>
                           <a:ea typeface="Calibri" pitchFamily="34" charset="-122"/>
                           <a:cs typeface="Calibri" pitchFamily="34" charset="-120"/>
                         </a:rPr>
-                        <a:t>−2.813 por hora</a:t>
+                        <a:t>5,7 d</a:t>
                       </a:r>
-                      <a:endParaRPr lang="en-US" sz="1100" dirty="0">
+                      <a:endParaRPr lang="en-US" sz="1200" dirty="0">
                         <a:latin typeface="Calibri" charset="0"/>
                         <a:ea typeface="Calibri" charset="0"/>
                         <a:cs typeface="Calibri" charset="0"/>
@@ -7729,11 +7972,11 @@
                     <a:bodyPr/>
                     <a:lstStyle/>
                     <a:p>
-                      <a:pPr indent="0" marL="0">
+                      <a:pPr algn="r" indent="0" marL="0">
                         <a:buNone/>
                       </a:pPr>
                       <a:r>
-                        <a:rPr lang="en-US" sz="1100" dirty="0">
+                        <a:rPr lang="en-US" sz="1200" dirty="0">
                           <a:solidFill>
                             <a:srgbClr val="1F2A36"/>
                           </a:solidFill>
@@ -7741,9 +7984,139 @@
                           <a:ea typeface="Calibri" pitchFamily="34" charset="-122"/>
                           <a:cs typeface="Calibri" pitchFamily="34" charset="-120"/>
                         </a:rPr>
-                        <a:t>Petro Star</a:t>
+                        <a:t>16,4 d</a:t>
                       </a:r>
-                      <a:endParaRPr lang="en-US" sz="1100" dirty="0">
+                      <a:endParaRPr lang="en-US" sz="1200" dirty="0">
+                        <a:latin typeface="Calibri" charset="0"/>
+                        <a:ea typeface="Calibri" charset="0"/>
+                        <a:cs typeface="Calibri" charset="0"/>
+                      </a:endParaRPr>
+                    </a:p>
+                  </a:txBody>
+                  <a:tcPr marL="91440" marR="91440" marT="45720" marB="45720" anchor="ctr">
+                    <a:lnL w="6350" cap="flat" cmpd="sng" algn="ctr">
+                      <a:solidFill>
+                        <a:srgbClr val="D5DBE1"/>
+                      </a:solidFill>
+                      <a:prstDash val="solid"/>
+                      <a:round/>
+                      <a:headEnd type="none" w="med" len="med"/>
+                      <a:tailEnd type="none" w="med" len="med"/>
+                    </a:lnL>
+                    <a:lnR w="6350" cap="flat" cmpd="sng" algn="ctr">
+                      <a:solidFill>
+                        <a:srgbClr val="D5DBE1"/>
+                      </a:solidFill>
+                      <a:prstDash val="solid"/>
+                      <a:round/>
+                      <a:headEnd type="none" w="med" len="med"/>
+                      <a:tailEnd type="none" w="med" len="med"/>
+                    </a:lnR>
+                    <a:lnT w="6350" cap="flat" cmpd="sng" algn="ctr">
+                      <a:solidFill>
+                        <a:srgbClr val="D5DBE1"/>
+                      </a:solidFill>
+                      <a:prstDash val="solid"/>
+                      <a:round/>
+                      <a:headEnd type="none" w="med" len="med"/>
+                      <a:tailEnd type="none" w="med" len="med"/>
+                    </a:lnT>
+                    <a:lnB w="6350" cap="flat" cmpd="sng" algn="ctr">
+                      <a:solidFill>
+                        <a:srgbClr val="D5DBE1"/>
+                      </a:solidFill>
+                      <a:prstDash val="solid"/>
+                      <a:round/>
+                      <a:headEnd type="none" w="med" len="med"/>
+                      <a:tailEnd type="none" w="med" len="med"/>
+                    </a:lnB>
+                  </a:tcPr>
+                </a:tc>
+                <a:tc>
+                  <a:txBody>
+                    <a:bodyPr/>
+                    <a:lstStyle/>
+                    <a:p>
+                      <a:pPr algn="r" indent="0" marL="0">
+                        <a:buNone/>
+                      </a:pPr>
+                      <a:r>
+                        <a:rPr lang="en-US" sz="1200" dirty="0">
+                          <a:solidFill>
+                            <a:srgbClr val="1F2A36"/>
+                          </a:solidFill>
+                          <a:latin typeface="Calibri" pitchFamily="34" charset="0"/>
+                          <a:ea typeface="Calibri" pitchFamily="34" charset="-122"/>
+                          <a:cs typeface="Calibri" pitchFamily="34" charset="-120"/>
+                        </a:rPr>
+                        <a:t>16,0 d</a:t>
+                      </a:r>
+                      <a:endParaRPr lang="en-US" sz="1200" dirty="0">
+                        <a:latin typeface="Calibri" charset="0"/>
+                        <a:ea typeface="Calibri" charset="0"/>
+                        <a:cs typeface="Calibri" charset="0"/>
+                      </a:endParaRPr>
+                    </a:p>
+                  </a:txBody>
+                  <a:tcPr marL="91440" marR="91440" marT="45720" marB="45720" anchor="ctr">
+                    <a:lnL w="6350" cap="flat" cmpd="sng" algn="ctr">
+                      <a:solidFill>
+                        <a:srgbClr val="D5DBE1"/>
+                      </a:solidFill>
+                      <a:prstDash val="solid"/>
+                      <a:round/>
+                      <a:headEnd type="none" w="med" len="med"/>
+                      <a:tailEnd type="none" w="med" len="med"/>
+                    </a:lnL>
+                    <a:lnR w="6350" cap="flat" cmpd="sng" algn="ctr">
+                      <a:solidFill>
+                        <a:srgbClr val="D5DBE1"/>
+                      </a:solidFill>
+                      <a:prstDash val="solid"/>
+                      <a:round/>
+                      <a:headEnd type="none" w="med" len="med"/>
+                      <a:tailEnd type="none" w="med" len="med"/>
+                    </a:lnR>
+                    <a:lnT w="6350" cap="flat" cmpd="sng" algn="ctr">
+                      <a:solidFill>
+                        <a:srgbClr val="D5DBE1"/>
+                      </a:solidFill>
+                      <a:prstDash val="solid"/>
+                      <a:round/>
+                      <a:headEnd type="none" w="med" len="med"/>
+                      <a:tailEnd type="none" w="med" len="med"/>
+                    </a:lnT>
+                    <a:lnB w="6350" cap="flat" cmpd="sng" algn="ctr">
+                      <a:solidFill>
+                        <a:srgbClr val="D5DBE1"/>
+                      </a:solidFill>
+                      <a:prstDash val="solid"/>
+                      <a:round/>
+                      <a:headEnd type="none" w="med" len="med"/>
+                      <a:tailEnd type="none" w="med" len="med"/>
+                    </a:lnB>
+                  </a:tcPr>
+                </a:tc>
+                <a:tc>
+                  <a:txBody>
+                    <a:bodyPr/>
+                    <a:lstStyle/>
+                    <a:p>
+                      <a:pPr algn="r" indent="0" marL="0">
+                        <a:buNone/>
+                      </a:pPr>
+                      <a:r>
+                        <a:rPr lang="en-US" sz="1200" dirty="0">
+                          <a:solidFill>
+                            <a:srgbClr val="1F2A36"/>
+                          </a:solidFill>
+                          <a:latin typeface="Calibri" pitchFamily="34" charset="0"/>
+                          <a:ea typeface="Calibri" pitchFamily="34" charset="-122"/>
+                          <a:cs typeface="Calibri" pitchFamily="34" charset="-120"/>
+                        </a:rPr>
+                        <a:t>18,2 d</a:t>
+                      </a:r>
+                      <a:endParaRPr lang="en-US" sz="1200" dirty="0">
                         <a:latin typeface="Calibri" charset="0"/>
                         <a:ea typeface="Calibri" charset="0"/>
                         <a:cs typeface="Calibri" charset="0"/>
@@ -7800,7 +8173,7 @@
                         <a:buNone/>
                       </a:pPr>
                       <a:r>
-                        <a:rPr lang="en-US" sz="1100" dirty="0">
+                        <a:rPr lang="en-US" sz="1200" dirty="0">
                           <a:solidFill>
                             <a:srgbClr val="1F2A36"/>
                           </a:solidFill>
@@ -7808,74 +8181,9 @@
                           <a:ea typeface="Calibri" pitchFamily="34" charset="-122"/>
                           <a:cs typeface="Calibri" pitchFamily="34" charset="-120"/>
                         </a:rPr>
-                        <a:t>Tiempo perdido en perforación (NPT) (baja la frecuencia)</a:t>
+                        <a:t>Meses bloqueados con contrato vigente</a:t>
                       </a:r>
-                      <a:endParaRPr lang="en-US" sz="1100" dirty="0">
-                        <a:latin typeface="Calibri" charset="0"/>
-                        <a:ea typeface="Calibri" charset="0"/>
-                        <a:cs typeface="Calibri" charset="0"/>
-                      </a:endParaRPr>
-                    </a:p>
-                  </a:txBody>
-                  <a:tcPr marL="91440" marR="91440" marT="45720" marB="45720" anchor="ctr">
-                    <a:lnL w="6350" cap="flat" cmpd="sng" algn="ctr">
-                      <a:solidFill>
-                        <a:srgbClr val="D5DBE1"/>
-                      </a:solidFill>
-                      <a:prstDash val="solid"/>
-                      <a:round/>
-                      <a:headEnd type="none" w="med" len="med"/>
-                      <a:tailEnd type="none" w="med" len="med"/>
-                    </a:lnL>
-                    <a:lnR w="6350" cap="flat" cmpd="sng" algn="ctr">
-                      <a:solidFill>
-                        <a:srgbClr val="D5DBE1"/>
-                      </a:solidFill>
-                      <a:prstDash val="solid"/>
-                      <a:round/>
-                      <a:headEnd type="none" w="med" len="med"/>
-                      <a:tailEnd type="none" w="med" len="med"/>
-                    </a:lnR>
-                    <a:lnT w="6350" cap="flat" cmpd="sng" algn="ctr">
-                      <a:solidFill>
-                        <a:srgbClr val="D5DBE1"/>
-                      </a:solidFill>
-                      <a:prstDash val="solid"/>
-                      <a:round/>
-                      <a:headEnd type="none" w="med" len="med"/>
-                      <a:tailEnd type="none" w="med" len="med"/>
-                    </a:lnT>
-                    <a:lnB w="6350" cap="flat" cmpd="sng" algn="ctr">
-                      <a:solidFill>
-                        <a:srgbClr val="D5DBE1"/>
-                      </a:solidFill>
-                      <a:prstDash val="solid"/>
-                      <a:round/>
-                      <a:headEnd type="none" w="med" len="med"/>
-                      <a:tailEnd type="none" w="med" len="med"/>
-                    </a:lnB>
-                  </a:tcPr>
-                </a:tc>
-                <a:tc>
-                  <a:txBody>
-                    <a:bodyPr/>
-                    <a:lstStyle/>
-                    <a:p>
-                      <a:pPr indent="0" marL="0">
-                        <a:buNone/>
-                      </a:pPr>
-                      <a:r>
-                        <a:rPr lang="en-US" sz="1100" dirty="0">
-                          <a:solidFill>
-                            <a:srgbClr val="1F2A36"/>
-                          </a:solidFill>
-                          <a:latin typeface="Calibri" pitchFamily="34" charset="0"/>
-                          <a:ea typeface="Calibri" pitchFamily="34" charset="-122"/>
-                          <a:cs typeface="Calibri" pitchFamily="34" charset="-120"/>
-                        </a:rPr>
-                        <a:t>0 %</a:t>
-                      </a:r>
-                      <a:endParaRPr lang="en-US" sz="1100" dirty="0">
+                      <a:endParaRPr lang="en-US" sz="1200" dirty="0">
                         <a:latin typeface="Calibri" charset="0"/>
                         <a:ea typeface="Calibri" charset="0"/>
                         <a:cs typeface="Calibri" charset="0"/>
@@ -7930,72 +8238,7 @@
                         <a:buNone/>
                       </a:pPr>
                       <a:r>
-                        <a:rPr lang="en-US" sz="1100" dirty="0">
-                          <a:solidFill>
-                            <a:srgbClr val="B03A2E"/>
-                          </a:solidFill>
-                          <a:latin typeface="Calibri" pitchFamily="34" charset="0"/>
-                          <a:ea typeface="Calibri" pitchFamily="34" charset="-122"/>
-                          <a:cs typeface="Calibri" pitchFamily="34" charset="-120"/>
-                        </a:rPr>
-                        <a:t>−0,24 M con 20 %</a:t>
-                      </a:r>
-                      <a:endParaRPr lang="en-US" sz="1100" dirty="0">
-                        <a:latin typeface="Calibri" charset="0"/>
-                        <a:ea typeface="Calibri" charset="0"/>
-                        <a:cs typeface="Calibri" charset="0"/>
-                      </a:endParaRPr>
-                    </a:p>
-                  </a:txBody>
-                  <a:tcPr marL="91440" marR="91440" marT="45720" marB="45720" anchor="ctr">
-                    <a:lnL w="6350" cap="flat" cmpd="sng" algn="ctr">
-                      <a:solidFill>
-                        <a:srgbClr val="D5DBE1"/>
-                      </a:solidFill>
-                      <a:prstDash val="solid"/>
-                      <a:round/>
-                      <a:headEnd type="none" w="med" len="med"/>
-                      <a:tailEnd type="none" w="med" len="med"/>
-                    </a:lnL>
-                    <a:lnR w="6350" cap="flat" cmpd="sng" algn="ctr">
-                      <a:solidFill>
-                        <a:srgbClr val="D5DBE1"/>
-                      </a:solidFill>
-                      <a:prstDash val="solid"/>
-                      <a:round/>
-                      <a:headEnd type="none" w="med" len="med"/>
-                      <a:tailEnd type="none" w="med" len="med"/>
-                    </a:lnR>
-                    <a:lnT w="6350" cap="flat" cmpd="sng" algn="ctr">
-                      <a:solidFill>
-                        <a:srgbClr val="D5DBE1"/>
-                      </a:solidFill>
-                      <a:prstDash val="solid"/>
-                      <a:round/>
-                      <a:headEnd type="none" w="med" len="med"/>
-                      <a:tailEnd type="none" w="med" len="med"/>
-                    </a:lnT>
-                    <a:lnB w="6350" cap="flat" cmpd="sng" algn="ctr">
-                      <a:solidFill>
-                        <a:srgbClr val="D5DBE1"/>
-                      </a:solidFill>
-                      <a:prstDash val="solid"/>
-                      <a:round/>
-                      <a:headEnd type="none" w="med" len="med"/>
-                      <a:tailEnd type="none" w="med" len="med"/>
-                    </a:lnB>
-                  </a:tcPr>
-                </a:tc>
-                <a:tc>
-                  <a:txBody>
-                    <a:bodyPr/>
-                    <a:lstStyle/>
-                    <a:p>
-                      <a:pPr indent="0" marL="0">
-                        <a:buNone/>
-                      </a:pPr>
-                      <a:r>
-                        <a:rPr lang="en-US" sz="1100" dirty="0">
+                        <a:rPr lang="en-US" sz="1200" dirty="0">
                           <a:solidFill>
                             <a:srgbClr val="1F2A36"/>
                           </a:solidFill>
@@ -8003,141 +8246,9 @@
                           <a:ea typeface="Calibri" pitchFamily="34" charset="-122"/>
                           <a:cs typeface="Calibri" pitchFamily="34" charset="-120"/>
                         </a:rPr>
-                        <a:t>SierraCol</a:t>
+                        <a:t>1,2</a:t>
                       </a:r>
-                      <a:endParaRPr lang="en-US" sz="1100" dirty="0">
-                        <a:latin typeface="Calibri" charset="0"/>
-                        <a:ea typeface="Calibri" charset="0"/>
-                        <a:cs typeface="Calibri" charset="0"/>
-                      </a:endParaRPr>
-                    </a:p>
-                  </a:txBody>
-                  <a:tcPr marL="91440" marR="91440" marT="45720" marB="45720" anchor="ctr">
-                    <a:lnL w="6350" cap="flat" cmpd="sng" algn="ctr">
-                      <a:solidFill>
-                        <a:srgbClr val="D5DBE1"/>
-                      </a:solidFill>
-                      <a:prstDash val="solid"/>
-                      <a:round/>
-                      <a:headEnd type="none" w="med" len="med"/>
-                      <a:tailEnd type="none" w="med" len="med"/>
-                    </a:lnL>
-                    <a:lnR w="6350" cap="flat" cmpd="sng" algn="ctr">
-                      <a:solidFill>
-                        <a:srgbClr val="D5DBE1"/>
-                      </a:solidFill>
-                      <a:prstDash val="solid"/>
-                      <a:round/>
-                      <a:headEnd type="none" w="med" len="med"/>
-                      <a:tailEnd type="none" w="med" len="med"/>
-                    </a:lnR>
-                    <a:lnT w="6350" cap="flat" cmpd="sng" algn="ctr">
-                      <a:solidFill>
-                        <a:srgbClr val="D5DBE1"/>
-                      </a:solidFill>
-                      <a:prstDash val="solid"/>
-                      <a:round/>
-                      <a:headEnd type="none" w="med" len="med"/>
-                      <a:tailEnd type="none" w="med" len="med"/>
-                    </a:lnT>
-                    <a:lnB w="6350" cap="flat" cmpd="sng" algn="ctr">
-                      <a:solidFill>
-                        <a:srgbClr val="D5DBE1"/>
-                      </a:solidFill>
-                      <a:prstDash val="solid"/>
-                      <a:round/>
-                      <a:headEnd type="none" w="med" len="med"/>
-                      <a:tailEnd type="none" w="med" len="med"/>
-                    </a:lnB>
-                  </a:tcPr>
-                </a:tc>
-              </a:tr>
-              <a:tr h="384048">
-                <a:tc>
-                  <a:txBody>
-                    <a:bodyPr/>
-                    <a:lstStyle/>
-                    <a:p>
-                      <a:pPr indent="0" marL="0">
-                        <a:buNone/>
-                      </a:pPr>
-                      <a:r>
-                        <a:rPr lang="en-US" sz="1100" dirty="0">
-                          <a:solidFill>
-                            <a:srgbClr val="1F2A36"/>
-                          </a:solidFill>
-                          <a:latin typeface="Calibri" pitchFamily="34" charset="0"/>
-                          <a:ea typeface="Calibri" pitchFamily="34" charset="-122"/>
-                          <a:cs typeface="Calibri" pitchFamily="34" charset="-120"/>
-                        </a:rPr>
-                        <a:t>Lump Sum: valores del Excel vs cotización 1255</a:t>
-                      </a:r>
-                      <a:endParaRPr lang="en-US" sz="1100" dirty="0">
-                        <a:latin typeface="Calibri" charset="0"/>
-                        <a:ea typeface="Calibri" charset="0"/>
-                        <a:cs typeface="Calibri" charset="0"/>
-                      </a:endParaRPr>
-                    </a:p>
-                  </a:txBody>
-                  <a:tcPr marL="91440" marR="91440" marT="45720" marB="45720" anchor="ctr">
-                    <a:lnL w="6350" cap="flat" cmpd="sng" algn="ctr">
-                      <a:solidFill>
-                        <a:srgbClr val="D5DBE1"/>
-                      </a:solidFill>
-                      <a:prstDash val="solid"/>
-                      <a:round/>
-                      <a:headEnd type="none" w="med" len="med"/>
-                      <a:tailEnd type="none" w="med" len="med"/>
-                    </a:lnL>
-                    <a:lnR w="6350" cap="flat" cmpd="sng" algn="ctr">
-                      <a:solidFill>
-                        <a:srgbClr val="D5DBE1"/>
-                      </a:solidFill>
-                      <a:prstDash val="solid"/>
-                      <a:round/>
-                      <a:headEnd type="none" w="med" len="med"/>
-                      <a:tailEnd type="none" w="med" len="med"/>
-                    </a:lnR>
-                    <a:lnT w="6350" cap="flat" cmpd="sng" algn="ctr">
-                      <a:solidFill>
-                        <a:srgbClr val="D5DBE1"/>
-                      </a:solidFill>
-                      <a:prstDash val="solid"/>
-                      <a:round/>
-                      <a:headEnd type="none" w="med" len="med"/>
-                      <a:tailEnd type="none" w="med" len="med"/>
-                    </a:lnT>
-                    <a:lnB w="6350" cap="flat" cmpd="sng" algn="ctr">
-                      <a:solidFill>
-                        <a:srgbClr val="D5DBE1"/>
-                      </a:solidFill>
-                      <a:prstDash val="solid"/>
-                      <a:round/>
-                      <a:headEnd type="none" w="med" len="med"/>
-                      <a:tailEnd type="none" w="med" len="med"/>
-                    </a:lnB>
-                  </a:tcPr>
-                </a:tc>
-                <a:tc>
-                  <a:txBody>
-                    <a:bodyPr/>
-                    <a:lstStyle/>
-                    <a:p>
-                      <a:pPr indent="0" marL="0">
-                        <a:buNone/>
-                      </a:pPr>
-                      <a:r>
-                        <a:rPr lang="en-US" sz="1100" dirty="0">
-                          <a:solidFill>
-                            <a:srgbClr val="1F2A36"/>
-                          </a:solidFill>
-                          <a:latin typeface="Calibri" pitchFamily="34" charset="0"/>
-                          <a:ea typeface="Calibri" pitchFamily="34" charset="-122"/>
-                          <a:cs typeface="Calibri" pitchFamily="34" charset="-120"/>
-                        </a:rPr>
-                        <a:t>Excel</a:t>
-                      </a:r>
-                      <a:endParaRPr lang="en-US" sz="1100" dirty="0">
+                      <a:endParaRPr lang="en-US" sz="1200" dirty="0">
                         <a:latin typeface="Calibri" charset="0"/>
                         <a:ea typeface="Calibri" charset="0"/>
                         <a:cs typeface="Calibri" charset="0"/>
@@ -8192,72 +8303,7 @@
                         <a:buNone/>
                       </a:pPr>
                       <a:r>
-                        <a:rPr lang="en-US" sz="1100" dirty="0">
-                          <a:solidFill>
-                            <a:srgbClr val="2E7D5B"/>
-                          </a:solidFill>
-                          <a:latin typeface="Calibri" pitchFamily="34" charset="0"/>
-                          <a:ea typeface="Calibri" pitchFamily="34" charset="-122"/>
-                          <a:cs typeface="Calibri" pitchFamily="34" charset="-120"/>
-                        </a:rPr>
-                        <a:t>+0,44 M</a:t>
-                      </a:r>
-                      <a:endParaRPr lang="en-US" sz="1100" dirty="0">
-                        <a:latin typeface="Calibri" charset="0"/>
-                        <a:ea typeface="Calibri" charset="0"/>
-                        <a:cs typeface="Calibri" charset="0"/>
-                      </a:endParaRPr>
-                    </a:p>
-                  </a:txBody>
-                  <a:tcPr marL="91440" marR="91440" marT="45720" marB="45720" anchor="ctr">
-                    <a:lnL w="6350" cap="flat" cmpd="sng" algn="ctr">
-                      <a:solidFill>
-                        <a:srgbClr val="D5DBE1"/>
-                      </a:solidFill>
-                      <a:prstDash val="solid"/>
-                      <a:round/>
-                      <a:headEnd type="none" w="med" len="med"/>
-                      <a:tailEnd type="none" w="med" len="med"/>
-                    </a:lnL>
-                    <a:lnR w="6350" cap="flat" cmpd="sng" algn="ctr">
-                      <a:solidFill>
-                        <a:srgbClr val="D5DBE1"/>
-                      </a:solidFill>
-                      <a:prstDash val="solid"/>
-                      <a:round/>
-                      <a:headEnd type="none" w="med" len="med"/>
-                      <a:tailEnd type="none" w="med" len="med"/>
-                    </a:lnR>
-                    <a:lnT w="6350" cap="flat" cmpd="sng" algn="ctr">
-                      <a:solidFill>
-                        <a:srgbClr val="D5DBE1"/>
-                      </a:solidFill>
-                      <a:prstDash val="solid"/>
-                      <a:round/>
-                      <a:headEnd type="none" w="med" len="med"/>
-                      <a:tailEnd type="none" w="med" len="med"/>
-                    </a:lnT>
-                    <a:lnB w="6350" cap="flat" cmpd="sng" algn="ctr">
-                      <a:solidFill>
-                        <a:srgbClr val="D5DBE1"/>
-                      </a:solidFill>
-                      <a:prstDash val="solid"/>
-                      <a:round/>
-                      <a:headEnd type="none" w="med" len="med"/>
-                      <a:tailEnd type="none" w="med" len="med"/>
-                    </a:lnB>
-                  </a:tcPr>
-                </a:tc>
-                <a:tc>
-                  <a:txBody>
-                    <a:bodyPr/>
-                    <a:lstStyle/>
-                    <a:p>
-                      <a:pPr indent="0" marL="0">
-                        <a:buNone/>
-                      </a:pPr>
-                      <a:r>
-                        <a:rPr lang="en-US" sz="1100" dirty="0">
+                        <a:rPr lang="en-US" sz="1200" dirty="0">
                           <a:solidFill>
                             <a:srgbClr val="1F2A36"/>
                           </a:solidFill>
@@ -8265,141 +8311,9 @@
                           <a:ea typeface="Calibri" pitchFamily="34" charset="-122"/>
                           <a:cs typeface="Calibri" pitchFamily="34" charset="-120"/>
                         </a:rPr>
-                        <a:t>SCM</a:t>
+                        <a:t>3,6</a:t>
                       </a:r>
-                      <a:endParaRPr lang="en-US" sz="1100" dirty="0">
-                        <a:latin typeface="Calibri" charset="0"/>
-                        <a:ea typeface="Calibri" charset="0"/>
-                        <a:cs typeface="Calibri" charset="0"/>
-                      </a:endParaRPr>
-                    </a:p>
-                  </a:txBody>
-                  <a:tcPr marL="91440" marR="91440" marT="45720" marB="45720" anchor="ctr">
-                    <a:lnL w="6350" cap="flat" cmpd="sng" algn="ctr">
-                      <a:solidFill>
-                        <a:srgbClr val="D5DBE1"/>
-                      </a:solidFill>
-                      <a:prstDash val="solid"/>
-                      <a:round/>
-                      <a:headEnd type="none" w="med" len="med"/>
-                      <a:tailEnd type="none" w="med" len="med"/>
-                    </a:lnL>
-                    <a:lnR w="6350" cap="flat" cmpd="sng" algn="ctr">
-                      <a:solidFill>
-                        <a:srgbClr val="D5DBE1"/>
-                      </a:solidFill>
-                      <a:prstDash val="solid"/>
-                      <a:round/>
-                      <a:headEnd type="none" w="med" len="med"/>
-                      <a:tailEnd type="none" w="med" len="med"/>
-                    </a:lnR>
-                    <a:lnT w="6350" cap="flat" cmpd="sng" algn="ctr">
-                      <a:solidFill>
-                        <a:srgbClr val="D5DBE1"/>
-                      </a:solidFill>
-                      <a:prstDash val="solid"/>
-                      <a:round/>
-                      <a:headEnd type="none" w="med" len="med"/>
-                      <a:tailEnd type="none" w="med" len="med"/>
-                    </a:lnT>
-                    <a:lnB w="6350" cap="flat" cmpd="sng" algn="ctr">
-                      <a:solidFill>
-                        <a:srgbClr val="D5DBE1"/>
-                      </a:solidFill>
-                      <a:prstDash val="solid"/>
-                      <a:round/>
-                      <a:headEnd type="none" w="med" len="med"/>
-                      <a:tailEnd type="none" w="med" len="med"/>
-                    </a:lnB>
-                  </a:tcPr>
-                </a:tc>
-              </a:tr>
-              <a:tr h="384048">
-                <a:tc>
-                  <a:txBody>
-                    <a:bodyPr/>
-                    <a:lstStyle/>
-                    <a:p>
-                      <a:pPr indent="0" marL="0">
-                        <a:buNone/>
-                      </a:pPr>
-                      <a:r>
-                        <a:rPr lang="en-US" sz="1100" dirty="0">
-                          <a:solidFill>
-                            <a:srgbClr val="1F2A36"/>
-                          </a:solidFill>
-                          <a:latin typeface="Calibri" pitchFamily="34" charset="0"/>
-                          <a:ea typeface="Calibri" pitchFamily="34" charset="-122"/>
-                          <a:cs typeface="Calibri" pitchFamily="34" charset="-120"/>
-                        </a:rPr>
-                        <a:t>Riesgos no cuantificados: coordinación taladro–transportador, HSE y daños, disponibilidad, plazo y salida, pago en COP</a:t>
-                      </a:r>
-                      <a:endParaRPr lang="en-US" sz="1100" dirty="0">
-                        <a:latin typeface="Calibri" charset="0"/>
-                        <a:ea typeface="Calibri" charset="0"/>
-                        <a:cs typeface="Calibri" charset="0"/>
-                      </a:endParaRPr>
-                    </a:p>
-                  </a:txBody>
-                  <a:tcPr marL="91440" marR="91440" marT="45720" marB="45720" anchor="ctr">
-                    <a:lnL w="6350" cap="flat" cmpd="sng" algn="ctr">
-                      <a:solidFill>
-                        <a:srgbClr val="D5DBE1"/>
-                      </a:solidFill>
-                      <a:prstDash val="solid"/>
-                      <a:round/>
-                      <a:headEnd type="none" w="med" len="med"/>
-                      <a:tailEnd type="none" w="med" len="med"/>
-                    </a:lnL>
-                    <a:lnR w="6350" cap="flat" cmpd="sng" algn="ctr">
-                      <a:solidFill>
-                        <a:srgbClr val="D5DBE1"/>
-                      </a:solidFill>
-                      <a:prstDash val="solid"/>
-                      <a:round/>
-                      <a:headEnd type="none" w="med" len="med"/>
-                      <a:tailEnd type="none" w="med" len="med"/>
-                    </a:lnR>
-                    <a:lnT w="6350" cap="flat" cmpd="sng" algn="ctr">
-                      <a:solidFill>
-                        <a:srgbClr val="D5DBE1"/>
-                      </a:solidFill>
-                      <a:prstDash val="solid"/>
-                      <a:round/>
-                      <a:headEnd type="none" w="med" len="med"/>
-                      <a:tailEnd type="none" w="med" len="med"/>
-                    </a:lnT>
-                    <a:lnB w="6350" cap="flat" cmpd="sng" algn="ctr">
-                      <a:solidFill>
-                        <a:srgbClr val="D5DBE1"/>
-                      </a:solidFill>
-                      <a:prstDash val="solid"/>
-                      <a:round/>
-                      <a:headEnd type="none" w="med" len="med"/>
-                      <a:tailEnd type="none" w="med" len="med"/>
-                    </a:lnB>
-                  </a:tcPr>
-                </a:tc>
-                <a:tc>
-                  <a:txBody>
-                    <a:bodyPr/>
-                    <a:lstStyle/>
-                    <a:p>
-                      <a:pPr indent="0" marL="0">
-                        <a:buNone/>
-                      </a:pPr>
-                      <a:r>
-                        <a:rPr lang="en-US" sz="1100" dirty="0">
-                          <a:solidFill>
-                            <a:srgbClr val="1F2A36"/>
-                          </a:solidFill>
-                          <a:latin typeface="Calibri" pitchFamily="34" charset="0"/>
-                          <a:ea typeface="Calibri" pitchFamily="34" charset="-122"/>
-                          <a:cs typeface="Calibri" pitchFamily="34" charset="-120"/>
-                        </a:rPr>
-                        <a:t>Sin valorar</a:t>
-                      </a:r>
-                      <a:endParaRPr lang="en-US" sz="1100" dirty="0">
+                      <a:endParaRPr lang="en-US" sz="1200" dirty="0">
                         <a:latin typeface="Calibri" charset="0"/>
                         <a:ea typeface="Calibri" charset="0"/>
                         <a:cs typeface="Calibri" charset="0"/>
@@ -8454,17 +8368,17 @@
                         <a:buNone/>
                       </a:pPr>
                       <a:r>
-                        <a:rPr lang="en-US" sz="1100" dirty="0">
+                        <a:rPr lang="en-US" sz="1200" dirty="0">
                           <a:solidFill>
-                            <a:srgbClr val="B03A2E"/>
+                            <a:srgbClr val="1F2A36"/>
                           </a:solidFill>
                           <a:latin typeface="Calibri" pitchFamily="34" charset="0"/>
                           <a:ea typeface="Calibri" pitchFamily="34" charset="-122"/>
                           <a:cs typeface="Calibri" pitchFamily="34" charset="-120"/>
                         </a:rPr>
-                        <a:t>No cuantificado</a:t>
+                        <a:t>2,5</a:t>
                       </a:r>
-                      <a:endParaRPr lang="en-US" sz="1100" dirty="0">
+                      <a:endParaRPr lang="en-US" sz="1200" dirty="0">
                         <a:latin typeface="Calibri" charset="0"/>
                         <a:ea typeface="Calibri" charset="0"/>
                         <a:cs typeface="Calibri" charset="0"/>
@@ -8515,11 +8429,11 @@
                     <a:bodyPr/>
                     <a:lstStyle/>
                     <a:p>
-                      <a:pPr indent="0" marL="0">
+                      <a:pPr algn="r" indent="0" marL="0">
                         <a:buNone/>
                       </a:pPr>
                       <a:r>
-                        <a:rPr lang="en-US" sz="1100" dirty="0">
+                        <a:rPr lang="en-US" sz="1200" dirty="0">
                           <a:solidFill>
                             <a:srgbClr val="1F2A36"/>
                           </a:solidFill>
@@ -8527,9 +8441,9 @@
                           <a:ea typeface="Calibri" pitchFamily="34" charset="-122"/>
                           <a:cs typeface="Calibri" pitchFamily="34" charset="-120"/>
                         </a:rPr>
-                        <a:t>Contratos / HSE</a:t>
+                        <a:t>2,8</a:t>
                       </a:r>
-                      <a:endParaRPr lang="en-US" sz="1100" dirty="0">
+                      <a:endParaRPr lang="en-US" sz="1200" dirty="0">
                         <a:latin typeface="Calibri" charset="0"/>
                         <a:ea typeface="Calibri" charset="0"/>
                         <a:cs typeface="Calibri" charset="0"/>
@@ -8582,14 +8496,61 @@
       </p:graphicFrame>
       <p:sp>
         <p:nvSpPr>
-          <p:cNvPr id="4" name="card6"/>
+          <p:cNvPr id="4" name="Text 1"/>
+          <p:cNvSpPr txBox="1"/>
+          <p:nvPr/>
+        </p:nvSpPr>
+        <p:spPr>
+          <a:xfrm>
+            <a:off x="548640" y="4160520"/>
+            <a:ext cx="7315200" cy="1005840"/>
+          </a:xfrm>
+          <a:prstGeom prst="rect">
+            <a:avLst/>
+          </a:prstGeom>
+          <a:noFill/>
+          <a:ln/>
+        </p:spPr>
+        <p:txBody>
+          <a:bodyPr wrap="square" lIns="0" tIns="0" rIns="0" bIns="0" rtlCol="0" anchor="t"/>
+          <a:lstStyle/>
+          <a:p>
+            <a:pPr indent="0" marL="0">
+              <a:buNone/>
+            </a:pPr>
+            <a:r>
+              <a:rPr lang="en-US" sz="1200" b="1" dirty="0">
+                <a:solidFill>
+                  <a:schemeClr val="tx2"/>
+                </a:solidFill>
+              </a:rPr>
+              <a:t>Por qué: </a:t>
+            </a:r>
+            <a:pPr indent="0" marL="0">
+              <a:buNone/>
+            </a:pPr>
+            <a:r>
+              <a:rPr lang="en-US" sz="1200" dirty="0">
+                <a:solidFill>
+                  <a:schemeClr val="tx2"/>
+                </a:solidFill>
+              </a:rPr>
+              <a:t>en el Work Order una demora o un mes sin mover no cuesta nada. En el tercerizado cada hora sobre el tiempo cotizado cuesta unos 2.813 USD (taladro 1.456 + equipos y señalizadores 1.357) y un mes bloqueado paga el cargo fijo completo (Petro Star 161 k, Ecotransur 226 k).</a:t>
+            </a:r>
+            <a:endParaRPr lang="en-US" sz="1200" dirty="0"/>
+          </a:p>
+        </p:txBody>
+      </p:sp>
+      <p:sp>
+        <p:nvSpPr>
+          <p:cNvPr id="5" name="card6"/>
           <p:cNvSpPr/>
           <p:nvPr/>
         </p:nvSpPr>
         <p:spPr>
           <a:xfrm>
             <a:off x="8229600" y="1280160"/>
-            <a:ext cx="3383280" cy="3749040"/>
+            <a:ext cx="3383280" cy="3931920"/>
           </a:xfrm>
           <a:prstGeom prst="roundRect">
             <a:avLst>
@@ -8609,14 +8570,14 @@
       </p:sp>
       <p:sp>
         <p:nvSpPr>
-          <p:cNvPr id="5" name="Text 2"/>
+          <p:cNvPr id="6" name="Text 3"/>
           <p:cNvSpPr txBox="1"/>
           <p:nvPr/>
         </p:nvSpPr>
         <p:spPr>
           <a:xfrm>
             <a:off x="8412480" y="1463040"/>
-            <a:ext cx="3017520" cy="3474720"/>
+            <a:ext cx="3017520" cy="3657600"/>
           </a:xfrm>
           <a:prstGeom prst="rect">
             <a:avLst/>
@@ -8640,23 +8601,78 @@
                   <a:schemeClr val="accent1"/>
                 </a:solidFill>
               </a:rPr>
-              <a:t>Lectura</a:t>
+              <a:t>Falta confirmar</a:t>
             </a:r>
-            <a:endParaRPr lang="en-US" sz="1600" dirty="0"/>
+            <a:endParaRPr lang="en-US" sz="1200" dirty="0"/>
           </a:p>
           <a:p>
-            <a:pPr indent="0" marL="0">
-              <a:buNone/>
+            <a:pPr marL="342900" indent="-342900">
+              <a:spcAft>
+                <a:spcPts val="600"/>
+              </a:spcAft>
+              <a:buSzPct val="100000"/>
+              <a:buChar char="•"/>
             </a:pPr>
             <a:r>
-              <a:rPr lang="en-US" sz="1300" dirty="0">
+              <a:rPr lang="en-US" sz="1200" dirty="0">
                 <a:solidFill>
                   <a:schemeClr val="bg1"/>
                 </a:solidFill>
               </a:rPr>
-              <a:t>Sesgo sistemático: casi todos los supuestos empujan hacia el tercerizado; las excepciones son los precios del Lump Sum (+0,44 M) y el cargo fijo de Petro Star con 5 movilizaciones (+0,08 M). Con la frecuencia y la mezcla de 2025 y las horas que cotizó Petro Star, el ahorro desaparece (Petro Star −0,02 M; Ecotransur −0,01 M). Antes de cambiar el contrato: confirmar la frecuencia mensual esperada, el rango real de los pozos y la exposición a la tasa de cambio (TRM ±10 % mueve ±0,3 M).</a:t>
+              <a:t>Tabla del Work Order por horas: hoy se compara contra la banda más lenta; si el contratista mueve rápido, el WO cuesta más (+5 % al WO ≈ +0,16 M a favor del tercerizado).</a:t>
             </a:r>
-            <a:endParaRPr lang="en-US" sz="1600" dirty="0"/>
+            <a:endParaRPr lang="en-US" sz="1200" dirty="0"/>
+          </a:p>
+          <a:p>
+            <a:pPr marL="342900" indent="-342900">
+              <a:spcAft>
+                <a:spcPts val="600"/>
+              </a:spcAft>
+              <a:buSzPct val="100000"/>
+              <a:buChar char="•"/>
+            </a:pPr>
+            <a:r>
+              <a:rPr lang="en-US" sz="1200" dirty="0">
+                <a:solidFill>
+                  <a:schemeClr val="bg1"/>
+                </a:solidFill>
+              </a:rPr>
+              <a:t>Horas que se pagarán al taladro: con las cotizadas (24 h en 0,1–5 km) el ahorro baja 0,17 M.</a:t>
+            </a:r>
+            <a:endParaRPr lang="en-US" sz="1200" dirty="0"/>
+          </a:p>
+          <a:p>
+            <a:pPr marL="342900" indent="-342900">
+              <a:spcAft>
+                <a:spcPts val="600"/>
+              </a:spcAft>
+              <a:buSzPct val="100000"/>
+              <a:buChar char="•"/>
+            </a:pPr>
+            <a:r>
+              <a:rPr lang="en-US" sz="1200" dirty="0">
+                <a:solidFill>
+                  <a:schemeClr val="bg1"/>
+                </a:solidFill>
+              </a:rPr>
+              <a:t>Precios del Lump Sum: el Excel está por encima de la cotización 1255 (+0,44 M).</a:t>
+            </a:r>
+            <a:endParaRPr lang="en-US" sz="1200" dirty="0"/>
+          </a:p>
+          <a:p>
+            <a:pPr marL="342900" indent="-342900">
+              <a:buSzPct val="100000"/>
+              <a:buChar char="•"/>
+            </a:pPr>
+            <a:r>
+              <a:rPr lang="en-US" sz="1200" dirty="0">
+                <a:solidFill>
+                  <a:schemeClr val="bg1"/>
+                </a:solidFill>
+              </a:rPr>
+              <a:t>Riesgos no valorados: coordinación de dos contratistas, HSE y daños, disponibilidad, pago en COP.</a:t>
+            </a:r>
+            <a:endParaRPr lang="en-US" sz="1200" dirty="0"/>
           </a:p>
         </p:txBody>
       </p:sp>

</xml_diff>

<commit_message>
Movilización: audit of SierraCol's own evaluation (v5), measured social-blockade hours added to engine and simulator, deck refresh
Co-Authored-By: Claude Opus 5.5 <noreply@anthropic.com>
Claude-Session: https://claude.ai/code/session_01BsMRKE8hArHddZxwmwcNWn
</commit_message>
<xml_diff>
--- a/movilizacion/entregables/Presentacion_Movilizacion_GRS110.pptx
+++ b/movilizacion/entregables/Presentacion_Movilizacion_GRS110.pptx
@@ -110,22 +110,22 @@
   <p:extLst>
     <p:ext uri="{521415D9-36F7-43E2-AB2F-B90AF26B5E84}">
       <p14:sectionLst xmlns:p14="http://schemas.microsoft.com/office/powerpoint/2010/main">
-        <p14:section name="Decisión" id="{c1eafc6c-2fbe-c2c4-0f8e-7e4542a9f3ba}">
+        <p14:section name="Decisión" id="{cf5aa66f-bb9f-e6b7-9f49-55eb3fdd67ef}">
           <p14:sldIdLst>
             <p14:sldId id="256"/>
           </p14:sldIdLst>
         </p14:section>
-        <p14:section name="Estructura de costo" id="{57cd9278-a18e-e4e5-3109-afe9e591052c}">
+        <p14:section name="Estructura de costo" id="{fed18006-a86b-04cc-7b5c-943aa119ced4}">
           <p14:sldIdLst>
             <p14:sldId id="257"/>
           </p14:sldIdLst>
         </p14:section>
-        <p14:section name="Frontera" id="{d9ba0ae3-c6c2-b0ce-a96a-cd6a38fa17c7}">
+        <p14:section name="Frontera" id="{03e042d4-8076-3333-4f00-08344c50575e}">
           <p14:sldIdLst>
             <p14:sldId id="258"/>
           </p14:sldIdLst>
         </p14:section>
-        <p14:section name="Pendientes" id="{1ff4f43f-eb30-3710-c101-2463e05d3c19}">
+        <p14:section name="Pendientes" id="{79cfa555-aad9-0fab-2a2e-45251ea4ef29}">
           <p14:sldIdLst>
             <p14:sldId id="259"/>
           </p14:sldIdLst>
@@ -1271,28 +1271,28 @@
                 <c:formatCode>General</c:formatCode>
                 <c:ptCount val="8"/>
                 <c:pt idx="0">
-                  <c:v>-35057.83378378302</c:v>
+                  <c:v>-83725.53918918828</c:v>
                 </c:pt>
                 <c:pt idx="1">
-                  <c:v>81238.02756756824</c:v>
+                  <c:v>32570.32216216298</c:v>
                 </c:pt>
                 <c:pt idx="2">
-                  <c:v>199754.31567567633</c:v>
+                  <c:v>151086.61027027108</c:v>
                 </c:pt>
                 <c:pt idx="3">
-                  <c:v>347086.30716216285</c:v>
+                  <c:v>298418.6017567576</c:v>
                 </c:pt>
                 <c:pt idx="4">
-                  <c:v>572946.5894594598</c:v>
+                  <c:v>524278.8840540545</c:v>
                 </c:pt>
                 <c:pt idx="5">
-                  <c:v>592957.5331081082</c:v>
+                  <c:v>544289.827702703</c:v>
                 </c:pt>
                 <c:pt idx="6">
-                  <c:v>730502.1668918924</c:v>
+                  <c:v>681834.4614864872</c:v>
                 </c:pt>
                 <c:pt idx="7">
-                  <c:v>731308.5840540547</c:v>
+                  <c:v>682640.8786486494</c:v>
                 </c:pt>
               </c:numCache>
             </c:numRef>
@@ -1409,28 +1409,28 @@
                 <c:formatCode>General</c:formatCode>
                 <c:ptCount val="8"/>
                 <c:pt idx="0">
-                  <c:v>105486.55675675627</c:v>
+                  <c:v>56818.85135135101</c:v>
                 </c:pt>
                 <c:pt idx="1">
-                  <c:v>331804.0797297298</c:v>
+                  <c:v>283136.37432432454</c:v>
                 </c:pt>
                 <c:pt idx="2">
-                  <c:v>558121.6027027033</c:v>
+                  <c:v>509453.89729729807</c:v>
                 </c:pt>
                 <c:pt idx="3">
-                  <c:v>472628.1175675681</c:v>
+                  <c:v>423960.41216216283</c:v>
                 </c:pt>
                 <c:pt idx="4">
-                  <c:v>635871.6054054066</c:v>
+                  <c:v>587203.9000000013</c:v>
                 </c:pt>
                 <c:pt idx="5">
-                  <c:v>572797.5702702715</c:v>
+                  <c:v>524129.86486486625</c:v>
                 </c:pt>
                 <c:pt idx="6">
-                  <c:v>695386.4729729742</c:v>
+                  <c:v>646718.7675675689</c:v>
                 </c:pt>
                 <c:pt idx="7">
-                  <c:v>668782.7081081085</c:v>
+                  <c:v>620115.0027027032</c:v>
                 </c:pt>
               </c:numCache>
             </c:numRef>
@@ -1547,28 +1547,28 @@
                 <c:formatCode>General</c:formatCode>
                 <c:ptCount val="8"/>
                 <c:pt idx="0">
-                  <c:v>-640006.1527027027</c:v>
+                  <c:v>-688673.8581081079</c:v>
                 </c:pt>
                 <c:pt idx="1">
-                  <c:v>-523710.2913513514</c:v>
+                  <c:v>-572377.9967567567</c:v>
                 </c:pt>
                 <c:pt idx="2">
-                  <c:v>-405194.0032432433</c:v>
+                  <c:v>-453861.7086486486</c:v>
                 </c:pt>
                 <c:pt idx="3">
-                  <c:v>-336523.04000000004</c:v>
+                  <c:v>-385190.7454054053</c:v>
                 </c:pt>
                 <c:pt idx="4">
-                  <c:v>-159478.77459459472</c:v>
+                  <c:v>-208146.47999999998</c:v>
                 </c:pt>
                 <c:pt idx="5">
-                  <c:v>-188283.84783783788</c:v>
+                  <c:v>-236951.55324324314</c:v>
                 </c:pt>
                 <c:pt idx="6">
-                  <c:v>-118526.23648648662</c:v>
+                  <c:v>-167193.94189189188</c:v>
                 </c:pt>
                 <c:pt idx="7">
-                  <c:v>-188283.84783783788</c:v>
+                  <c:v>-236951.55324324314</c:v>
                 </c:pt>
               </c:numCache>
             </c:numRef>
@@ -3209,7 +3209,7 @@
               <a:buNone/>
             </a:pPr>
             <a:r>
-              <a:rPr lang="en-US" sz="2600" b="1" dirty="0">
+              <a:rPr lang="en-US" sz="3600" b="1" dirty="0">
                 <a:solidFill>
                   <a:schemeClr val="accent4"/>
                 </a:solidFill>
@@ -3219,7 +3219,7 @@
               </a:rPr>
               <a:t>1–3 %</a:t>
             </a:r>
-            <a:endParaRPr lang="en-US" sz="2600" dirty="0"/>
+            <a:endParaRPr lang="en-US" sz="3600" dirty="0"/>
           </a:p>
         </p:txBody>
       </p:sp>
@@ -3267,7 +3267,7 @@
                   <a:schemeClr val="tx2"/>
                 </a:solidFill>
               </a:rPr>
-              <a:t>Ahorro por pozo con 5–6 movs/mes: Petro Star normal 6–16 k USD, Ecotransur 16–18 k USD (pozo de 500–600 k)</a:t>
+              <a:t>Ahorro por pozo con 5–6 movs/mes: Petro Star normal 4–15 k USD, Ecotransur 15–17 k USD (pozo de 500–600 k)</a:t>
             </a:r>
             <a:endParaRPr lang="en-US" sz="1400" dirty="0"/>
           </a:p>
@@ -3333,7 +3333,7 @@
                 <a:ea typeface="Cambria" pitchFamily="34" charset="-122"/>
                 <a:cs typeface="Cambria" pitchFamily="34" charset="-120"/>
               </a:rPr>
-              <a:t>2 h</a:t>
+              <a:t>1,5 h</a:t>
             </a:r>
             <a:endParaRPr lang="en-US" sz="3600" dirty="0"/>
           </a:p>
@@ -3383,7 +3383,7 @@
                   <a:schemeClr val="tx2"/>
                 </a:solidFill>
               </a:rPr>
-              <a:t>sobre el tiempo cotizado borran el ahorro de Petro Star con 5 movs/mes; con 6, unas 6 h (taladro + equipos)</a:t>
+              <a:t>sobre el tiempo cotizado borran el ahorro de Petro Star con 5 movs/mes; con 6, unas 5 h (taladro + equipos)</a:t>
             </a:r>
             <a:endParaRPr lang="en-US" sz="1400" dirty="0"/>
           </a:p>
@@ -3535,7 +3535,7 @@
                   <a:schemeClr val="tx2"/>
                 </a:solidFill>
               </a:rPr>
-              <a:t>Campaña 15 + 20 pozos (0,1–5 km), frecuencia esperada 5–6 movs/mes, TRM 3.700. Con 4 movs/mes Petro Star ya pierde. Logs: 2024 tuvo 6 o más en 9 de 11 meses; 2025, en 4 de 9.</a:t>
+              <a:t>Campaña 15 + 20 pozos (0,1–5 km), 5–6 movs/mes, TRM 3.700 y 17,3 h de bloqueo social medido (OpenWells 2025). Con 4 movs/mes Petro Star pierde. Logs: 2024 tuvo 6 o más en 9 de 11 meses; 2025, en 4 de 9.</a:t>
             </a:r>
             <a:endParaRPr lang="en-US" sz="1050" dirty="0"/>
           </a:p>
@@ -6611,7 +6611,7 @@
                           <a:ea typeface="Calibri" pitchFamily="34" charset="-122"/>
                           <a:cs typeface="Calibri" pitchFamily="34" charset="-120"/>
                         </a:rPr>
-                        <a:t>+0,20 M</a:t>
+                        <a:t>+0,15 M</a:t>
                       </a:r>
                       <a:endParaRPr lang="en-US" sz="1200" dirty="0">
                         <a:latin typeface="Calibri" charset="0"/>
@@ -6676,7 +6676,7 @@
                           <a:ea typeface="Calibri" pitchFamily="34" charset="-122"/>
                           <a:cs typeface="Calibri" pitchFamily="34" charset="-120"/>
                         </a:rPr>
-                        <a:t>+0,57 M</a:t>
+                        <a:t>+0,52 M</a:t>
                       </a:r>
                       <a:endParaRPr lang="en-US" sz="1200" dirty="0">
                         <a:latin typeface="Calibri" charset="0"/>
@@ -6741,7 +6741,7 @@
                           <a:ea typeface="Calibri" pitchFamily="34" charset="-122"/>
                           <a:cs typeface="Calibri" pitchFamily="34" charset="-120"/>
                         </a:rPr>
-                        <a:t>+0,56 M</a:t>
+                        <a:t>+0,51 M</a:t>
                       </a:r>
                       <a:endParaRPr lang="en-US" sz="1200" dirty="0">
                         <a:latin typeface="Calibri" charset="0"/>
@@ -6806,7 +6806,7 @@
                           <a:ea typeface="Calibri" pitchFamily="34" charset="-122"/>
                           <a:cs typeface="Calibri" pitchFamily="34" charset="-120"/>
                         </a:rPr>
-                        <a:t>+0,64 M</a:t>
+                        <a:t>+0,59 M</a:t>
                       </a:r>
                       <a:endParaRPr lang="en-US" sz="1200" dirty="0">
                         <a:latin typeface="Calibri" charset="0"/>
@@ -6938,7 +6938,7 @@
                           <a:ea typeface="Calibri" pitchFamily="34" charset="-122"/>
                           <a:cs typeface="Calibri" pitchFamily="34" charset="-120"/>
                         </a:rPr>
-                        <a:t>1,0 %</a:t>
+                        <a:t>0,8 %</a:t>
                       </a:r>
                       <a:endParaRPr lang="en-US" sz="1200" dirty="0">
                         <a:latin typeface="Calibri" charset="0"/>
@@ -7003,7 +7003,7 @@
                           <a:ea typeface="Calibri" pitchFamily="34" charset="-122"/>
                           <a:cs typeface="Calibri" pitchFamily="34" charset="-120"/>
                         </a:rPr>
-                        <a:t>3,0 %</a:t>
+                        <a:t>2,7 %</a:t>
                       </a:r>
                       <a:endParaRPr lang="en-US" sz="1200" dirty="0">
                         <a:latin typeface="Calibri" charset="0"/>
@@ -7068,7 +7068,7 @@
                           <a:ea typeface="Calibri" pitchFamily="34" charset="-122"/>
                           <a:cs typeface="Calibri" pitchFamily="34" charset="-120"/>
                         </a:rPr>
-                        <a:t>2,9 %</a:t>
+                        <a:t>2,6 %</a:t>
                       </a:r>
                       <a:endParaRPr lang="en-US" sz="1200" dirty="0">
                         <a:latin typeface="Calibri" charset="0"/>
@@ -7133,7 +7133,7 @@
                           <a:ea typeface="Calibri" pitchFamily="34" charset="-122"/>
                           <a:cs typeface="Calibri" pitchFamily="34" charset="-120"/>
                         </a:rPr>
-                        <a:t>3,3 %</a:t>
+                        <a:t>3,1 %</a:t>
                       </a:r>
                       <a:endParaRPr lang="en-US" sz="1200" dirty="0">
                         <a:latin typeface="Calibri" charset="0"/>
@@ -7265,7 +7265,7 @@
                           <a:ea typeface="Calibri" pitchFamily="34" charset="-122"/>
                           <a:cs typeface="Calibri" pitchFamily="34" charset="-120"/>
                         </a:rPr>
-                        <a:t>3,9 h</a:t>
+                        <a:t>3,0 h</a:t>
                       </a:r>
                       <a:endParaRPr lang="en-US" sz="1200" dirty="0">
                         <a:latin typeface="Calibri" charset="0"/>
@@ -7330,7 +7330,7 @@
                           <a:ea typeface="Calibri" pitchFamily="34" charset="-122"/>
                           <a:cs typeface="Calibri" pitchFamily="34" charset="-120"/>
                         </a:rPr>
-                        <a:t>11,2 h</a:t>
+                        <a:t>10,3 h</a:t>
                       </a:r>
                       <a:endParaRPr lang="en-US" sz="1200" dirty="0">
                         <a:latin typeface="Calibri" charset="0"/>
@@ -7395,7 +7395,7 @@
                           <a:ea typeface="Calibri" pitchFamily="34" charset="-122"/>
                           <a:cs typeface="Calibri" pitchFamily="34" charset="-120"/>
                         </a:rPr>
-                        <a:t>11,0 h</a:t>
+                        <a:t>10,0 h</a:t>
                       </a:r>
                       <a:endParaRPr lang="en-US" sz="1200" dirty="0">
                         <a:latin typeface="Calibri" charset="0"/>
@@ -7460,7 +7460,7 @@
                           <a:ea typeface="Calibri" pitchFamily="34" charset="-122"/>
                           <a:cs typeface="Calibri" pitchFamily="34" charset="-120"/>
                         </a:rPr>
-                        <a:t>12,5 h</a:t>
+                        <a:t>11,5 h</a:t>
                       </a:r>
                       <a:endParaRPr lang="en-US" sz="1200" dirty="0">
                         <a:latin typeface="Calibri" charset="0"/>
@@ -7592,7 +7592,7 @@
                           <a:ea typeface="Calibri" pitchFamily="34" charset="-122"/>
                           <a:cs typeface="Calibri" pitchFamily="34" charset="-120"/>
                         </a:rPr>
-                        <a:t>2,0 h</a:t>
+                        <a:t>1,5 h</a:t>
                       </a:r>
                       <a:endParaRPr lang="en-US" sz="1200" dirty="0">
                         <a:latin typeface="Calibri" charset="0"/>
@@ -7657,7 +7657,7 @@
                           <a:ea typeface="Calibri" pitchFamily="34" charset="-122"/>
                           <a:cs typeface="Calibri" pitchFamily="34" charset="-120"/>
                         </a:rPr>
-                        <a:t>5,8 h</a:t>
+                        <a:t>5,3 h</a:t>
                       </a:r>
                       <a:endParaRPr lang="en-US" sz="1200" dirty="0">
                         <a:latin typeface="Calibri" charset="0"/>
@@ -7722,7 +7722,7 @@
                           <a:ea typeface="Calibri" pitchFamily="34" charset="-122"/>
                           <a:cs typeface="Calibri" pitchFamily="34" charset="-120"/>
                         </a:rPr>
-                        <a:t>5,7 h</a:t>
+                        <a:t>5,2 h</a:t>
                       </a:r>
                       <a:endParaRPr lang="en-US" sz="1200" dirty="0">
                         <a:latin typeface="Calibri" charset="0"/>
@@ -7787,7 +7787,7 @@
                           <a:ea typeface="Calibri" pitchFamily="34" charset="-122"/>
                           <a:cs typeface="Calibri" pitchFamily="34" charset="-120"/>
                         </a:rPr>
-                        <a:t>6,5 h</a:t>
+                        <a:t>6,0 h</a:t>
                       </a:r>
                       <a:endParaRPr lang="en-US" sz="1200" dirty="0">
                         <a:latin typeface="Calibri" charset="0"/>
@@ -7919,7 +7919,7 @@
                           <a:ea typeface="Calibri" pitchFamily="34" charset="-122"/>
                           <a:cs typeface="Calibri" pitchFamily="34" charset="-120"/>
                         </a:rPr>
-                        <a:t>5,7 d</a:t>
+                        <a:t>4,3 d</a:t>
                       </a:r>
                       <a:endParaRPr lang="en-US" sz="1200" dirty="0">
                         <a:latin typeface="Calibri" charset="0"/>
@@ -7984,7 +7984,7 @@
                           <a:ea typeface="Calibri" pitchFamily="34" charset="-122"/>
                           <a:cs typeface="Calibri" pitchFamily="34" charset="-120"/>
                         </a:rPr>
-                        <a:t>16,4 d</a:t>
+                        <a:t>15,0 d</a:t>
                       </a:r>
                       <a:endParaRPr lang="en-US" sz="1200" dirty="0">
                         <a:latin typeface="Calibri" charset="0"/>
@@ -8049,7 +8049,7 @@
                           <a:ea typeface="Calibri" pitchFamily="34" charset="-122"/>
                           <a:cs typeface="Calibri" pitchFamily="34" charset="-120"/>
                         </a:rPr>
-                        <a:t>16,0 d</a:t>
+                        <a:t>14,6 d</a:t>
                       </a:r>
                       <a:endParaRPr lang="en-US" sz="1200" dirty="0">
                         <a:latin typeface="Calibri" charset="0"/>
@@ -8114,7 +8114,7 @@
                           <a:ea typeface="Calibri" pitchFamily="34" charset="-122"/>
                           <a:cs typeface="Calibri" pitchFamily="34" charset="-120"/>
                         </a:rPr>
-                        <a:t>18,2 d</a:t>
+                        <a:t>16,8 d</a:t>
                       </a:r>
                       <a:endParaRPr lang="en-US" sz="1200" dirty="0">
                         <a:latin typeface="Calibri" charset="0"/>
@@ -8246,7 +8246,7 @@
                           <a:ea typeface="Calibri" pitchFamily="34" charset="-122"/>
                           <a:cs typeface="Calibri" pitchFamily="34" charset="-120"/>
                         </a:rPr>
-                        <a:t>1,2</a:t>
+                        <a:t>0,9</a:t>
                       </a:r>
                       <a:endParaRPr lang="en-US" sz="1200" dirty="0">
                         <a:latin typeface="Calibri" charset="0"/>
@@ -8311,7 +8311,7 @@
                           <a:ea typeface="Calibri" pitchFamily="34" charset="-122"/>
                           <a:cs typeface="Calibri" pitchFamily="34" charset="-120"/>
                         </a:rPr>
-                        <a:t>3,6</a:t>
+                        <a:t>3,3</a:t>
                       </a:r>
                       <a:endParaRPr lang="en-US" sz="1200" dirty="0">
                         <a:latin typeface="Calibri" charset="0"/>
@@ -8376,7 +8376,7 @@
                           <a:ea typeface="Calibri" pitchFamily="34" charset="-122"/>
                           <a:cs typeface="Calibri" pitchFamily="34" charset="-120"/>
                         </a:rPr>
-                        <a:t>2,5</a:t>
+                        <a:t>2,3</a:t>
                       </a:r>
                       <a:endParaRPr lang="en-US" sz="1200" dirty="0">
                         <a:latin typeface="Calibri" charset="0"/>
@@ -8441,7 +8441,7 @@
                           <a:ea typeface="Calibri" pitchFamily="34" charset="-122"/>
                           <a:cs typeface="Calibri" pitchFamily="34" charset="-120"/>
                         </a:rPr>
-                        <a:t>2,8</a:t>
+                        <a:t>2,6</a:t>
                       </a:r>
                       <a:endParaRPr lang="en-US" sz="1200" dirty="0">
                         <a:latin typeface="Calibri" charset="0"/>
@@ -8535,7 +8535,7 @@
                   <a:schemeClr val="tx2"/>
                 </a:solidFill>
               </a:rPr>
-              <a:t>en el Work Order una demora o un mes sin mover no cuesta nada. En el tercerizado cada hora sobre el tiempo cotizado cuesta unos 2.813 USD (taladro 1.456 + equipos y señalizadores 1.357) y un mes bloqueado paga el cargo fijo completo (Petro Star 161 k, Ecotransur 226 k).</a:t>
+              <a:t>en el Work Order una demora, un bloqueo o un mes sin mover no cuesta nada. En el tercerizado cada hora sobre el tiempo cotizado cuesta unos 2.813 USD (taladro 1.456 + equipos y señalizadores 1.357) y un mes bloqueado paga el cargo fijo completo (Petro Star 161 k, Ecotransur 226 k).</a:t>
             </a:r>
             <a:endParaRPr lang="en-US" sz="1200" dirty="0"/>
           </a:p>

</xml_diff>

<commit_message>
Movilización: Work Order tariffs are a cap (confirmed); outsourced has no cap — reframed across simulator, audit and deck
Co-Authored-By: Claude Opus 5.5 <noreply@anthropic.com>
Claude-Session: https://claude.ai/code/session_01BsMRKE8hArHddZxwmwcNWn
</commit_message>
<xml_diff>
--- a/movilizacion/entregables/Presentacion_Movilizacion_GRS110.pptx
+++ b/movilizacion/entregables/Presentacion_Movilizacion_GRS110.pptx
@@ -110,22 +110,22 @@
   <p:extLst>
     <p:ext uri="{521415D9-36F7-43E2-AB2F-B90AF26B5E84}">
       <p14:sectionLst xmlns:p14="http://schemas.microsoft.com/office/powerpoint/2010/main">
-        <p14:section name="Decisión" id="{cf5aa66f-bb9f-e6b7-9f49-55eb3fdd67ef}">
+        <p14:section name="Decisión" id="{7fc33bc1-a053-5608-fdc1-37e14e11a683}">
           <p14:sldIdLst>
             <p14:sldId id="256"/>
           </p14:sldIdLst>
         </p14:section>
-        <p14:section name="Estructura de costo" id="{fed18006-a86b-04cc-7b5c-943aa119ced4}">
+        <p14:section name="Estructura de costo" id="{d91145b5-66e8-9c0a-5686-bda882747d8f}">
           <p14:sldIdLst>
             <p14:sldId id="257"/>
           </p14:sldIdLst>
         </p14:section>
-        <p14:section name="Frontera" id="{03e042d4-8076-3333-4f00-08344c50575e}">
+        <p14:section name="Frontera" id="{95188d28-818f-8dce-25c8-77d4503b37b3}">
           <p14:sldIdLst>
             <p14:sldId id="258"/>
           </p14:sldIdLst>
         </p14:section>
-        <p14:section name="Pendientes" id="{79cfa555-aad9-0fab-2a2e-45251ea4ef29}">
+        <p14:section name="Pendientes" id="{fe3d7e6d-4831-a802-e42f-fb7c76d20bae}">
           <p14:sldIdLst>
             <p14:sldId id="259"/>
           </p14:sldIdLst>
@@ -8619,7 +8619,7 @@
                   <a:schemeClr val="bg1"/>
                 </a:solidFill>
               </a:rPr>
-              <a:t>Tabla del Work Order por horas: hoy se compara contra la banda más lenta; si el contratista mueve rápido, el WO cuesta más (+5 % al WO ≈ +0,16 M a favor del tercerizado).</a:t>
+              <a:t>El Work Order tiene tope: lo comparamos contra su tarifa máxima. El tercerizado no tiene tope; el riesgo de cada hora extra queda en SierraCol.</a:t>
             </a:r>
             <a:endParaRPr lang="en-US" sz="1200" dirty="0"/>
           </a:p>

</xml_diff>

<commit_message>
Movilización: deck card header wording
Co-Authored-By: Claude Opus 5.5 <noreply@anthropic.com>
Claude-Session: https://claude.ai/code/session_01BsMRKE8hArHddZxwmwcNWn
</commit_message>
<xml_diff>
--- a/movilizacion/entregables/Presentacion_Movilizacion_GRS110.pptx
+++ b/movilizacion/entregables/Presentacion_Movilizacion_GRS110.pptx
@@ -110,22 +110,22 @@
   <p:extLst>
     <p:ext uri="{521415D9-36F7-43E2-AB2F-B90AF26B5E84}">
       <p14:sectionLst xmlns:p14="http://schemas.microsoft.com/office/powerpoint/2010/main">
-        <p14:section name="Decisión" id="{7fc33bc1-a053-5608-fdc1-37e14e11a683}">
+        <p14:section name="Decisión" id="{7d6ecde9-c1f9-c9d8-9958-083633f1b2f2}">
           <p14:sldIdLst>
             <p14:sldId id="256"/>
           </p14:sldIdLst>
         </p14:section>
-        <p14:section name="Estructura de costo" id="{d91145b5-66e8-9c0a-5686-bda882747d8f}">
+        <p14:section name="Estructura de costo" id="{687b3cc8-9639-5dfe-5c8b-5dcc5b41850a}">
           <p14:sldIdLst>
             <p14:sldId id="257"/>
           </p14:sldIdLst>
         </p14:section>
-        <p14:section name="Frontera" id="{95188d28-818f-8dce-25c8-77d4503b37b3}">
+        <p14:section name="Frontera" id="{21eb3510-71b9-ecc6-3e77-7a34e46c89d3}">
           <p14:sldIdLst>
             <p14:sldId id="258"/>
           </p14:sldIdLst>
         </p14:section>
-        <p14:section name="Pendientes" id="{fe3d7e6d-4831-a802-e42f-fb7c76d20bae}">
+        <p14:section name="Pendientes" id="{9a828c4c-8223-5429-cb91-8cbd9e41fbed}">
           <p14:sldIdLst>
             <p14:sldId id="259"/>
           </p14:sldIdLst>
@@ -8601,7 +8601,7 @@
                   <a:schemeClr val="accent1"/>
                 </a:solidFill>
               </a:rPr>
-              <a:t>Falta confirmar</a:t>
+              <a:t>A tener en cuenta</a:t>
             </a:r>
             <a:endParaRPr lang="en-US" sz="1200" dirty="0"/>
           </a:p>

</xml_diff>

<commit_message>
Movilización: well cost 600k (SierraCol range 550–650k); campaign-level savings framing
Co-Authored-By: Claude Opus 5.5 <noreply@anthropic.com>
Claude-Session: https://claude.ai/code/session_01BsMRKE8hArHddZxwmwcNWn
</commit_message>
<xml_diff>
--- a/movilizacion/entregables/Presentacion_Movilizacion_GRS110.pptx
+++ b/movilizacion/entregables/Presentacion_Movilizacion_GRS110.pptx
@@ -110,22 +110,22 @@
   <p:extLst>
     <p:ext uri="{521415D9-36F7-43E2-AB2F-B90AF26B5E84}">
       <p14:sectionLst xmlns:p14="http://schemas.microsoft.com/office/powerpoint/2010/main">
-        <p14:section name="Decisión" id="{7d6ecde9-c1f9-c9d8-9958-083633f1b2f2}">
+        <p14:section name="Decisión" id="{6717f10d-acf0-713c-dda0-4ae4678a0250}">
           <p14:sldIdLst>
             <p14:sldId id="256"/>
           </p14:sldIdLst>
         </p14:section>
-        <p14:section name="Estructura de costo" id="{687b3cc8-9639-5dfe-5c8b-5dcc5b41850a}">
+        <p14:section name="Estructura de costo" id="{b361c65b-1061-c340-3cdc-4eff4a4ec4e4}">
           <p14:sldIdLst>
             <p14:sldId id="257"/>
           </p14:sldIdLst>
         </p14:section>
-        <p14:section name="Frontera" id="{21eb3510-71b9-ecc6-3e77-7a34e46c89d3}">
+        <p14:section name="Frontera" id="{d9a10660-02df-8645-bfcd-33f2e3b23706}">
           <p14:sldIdLst>
             <p14:sldId id="258"/>
           </p14:sldIdLst>
         </p14:section>
-        <p14:section name="Pendientes" id="{9a828c4c-8223-5429-cb91-8cbd9e41fbed}">
+        <p14:section name="Pendientes" id="{7d73b183-f5a4-2034-e3af-b9bd831f7387}">
           <p14:sldIdLst>
             <p14:sldId id="259"/>
           </p14:sldIdLst>
@@ -3209,7 +3209,7 @@
               <a:buNone/>
             </a:pPr>
             <a:r>
-              <a:rPr lang="en-US" sz="3600" b="1" dirty="0">
+              <a:rPr lang="en-US" sz="2600" b="1" dirty="0">
                 <a:solidFill>
                   <a:schemeClr val="accent4"/>
                 </a:solidFill>
@@ -3217,9 +3217,9 @@
                 <a:ea typeface="Cambria" pitchFamily="34" charset="-122"/>
                 <a:cs typeface="Cambria" pitchFamily="34" charset="-120"/>
               </a:rPr>
-              <a:t>1–3 %</a:t>
+              <a:t>0,7–3 %</a:t>
             </a:r>
-            <a:endParaRPr lang="en-US" sz="3600" dirty="0"/>
+            <a:endParaRPr lang="en-US" sz="2600" dirty="0"/>
           </a:p>
         </p:txBody>
       </p:sp>
@@ -3253,7 +3253,7 @@
                   <a:schemeClr val="tx1"/>
                 </a:solidFill>
               </a:rPr>
-              <a:t>del costo de cada pozo</a:t>
+              <a:t>del costo de la campaña</a:t>
             </a:r>
             <a:endParaRPr lang="en-US" sz="1400" dirty="0"/>
           </a:p>
@@ -3267,7 +3267,7 @@
                   <a:schemeClr val="tx2"/>
                 </a:solidFill>
               </a:rPr>
-              <a:t>Ahorro por pozo con 5–6 movs/mes: Petro Star normal 4–15 k USD, Ecotransur 15–17 k USD (pozo de 500–600 k)</a:t>
+              <a:t>Ahorro de la campaña de 35 pozos (~21 M USD): 0,15–0,59 M, es decir 4–17 k USD por pozo (pozo de 550–650 k)</a:t>
             </a:r>
             <a:endParaRPr lang="en-US" sz="1400" dirty="0"/>
           </a:p>
@@ -6873,7 +6873,7 @@
                           <a:ea typeface="Calibri" pitchFamily="34" charset="-122"/>
                           <a:cs typeface="Calibri" pitchFamily="34" charset="-120"/>
                         </a:rPr>
-                        <a:t>Ahorro por pozo (% de un pozo de 550 k)</a:t>
+                        <a:t>Ahorro por pozo (% de un pozo de 600 k)</a:t>
                       </a:r>
                       <a:endParaRPr lang="en-US" sz="1200" dirty="0">
                         <a:latin typeface="Calibri" charset="0"/>
@@ -6938,7 +6938,7 @@
                           <a:ea typeface="Calibri" pitchFamily="34" charset="-122"/>
                           <a:cs typeface="Calibri" pitchFamily="34" charset="-120"/>
                         </a:rPr>
-                        <a:t>0,8 %</a:t>
+                        <a:t>0,7 %</a:t>
                       </a:r>
                       <a:endParaRPr lang="en-US" sz="1200" dirty="0">
                         <a:latin typeface="Calibri" charset="0"/>
@@ -7003,7 +7003,7 @@
                           <a:ea typeface="Calibri" pitchFamily="34" charset="-122"/>
                           <a:cs typeface="Calibri" pitchFamily="34" charset="-120"/>
                         </a:rPr>
-                        <a:t>2,7 %</a:t>
+                        <a:t>2,5 %</a:t>
                       </a:r>
                       <a:endParaRPr lang="en-US" sz="1200" dirty="0">
                         <a:latin typeface="Calibri" charset="0"/>
@@ -7068,7 +7068,7 @@
                           <a:ea typeface="Calibri" pitchFamily="34" charset="-122"/>
                           <a:cs typeface="Calibri" pitchFamily="34" charset="-120"/>
                         </a:rPr>
-                        <a:t>2,6 %</a:t>
+                        <a:t>2,4 %</a:t>
                       </a:r>
                       <a:endParaRPr lang="en-US" sz="1200" dirty="0">
                         <a:latin typeface="Calibri" charset="0"/>
@@ -7133,7 +7133,7 @@
                           <a:ea typeface="Calibri" pitchFamily="34" charset="-122"/>
                           <a:cs typeface="Calibri" pitchFamily="34" charset="-120"/>
                         </a:rPr>
-                        <a:t>3,1 %</a:t>
+                        <a:t>2,8 %</a:t>
                       </a:r>
                       <a:endParaRPr lang="en-US" sz="1200" dirty="0">
                         <a:latin typeface="Calibri" charset="0"/>

</xml_diff>

<commit_message>
Movilización: deck KPIs data-driven, audit workbooks aligned to current base
Co-Authored-By: Claude Opus 5.5 <noreply@anthropic.com>
Claude-Session: https://claude.ai/code/session_01BsMRKE8hArHddZxwmwcNWn
</commit_message>
<xml_diff>
--- a/movilizacion/entregables/Presentacion_Movilizacion_GRS110.pptx
+++ b/movilizacion/entregables/Presentacion_Movilizacion_GRS110.pptx
@@ -110,22 +110,22 @@
   <p:extLst>
     <p:ext uri="{521415D9-36F7-43E2-AB2F-B90AF26B5E84}">
       <p14:sectionLst xmlns:p14="http://schemas.microsoft.com/office/powerpoint/2010/main">
-        <p14:section name="Decisión" id="{6717f10d-acf0-713c-dda0-4ae4678a0250}">
+        <p14:section name="Decisión" id="{7aea24ca-9a34-139b-2464-27a22d34107c}">
           <p14:sldIdLst>
             <p14:sldId id="256"/>
           </p14:sldIdLst>
         </p14:section>
-        <p14:section name="Estructura de costo" id="{b361c65b-1061-c340-3cdc-4eff4a4ec4e4}">
+        <p14:section name="Estructura de costo" id="{b5b51beb-5bef-0f5b-0c30-4dc442754189}">
           <p14:sldIdLst>
             <p14:sldId id="257"/>
           </p14:sldIdLst>
         </p14:section>
-        <p14:section name="Frontera" id="{d9a10660-02df-8645-bfcd-33f2e3b23706}">
+        <p14:section name="Frontera" id="{9913c817-55eb-3934-c629-a71cb138af4d}">
           <p14:sldIdLst>
             <p14:sldId id="258"/>
           </p14:sldIdLst>
         </p14:section>
-        <p14:section name="Pendientes" id="{7d73b183-f5a4-2034-e3af-b9bd831f7387}">
+        <p14:section name="Pendientes" id="{68c27ff3-cdff-5b86-a6e7-864052c7b51d}">
           <p14:sldIdLst>
             <p14:sldId id="259"/>
           </p14:sldIdLst>
@@ -1271,28 +1271,28 @@
                 <c:formatCode>General</c:formatCode>
                 <c:ptCount val="8"/>
                 <c:pt idx="0">
-                  <c:v>-83725.53918918828</c:v>
+                  <c:v>-135076.89054054068</c:v>
                 </c:pt>
                 <c:pt idx="1">
-                  <c:v>32570.32216216298</c:v>
+                  <c:v>-2564.812972973101</c:v>
                 </c:pt>
                 <c:pt idx="2">
-                  <c:v>151086.61027027108</c:v>
+                  <c:v>132167.69135135133</c:v>
                 </c:pt>
                 <c:pt idx="3">
-                  <c:v>298418.6017567576</c:v>
+                  <c:v>279499.68283783784</c:v>
                 </c:pt>
                 <c:pt idx="4">
-                  <c:v>524278.8840540545</c:v>
+                  <c:v>521576.18135135155</c:v>
                 </c:pt>
                 <c:pt idx="5">
-                  <c:v>544289.827702703</c:v>
+                  <c:v>541587.1250000009</c:v>
                 </c:pt>
                 <c:pt idx="6">
-                  <c:v>681834.4614864872</c:v>
+                  <c:v>695347.9750000006</c:v>
                 </c:pt>
                 <c:pt idx="7">
-                  <c:v>682640.8786486494</c:v>
+                  <c:v>696154.3921621628</c:v>
                 </c:pt>
               </c:numCache>
             </c:numRef>
@@ -1409,28 +1409,28 @@
                 <c:formatCode>General</c:formatCode>
                 <c:ptCount val="8"/>
                 <c:pt idx="0">
-                  <c:v>56818.85135135101</c:v>
+                  <c:v>5467.499999997672</c:v>
                 </c:pt>
                 <c:pt idx="1">
-                  <c:v>283136.37432432454</c:v>
+                  <c:v>248001.23918918753</c:v>
                 </c:pt>
                 <c:pt idx="2">
-                  <c:v>509453.89729729807</c:v>
+                  <c:v>490534.9783783774</c:v>
                 </c:pt>
                 <c:pt idx="3">
-                  <c:v>423960.41216216283</c:v>
+                  <c:v>405041.49324324215</c:v>
                 </c:pt>
                 <c:pt idx="4">
-                  <c:v>587203.9000000013</c:v>
+                  <c:v>584501.197297297</c:v>
                 </c:pt>
                 <c:pt idx="5">
-                  <c:v>524129.86486486625</c:v>
+                  <c:v>521427.16216216143</c:v>
                 </c:pt>
                 <c:pt idx="6">
-                  <c:v>646718.7675675689</c:v>
+                  <c:v>660232.2810810809</c:v>
                 </c:pt>
                 <c:pt idx="7">
-                  <c:v>620115.0027027032</c:v>
+                  <c:v>633628.5162162161</c:v>
                 </c:pt>
               </c:numCache>
             </c:numRef>
@@ -1547,28 +1547,28 @@
                 <c:formatCode>General</c:formatCode>
                 <c:ptCount val="8"/>
                 <c:pt idx="0">
-                  <c:v>-688673.8581081079</c:v>
+                  <c:v>-740025.2094594599</c:v>
                 </c:pt>
                 <c:pt idx="1">
-                  <c:v>-572377.9967567567</c:v>
+                  <c:v>-607513.1318918923</c:v>
                 </c:pt>
                 <c:pt idx="2">
-                  <c:v>-453861.7086486486</c:v>
+                  <c:v>-472780.62756756786</c:v>
                 </c:pt>
                 <c:pt idx="3">
-                  <c:v>-385190.7454054053</c:v>
+                  <c:v>-404109.6643243246</c:v>
                 </c:pt>
                 <c:pt idx="4">
-                  <c:v>-208146.47999999998</c:v>
+                  <c:v>-210849.18270270294</c:v>
                 </c:pt>
                 <c:pt idx="5">
-                  <c:v>-236951.55324324314</c:v>
+                  <c:v>-239654.2559459461</c:v>
                 </c:pt>
                 <c:pt idx="6">
-                  <c:v>-167193.94189189188</c:v>
+                  <c:v>-153680.4283783785</c:v>
                 </c:pt>
                 <c:pt idx="7">
-                  <c:v>-236951.55324324314</c:v>
+                  <c:v>-223438.03972972976</c:v>
                 </c:pt>
               </c:numCache>
             </c:numRef>
@@ -3217,7 +3217,7 @@
                 <a:ea typeface="Cambria" pitchFamily="34" charset="-122"/>
                 <a:cs typeface="Cambria" pitchFamily="34" charset="-120"/>
               </a:rPr>
-              <a:t>0,7–3 %</a:t>
+              <a:t>0,6–2,8 %</a:t>
             </a:r>
             <a:endParaRPr lang="en-US" sz="2600" dirty="0"/>
           </a:p>
@@ -3267,7 +3267,7 @@
                   <a:schemeClr val="tx2"/>
                 </a:solidFill>
               </a:rPr>
-              <a:t>Ahorro de la campaña de 35 pozos (~21 M USD): 0,15–0,59 M, es decir 4–17 k USD por pozo (pozo de 550–650 k)</a:t>
+              <a:t>Ahorro de la campaña de 35 pozos (~21 M USD): 0,13–0,58 M, es decir 4–17 k USD por pozo (pozo de 550–650 k)</a:t>
             </a:r>
             <a:endParaRPr lang="en-US" sz="1400" dirty="0"/>
           </a:p>
@@ -3333,7 +3333,7 @@
                 <a:ea typeface="Cambria" pitchFamily="34" charset="-122"/>
                 <a:cs typeface="Cambria" pitchFamily="34" charset="-120"/>
               </a:rPr>
-              <a:t>1,5 h</a:t>
+              <a:t>1,3 h</a:t>
             </a:r>
             <a:endParaRPr lang="en-US" sz="3600" dirty="0"/>
           </a:p>
@@ -3535,7 +3535,7 @@
                   <a:schemeClr val="tx2"/>
                 </a:solidFill>
               </a:rPr>
-              <a:t>Campaña 15 + 20 pozos (0,1–5 km), 5–6 movs/mes, TRM 3.700 y 17,3 h de bloqueo social medido (OpenWells 2025). Con 4 movs/mes Petro Star pierde. Logs: 2024 tuvo 6 o más en 9 de 11 meses; 2025, en 4 de 9.</a:t>
+              <a:t>Campaña 15 + 20 pozos (0,1–5 km), 5–6 movs/mes, TRM 3.700, Truck Manager mensual y 17,3 h de bloqueo social medido (OpenWells 2025). Con 4 movs/mes Petro Star pierde. Logs: 2024 tuvo 6 o más en 9 de 11 meses; 2025, en 4 de 9.</a:t>
             </a:r>
             <a:endParaRPr lang="en-US" sz="1050" dirty="0"/>
           </a:p>
@@ -5482,7 +5482,7 @@
                           <a:ea typeface="Calibri" pitchFamily="34" charset="-122"/>
                           <a:cs typeface="Calibri" pitchFamily="34" charset="-120"/>
                         </a:rPr>
-                        <a:t>+1,13 M</a:t>
+                        <a:t>+1,14 M</a:t>
                       </a:r>
                       <a:endParaRPr lang="en-US" sz="1200" dirty="0">
                         <a:latin typeface="Calibri" charset="0"/>
@@ -5547,7 +5547,7 @@
                           <a:ea typeface="Calibri" pitchFamily="34" charset="-122"/>
                           <a:cs typeface="Calibri" pitchFamily="34" charset="-120"/>
                         </a:rPr>
-                        <a:t>−0,05 M</a:t>
+                        <a:t>−0,07 M</a:t>
                       </a:r>
                       <a:endParaRPr lang="en-US" sz="1200" dirty="0">
                         <a:latin typeface="Calibri" charset="0"/>
@@ -5679,7 +5679,7 @@
                           <a:ea typeface="Calibri" pitchFamily="34" charset="-122"/>
                           <a:cs typeface="Calibri" pitchFamily="34" charset="-120"/>
                         </a:rPr>
-                        <a:t>+0,99 M</a:t>
+                        <a:t>+1,00 M</a:t>
                       </a:r>
                       <a:endParaRPr lang="en-US" sz="1200" dirty="0">
                         <a:latin typeface="Calibri" charset="0"/>
@@ -5744,7 +5744,7 @@
                           <a:ea typeface="Calibri" pitchFamily="34" charset="-122"/>
                           <a:cs typeface="Calibri" pitchFamily="34" charset="-120"/>
                         </a:rPr>
-                        <a:t>−0,05 M</a:t>
+                        <a:t>−0,08 M</a:t>
                       </a:r>
                       <a:endParaRPr lang="en-US" sz="1200" dirty="0">
                         <a:latin typeface="Calibri" charset="0"/>
@@ -5876,7 +5876,7 @@
                           <a:ea typeface="Calibri" pitchFamily="34" charset="-122"/>
                           <a:cs typeface="Calibri" pitchFamily="34" charset="-120"/>
                         </a:rPr>
-                        <a:t>−0,98 M</a:t>
+                        <a:t>−0,97 M</a:t>
                       </a:r>
                       <a:endParaRPr lang="en-US" sz="1200" dirty="0">
                         <a:latin typeface="Calibri" charset="0"/>
@@ -5941,7 +5941,7 @@
                           <a:ea typeface="Calibri" pitchFamily="34" charset="-122"/>
                           <a:cs typeface="Calibri" pitchFamily="34" charset="-120"/>
                         </a:rPr>
-                        <a:t>−1,42 M</a:t>
+                        <a:t>−1,45 M</a:t>
                       </a:r>
                       <a:endParaRPr lang="en-US" sz="1200" dirty="0">
                         <a:latin typeface="Calibri" charset="0"/>
@@ -6611,7 +6611,7 @@
                           <a:ea typeface="Calibri" pitchFamily="34" charset="-122"/>
                           <a:cs typeface="Calibri" pitchFamily="34" charset="-120"/>
                         </a:rPr>
-                        <a:t>+0,15 M</a:t>
+                        <a:t>+0,13 M</a:t>
                       </a:r>
                       <a:endParaRPr lang="en-US" sz="1200" dirty="0">
                         <a:latin typeface="Calibri" charset="0"/>
@@ -6741,7 +6741,7 @@
                           <a:ea typeface="Calibri" pitchFamily="34" charset="-122"/>
                           <a:cs typeface="Calibri" pitchFamily="34" charset="-120"/>
                         </a:rPr>
-                        <a:t>+0,51 M</a:t>
+                        <a:t>+0,49 M</a:t>
                       </a:r>
                       <a:endParaRPr lang="en-US" sz="1200" dirty="0">
                         <a:latin typeface="Calibri" charset="0"/>
@@ -6806,7 +6806,7 @@
                           <a:ea typeface="Calibri" pitchFamily="34" charset="-122"/>
                           <a:cs typeface="Calibri" pitchFamily="34" charset="-120"/>
                         </a:rPr>
-                        <a:t>+0,59 M</a:t>
+                        <a:t>+0,58 M</a:t>
                       </a:r>
                       <a:endParaRPr lang="en-US" sz="1200" dirty="0">
                         <a:latin typeface="Calibri" charset="0"/>
@@ -6938,7 +6938,7 @@
                           <a:ea typeface="Calibri" pitchFamily="34" charset="-122"/>
                           <a:cs typeface="Calibri" pitchFamily="34" charset="-120"/>
                         </a:rPr>
-                        <a:t>0,7 %</a:t>
+                        <a:t>0,6 %</a:t>
                       </a:r>
                       <a:endParaRPr lang="en-US" sz="1200" dirty="0">
                         <a:latin typeface="Calibri" charset="0"/>
@@ -7068,7 +7068,7 @@
                           <a:ea typeface="Calibri" pitchFamily="34" charset="-122"/>
                           <a:cs typeface="Calibri" pitchFamily="34" charset="-120"/>
                         </a:rPr>
-                        <a:t>2,4 %</a:t>
+                        <a:t>2,3 %</a:t>
                       </a:r>
                       <a:endParaRPr lang="en-US" sz="1200" dirty="0">
                         <a:latin typeface="Calibri" charset="0"/>
@@ -7265,7 +7265,7 @@
                           <a:ea typeface="Calibri" pitchFamily="34" charset="-122"/>
                           <a:cs typeface="Calibri" pitchFamily="34" charset="-120"/>
                         </a:rPr>
-                        <a:t>3,0 h</a:t>
+                        <a:t>2,6 h</a:t>
                       </a:r>
                       <a:endParaRPr lang="en-US" sz="1200" dirty="0">
                         <a:latin typeface="Calibri" charset="0"/>
@@ -7330,7 +7330,7 @@
                           <a:ea typeface="Calibri" pitchFamily="34" charset="-122"/>
                           <a:cs typeface="Calibri" pitchFamily="34" charset="-120"/>
                         </a:rPr>
-                        <a:t>10,3 h</a:t>
+                        <a:t>10,2 h</a:t>
                       </a:r>
                       <a:endParaRPr lang="en-US" sz="1200" dirty="0">
                         <a:latin typeface="Calibri" charset="0"/>
@@ -7395,7 +7395,7 @@
                           <a:ea typeface="Calibri" pitchFamily="34" charset="-122"/>
                           <a:cs typeface="Calibri" pitchFamily="34" charset="-120"/>
                         </a:rPr>
-                        <a:t>10,0 h</a:t>
+                        <a:t>9,6 h</a:t>
                       </a:r>
                       <a:endParaRPr lang="en-US" sz="1200" dirty="0">
                         <a:latin typeface="Calibri" charset="0"/>
@@ -7592,7 +7592,7 @@
                           <a:ea typeface="Calibri" pitchFamily="34" charset="-122"/>
                           <a:cs typeface="Calibri" pitchFamily="34" charset="-120"/>
                         </a:rPr>
-                        <a:t>1,5 h</a:t>
+                        <a:t>1,3 h</a:t>
                       </a:r>
                       <a:endParaRPr lang="en-US" sz="1200" dirty="0">
                         <a:latin typeface="Calibri" charset="0"/>
@@ -7722,7 +7722,7 @@
                           <a:ea typeface="Calibri" pitchFamily="34" charset="-122"/>
                           <a:cs typeface="Calibri" pitchFamily="34" charset="-120"/>
                         </a:rPr>
-                        <a:t>5,2 h</a:t>
+                        <a:t>5,0 h</a:t>
                       </a:r>
                       <a:endParaRPr lang="en-US" sz="1200" dirty="0">
                         <a:latin typeface="Calibri" charset="0"/>
@@ -7787,7 +7787,7 @@
                           <a:ea typeface="Calibri" pitchFamily="34" charset="-122"/>
                           <a:cs typeface="Calibri" pitchFamily="34" charset="-120"/>
                         </a:rPr>
-                        <a:t>6,0 h</a:t>
+                        <a:t>5,9 h</a:t>
                       </a:r>
                       <a:endParaRPr lang="en-US" sz="1200" dirty="0">
                         <a:latin typeface="Calibri" charset="0"/>
@@ -7919,7 +7919,7 @@
                           <a:ea typeface="Calibri" pitchFamily="34" charset="-122"/>
                           <a:cs typeface="Calibri" pitchFamily="34" charset="-120"/>
                         </a:rPr>
-                        <a:t>4,3 d</a:t>
+                        <a:t>3,8 d</a:t>
                       </a:r>
                       <a:endParaRPr lang="en-US" sz="1200" dirty="0">
                         <a:latin typeface="Calibri" charset="0"/>
@@ -7984,7 +7984,7 @@
                           <a:ea typeface="Calibri" pitchFamily="34" charset="-122"/>
                           <a:cs typeface="Calibri" pitchFamily="34" charset="-120"/>
                         </a:rPr>
-                        <a:t>15,0 d</a:t>
+                        <a:t>14,9 d</a:t>
                       </a:r>
                       <a:endParaRPr lang="en-US" sz="1200" dirty="0">
                         <a:latin typeface="Calibri" charset="0"/>
@@ -8049,7 +8049,7 @@
                           <a:ea typeface="Calibri" pitchFamily="34" charset="-122"/>
                           <a:cs typeface="Calibri" pitchFamily="34" charset="-120"/>
                         </a:rPr>
-                        <a:t>14,6 d</a:t>
+                        <a:t>14,0 d</a:t>
                       </a:r>
                       <a:endParaRPr lang="en-US" sz="1200" dirty="0">
                         <a:latin typeface="Calibri" charset="0"/>
@@ -8114,7 +8114,7 @@
                           <a:ea typeface="Calibri" pitchFamily="34" charset="-122"/>
                           <a:cs typeface="Calibri" pitchFamily="34" charset="-120"/>
                         </a:rPr>
-                        <a:t>16,8 d</a:t>
+                        <a:t>16,7 d</a:t>
                       </a:r>
                       <a:endParaRPr lang="en-US" sz="1200" dirty="0">
                         <a:latin typeface="Calibri" charset="0"/>
@@ -8246,7 +8246,7 @@
                           <a:ea typeface="Calibri" pitchFamily="34" charset="-122"/>
                           <a:cs typeface="Calibri" pitchFamily="34" charset="-120"/>
                         </a:rPr>
-                        <a:t>0,9</a:t>
+                        <a:t>0,8</a:t>
                       </a:r>
                       <a:endParaRPr lang="en-US" sz="1200" dirty="0">
                         <a:latin typeface="Calibri" charset="0"/>
@@ -8311,7 +8311,7 @@
                           <a:ea typeface="Calibri" pitchFamily="34" charset="-122"/>
                           <a:cs typeface="Calibri" pitchFamily="34" charset="-120"/>
                         </a:rPr>
-                        <a:t>3,3</a:t>
+                        <a:t>3,2</a:t>
                       </a:r>
                       <a:endParaRPr lang="en-US" sz="1200" dirty="0">
                         <a:latin typeface="Calibri" charset="0"/>
@@ -8376,7 +8376,7 @@
                           <a:ea typeface="Calibri" pitchFamily="34" charset="-122"/>
                           <a:cs typeface="Calibri" pitchFamily="34" charset="-120"/>
                         </a:rPr>
-                        <a:t>2,3</a:t>
+                        <a:t>2,2</a:t>
                       </a:r>
                       <a:endParaRPr lang="en-US" sz="1200" dirty="0">
                         <a:latin typeface="Calibri" charset="0"/>

</xml_diff>

<commit_message>
Movilización: final audit fixes (blocked month incl. Truck Manager, input validations, chart links, pros/cons table, recommendation slide, unified names, neutral wording, print setup)
Co-Authored-By: Claude Opus 5.5 <noreply@anthropic.com>
Claude-Session: https://claude.ai/code/session_01BsMRKE8hArHddZxwmwcNWn
</commit_message>
<xml_diff>
--- a/movilizacion/entregables/Presentacion_Movilizacion_GRS110.pptx
+++ b/movilizacion/entregables/Presentacion_Movilizacion_GRS110.pptx
@@ -9,9 +9,10 @@
     <p:sldId id="257" r:id="rId3"/>
     <p:sldId id="258" r:id="rId4"/>
     <p:sldId id="259" r:id="rId5"/>
+    <p:sldId id="260" r:id="rId6"/>
   </p:sldIdLst>
   <p:notesMasterIdLst>
-    <p:notesMasterId r:id="rId6"/>
+    <p:notesMasterId r:id="rId7"/>
   </p:notesMasterIdLst>
   <p:sldSz cx="12192000" cy="6858000"/>
   <p:notesSz cx="6858000" cy="12192000"/>
@@ -110,24 +111,29 @@
   <p:extLst>
     <p:ext uri="{521415D9-36F7-43E2-AB2F-B90AF26B5E84}">
       <p14:sectionLst xmlns:p14="http://schemas.microsoft.com/office/powerpoint/2010/main">
-        <p14:section name="Decisión" id="{7aea24ca-9a34-139b-2464-27a22d34107c}">
+        <p14:section name="Decisión" id="{a1784786-4888-04e2-f8b3-8f12b1961e95}">
           <p14:sldIdLst>
             <p14:sldId id="256"/>
           </p14:sldIdLst>
         </p14:section>
-        <p14:section name="Estructura de costo" id="{b5b51beb-5bef-0f5b-0c30-4dc442754189}">
+        <p14:section name="Estructura de costo" id="{3646c10c-c8c8-5725-15e5-d6cff9aef1d2}">
           <p14:sldIdLst>
             <p14:sldId id="257"/>
           </p14:sldIdLst>
         </p14:section>
-        <p14:section name="Frontera" id="{9913c817-55eb-3934-c629-a71cb138af4d}">
+        <p14:section name="Frontera" id="{3876ff8d-7781-0dd3-0e9e-96500e084351}">
           <p14:sldIdLst>
             <p14:sldId id="258"/>
           </p14:sldIdLst>
         </p14:section>
-        <p14:section name="Pendientes" id="{68c27ff3-cdff-5b86-a6e7-864052c7b51d}">
+        <p14:section name="Pendientes" id="{4dc3da44-470f-48b5-69c4-a6640d8b1389}">
           <p14:sldIdLst>
             <p14:sldId id="259"/>
+          </p14:sldIdLst>
+        </p14:section>
+        <p14:section name="Recomendación" id="{8bdcaf60-b4a9-d1b3-d736-3df5a5629c3d}">
+          <p14:sldIdLst>
+            <p14:sldId id="260"/>
           </p14:sldIdLst>
         </p14:section>
       </p14:sectionLst>
@@ -865,7 +871,7 @@
               <c:strCache>
                 <c:ptCount val="1"/>
                 <c:pt idx="0">
-                  <c:v>Truck Manager</c:v>
+                  <c:v>Truck Manager (60 M COP/mes ÷ 5 movs)</c:v>
                 </c:pt>
               </c:strCache>
             </c:strRef>
@@ -939,19 +945,19 @@
                   <c:v>0</c:v>
                 </c:pt>
                 <c:pt idx="1">
-                  <c:v>2703</c:v>
+                  <c:v>3243</c:v>
                 </c:pt>
                 <c:pt idx="2">
-                  <c:v>2703</c:v>
+                  <c:v>3243</c:v>
                 </c:pt>
                 <c:pt idx="3">
-                  <c:v>2703</c:v>
+                  <c:v>3243</c:v>
                 </c:pt>
                 <c:pt idx="4">
-                  <c:v>2703</c:v>
+                  <c:v>3243</c:v>
                 </c:pt>
                 <c:pt idx="5">
-                  <c:v>2703</c:v>
+                  <c:v>3243</c:v>
                 </c:pt>
               </c:numCache>
             </c:numRef>
@@ -1046,7 +1052,7 @@
             </a:ln>
           </c:spPr>
         </c:majorGridlines>
-        <c:numFmt formatCode="$#,##0" sourceLinked="0"/>
+        <c:numFmt formatCode="#,##0" sourceLinked="0"/>
         <c:majorTickMark val="out"/>
         <c:minorTickMark val="none"/>
         <c:tickLblPos val="nextTo"/>
@@ -1271,28 +1277,28 @@
                 <c:formatCode>General</c:formatCode>
                 <c:ptCount val="8"/>
                 <c:pt idx="0">
-                  <c:v>-135076.89054054068</c:v>
+                  <c:v>-135092.51921921968</c:v>
                 </c:pt>
                 <c:pt idx="1">
-                  <c:v>-2564.812972973101</c:v>
+                  <c:v>-2580.4416516521014</c:v>
                 </c:pt>
                 <c:pt idx="2">
-                  <c:v>132167.69135135133</c:v>
+                  <c:v>132152.06267267233</c:v>
                 </c:pt>
                 <c:pt idx="3">
-                  <c:v>279499.68283783784</c:v>
+                  <c:v>279484.05415915884</c:v>
                 </c:pt>
                 <c:pt idx="4">
-                  <c:v>521576.18135135155</c:v>
+                  <c:v>521560.55267267255</c:v>
                 </c:pt>
                 <c:pt idx="5">
-                  <c:v>541587.1250000009</c:v>
+                  <c:v>541571.4963213219</c:v>
                 </c:pt>
                 <c:pt idx="6">
-                  <c:v>695347.9750000006</c:v>
+                  <c:v>695332.3463213216</c:v>
                 </c:pt>
                 <c:pt idx="7">
-                  <c:v>696154.3921621628</c:v>
+                  <c:v>696138.7634834838</c:v>
                 </c:pt>
               </c:numCache>
             </c:numRef>
@@ -1409,28 +1415,28 @@
                 <c:formatCode>General</c:formatCode>
                 <c:ptCount val="8"/>
                 <c:pt idx="0">
-                  <c:v>5467.499999997672</c:v>
+                  <c:v>5451.871321318671</c:v>
                 </c:pt>
                 <c:pt idx="1">
-                  <c:v>248001.23918918753</c:v>
+                  <c:v>247985.61051050853</c:v>
                 </c:pt>
                 <c:pt idx="2">
-                  <c:v>490534.9783783774</c:v>
+                  <c:v>490519.3496996984</c:v>
                 </c:pt>
                 <c:pt idx="3">
-                  <c:v>405041.49324324215</c:v>
+                  <c:v>405025.86456456315</c:v>
                 </c:pt>
                 <c:pt idx="4">
-                  <c:v>584501.197297297</c:v>
+                  <c:v>584485.568618618</c:v>
                 </c:pt>
                 <c:pt idx="5">
-                  <c:v>521427.16216216143</c:v>
+                  <c:v>521411.53348348243</c:v>
                 </c:pt>
                 <c:pt idx="6">
-                  <c:v>660232.2810810809</c:v>
+                  <c:v>660216.6524024019</c:v>
                 </c:pt>
                 <c:pt idx="7">
-                  <c:v>633628.5162162161</c:v>
+                  <c:v>633612.8875375371</c:v>
                 </c:pt>
               </c:numCache>
             </c:numRef>
@@ -1547,28 +1553,28 @@
                 <c:formatCode>General</c:formatCode>
                 <c:ptCount val="8"/>
                 <c:pt idx="0">
-                  <c:v>-740025.2094594599</c:v>
+                  <c:v>-740040.8381381389</c:v>
                 </c:pt>
                 <c:pt idx="1">
-                  <c:v>-607513.1318918923</c:v>
+                  <c:v>-607528.7605705713</c:v>
                 </c:pt>
                 <c:pt idx="2">
-                  <c:v>-472780.62756756786</c:v>
+                  <c:v>-472796.25624624686</c:v>
                 </c:pt>
                 <c:pt idx="3">
-                  <c:v>-404109.6643243246</c:v>
+                  <c:v>-404125.2930030036</c:v>
                 </c:pt>
                 <c:pt idx="4">
-                  <c:v>-210849.18270270294</c:v>
+                  <c:v>-210864.81138138194</c:v>
                 </c:pt>
                 <c:pt idx="5">
-                  <c:v>-239654.2559459461</c:v>
+                  <c:v>-239669.8846246251</c:v>
                 </c:pt>
                 <c:pt idx="6">
-                  <c:v>-153680.4283783785</c:v>
+                  <c:v>-153696.0570570575</c:v>
                 </c:pt>
                 <c:pt idx="7">
-                  <c:v>-223438.03972972976</c:v>
+                  <c:v>-223453.66840840876</c:v>
                 </c:pt>
               </c:numCache>
             </c:numRef>
@@ -1692,7 +1698,7 @@
             </a:ln>
           </c:spPr>
         </c:majorGridlines>
-        <c:numFmt formatCode="$#,##0" sourceLinked="0"/>
+        <c:numFmt formatCode="#,##0" sourceLinked="0"/>
         <c:majorTickMark val="out"/>
         <c:minorTickMark val="none"/>
         <c:tickLblPos val="nextTo"/>
@@ -2339,7 +2345,7 @@
           <a:p>
             <a:r>
               <a:rPr lang="en-US" dirty="0"/>
-              <a:t>Gráfico: hoja Sensibilidad, sección 1 (horas del Excel). Los dientes vienen del último mes de la campaña, que queda corto y vuelve a pagar cargo fijo. Tabla: hoja Sensibilidad, sección 3, y hojas Real 2024 / Real 2025.</a:t>
+              <a:t>Gráfico: hoja Sensibilidad, sección 1 (horas del Excel). La curva sube y baja porque el último mes de la campaña puede quedar corto y vuelve a pagar cargo fijo. Tabla: hoja Sensibilidad, sección 3, y hojas Real 2024 / Real 2025.</a:t>
             </a:r>
             <a:endParaRPr lang="en-US" dirty="0"/>
           </a:p>
@@ -2451,6 +2457,94 @@
             <a:fld id="{F7021451-1387-4CA6-816F-3879F97B5CBC}" type="slidenum">
               <a:rPr lang="en-US"/>
               <a:t>4</a:t>
+            </a:fld>
+            <a:endParaRPr lang="en-US"/>
+          </a:p>
+        </p:txBody>
+      </p:sp>
+    </p:spTree>
+    <p:extLst>
+      <p:ext uri="{BB962C8B-B14F-4D97-AF65-F5344CB8AC3E}">
+        <p14:creationId xmlns:p14="http://schemas.microsoft.com/office/powerpoint/2010/main" val="1024086991"/>
+      </p:ext>
+    </p:extLst>
+  </p:cSld>
+  <p:clrMapOvr>
+    <a:masterClrMapping/>
+  </p:clrMapOvr>
+</p:notes>
+</file>
+
+<file path=ppt/notesSlides/notesSlide5.xml><?xml version="1.0" encoding="utf-8"?>
+<p:notes xmlns:a="http://schemas.openxmlformats.org/drawingml/2006/main" xmlns:r="http://schemas.openxmlformats.org/officeDocument/2006/relationships" xmlns:p="http://schemas.openxmlformats.org/presentationml/2006/main">
+  <p:cSld>
+    <p:spTree>
+      <p:nvGrpSpPr>
+        <p:cNvPr id="1" name=""/>
+        <p:cNvGrpSpPr/>
+        <p:nvPr/>
+      </p:nvGrpSpPr>
+      <p:grpSpPr>
+        <a:xfrm>
+          <a:off x="0" y="0"/>
+          <a:ext cx="0" cy="0"/>
+          <a:chOff x="0" y="0"/>
+          <a:chExt cx="0" cy="0"/>
+        </a:xfrm>
+      </p:grpSpPr>
+      <p:sp>
+        <p:nvSpPr>
+          <p:cNvPr id="2" name="Slide Image Placeholder 1"/>
+          <p:cNvSpPr>
+            <a:spLocks noGrp="1" noRot="1" noChangeAspect="1"/>
+          </p:cNvSpPr>
+          <p:nvPr>
+            <p:ph type="sldImg"/>
+          </p:nvPr>
+        </p:nvSpPr>
+        <p:spPr/>
+      </p:sp>
+      <p:sp>
+        <p:nvSpPr>
+          <p:cNvPr id="3" name="Notes Placeholder 2"/>
+          <p:cNvSpPr>
+            <a:spLocks noGrp="1"/>
+          </p:cNvSpPr>
+          <p:nvPr>
+            <p:ph type="body" idx="1"/>
+          </p:nvPr>
+        </p:nvSpPr>
+        <p:spPr/>
+        <p:txBody>
+          <a:bodyPr/>
+          <a:lstStyle/>
+          <a:p>
+            <a:r>
+              <a:rPr lang="en-US" dirty="0"/>
+              <a:t>Texto completo en Simulador_Movilizacion_GRS110.xlsx, hoja Resumen, secciones 6 y 7.</a:t>
+            </a:r>
+            <a:endParaRPr lang="en-US" dirty="0"/>
+          </a:p>
+        </p:txBody>
+      </p:sp>
+      <p:sp>
+        <p:nvSpPr>
+          <p:cNvPr id="4" name="Slide Number Placeholder 3"/>
+          <p:cNvSpPr>
+            <a:spLocks noGrp="1"/>
+          </p:cNvSpPr>
+          <p:nvPr>
+            <p:ph type="sldNum" sz="quarter" idx="10"/>
+          </p:nvPr>
+        </p:nvSpPr>
+        <p:spPr/>
+        <p:txBody>
+          <a:bodyPr/>
+          <a:lstStyle/>
+          <a:p>
+            <a:fld id="{F7021451-1387-4CA6-816F-3879F97B5CBC}" type="slidenum">
+              <a:rPr lang="en-US"/>
+              <a:t>5</a:t>
             </a:fld>
             <a:endParaRPr lang="en-US"/>
           </a:p>
@@ -3121,7 +3215,7 @@
                   <a:schemeClr val="accent1"/>
                 </a:solidFill>
               </a:rPr>
-              <a:t>Por qué la respuesta es una frontera</a:t>
+              <a:t>Por qué decide la cantidad de movilizaciones de cada mes</a:t>
             </a:r>
             <a:endParaRPr lang="en-US" sz="1300" dirty="0"/>
           </a:p>
@@ -3267,7 +3361,7 @@
                   <a:schemeClr val="tx2"/>
                 </a:solidFill>
               </a:rPr>
-              <a:t>Ahorro de la campaña de 35 pozos (~21 M USD): 0,13–0,58 M, es decir 4–17 k USD por pozo (pozo de 550–650 k)</a:t>
+              <a:t>Ahorro de la campaña de 35 pozos (~21 M USD): 0,13 M–0,58 M, es decir 4–17 k USD por pozo (pozo de 550–650 k)</a:t>
             </a:r>
             <a:endParaRPr lang="en-US" sz="1400" dirty="0"/>
           </a:p>
@@ -3449,7 +3543,7 @@
                 <a:ea typeface="Cambria" pitchFamily="34" charset="-122"/>
                 <a:cs typeface="Cambria" pitchFamily="34" charset="-120"/>
               </a:rPr>
-              <a:t>No cruza</a:t>
+              <a:t>Pierde siempre</a:t>
             </a:r>
             <a:endParaRPr lang="en-US" sz="2600" dirty="0"/>
           </a:p>
@@ -3485,7 +3579,7 @@
                   <a:schemeClr val="tx1"/>
                 </a:solidFill>
               </a:rPr>
-              <a:t>con los precios del Excel</a:t>
+              <a:t>Petro Star Lump Sum</a:t>
             </a:r>
             <a:endParaRPr lang="en-US" sz="1400" dirty="0"/>
           </a:p>
@@ -3499,7 +3593,7 @@
                   <a:schemeClr val="tx2"/>
                 </a:solidFill>
               </a:rPr>
-              <a:t>Petro Star Lump Sum sin descuento. Con los precios de la cotización 1255 sí cruzaría: pendiente de Compras (SCM)</a:t>
+              <a:t>Pierde con 5 y con 6 movs/mes (−0,47 M y −0,21 M). Con los precios de la cotización 1255 quedaría en −0,03 M y +0,23 M: Compras debe aclararlos.</a:t>
             </a:r>
             <a:endParaRPr lang="en-US" sz="1400" dirty="0"/>
           </a:p>
@@ -4035,7 +4129,7 @@
                           <a:ea typeface="Calibri" pitchFamily="34" charset="-122"/>
                           <a:cs typeface="Calibri" pitchFamily="34" charset="-120"/>
                         </a:rPr>
-                        <a:t>$133.751</a:t>
+                        <a:t>133.751</a:t>
                       </a:r>
                       <a:endParaRPr lang="en-US" sz="1200" dirty="0">
                         <a:latin typeface="Calibri" charset="0"/>
@@ -4100,7 +4194,7 @@
                           <a:ea typeface="Calibri" pitchFamily="34" charset="-122"/>
                           <a:cs typeface="Calibri" pitchFamily="34" charset="-120"/>
                         </a:rPr>
-                        <a:t>$181.054</a:t>
+                        <a:t>181.054</a:t>
                       </a:r>
                       <a:endParaRPr lang="en-US" sz="1200" dirty="0">
                         <a:latin typeface="Calibri" charset="0"/>
@@ -4232,7 +4326,7 @@
                           <a:ea typeface="Calibri" pitchFamily="34" charset="-122"/>
                           <a:cs typeface="Calibri" pitchFamily="34" charset="-120"/>
                         </a:rPr>
-                        <a:t>$95.139</a:t>
+                        <a:t>95.139</a:t>
                       </a:r>
                       <a:endParaRPr lang="en-US" sz="1200" dirty="0">
                         <a:latin typeface="Calibri" charset="0"/>
@@ -4297,7 +4391,7 @@
                           <a:ea typeface="Calibri" pitchFamily="34" charset="-122"/>
                           <a:cs typeface="Calibri" pitchFamily="34" charset="-120"/>
                         </a:rPr>
-                        <a:t>$135.791</a:t>
+                        <a:t>135.791</a:t>
                       </a:r>
                       <a:endParaRPr lang="en-US" sz="1200" dirty="0">
                         <a:latin typeface="Calibri" charset="0"/>
@@ -4429,7 +4523,7 @@
                           <a:ea typeface="Calibri" pitchFamily="34" charset="-122"/>
                           <a:cs typeface="Calibri" pitchFamily="34" charset="-120"/>
                         </a:rPr>
-                        <a:t>$69.758</a:t>
+                        <a:t>69.758</a:t>
                       </a:r>
                       <a:endParaRPr lang="en-US" sz="1200" dirty="0">
                         <a:latin typeface="Calibri" charset="0"/>
@@ -4494,7 +4588,7 @@
                           <a:ea typeface="Calibri" pitchFamily="34" charset="-122"/>
                           <a:cs typeface="Calibri" pitchFamily="34" charset="-120"/>
                         </a:rPr>
-                        <a:t>$90.527</a:t>
+                        <a:t>90.527</a:t>
                       </a:r>
                       <a:endParaRPr lang="en-US" sz="1200" dirty="0">
                         <a:latin typeface="Calibri" charset="0"/>
@@ -4626,7 +4720,7 @@
                           <a:ea typeface="Calibri" pitchFamily="34" charset="-122"/>
                           <a:cs typeface="Calibri" pitchFamily="34" charset="-120"/>
                         </a:rPr>
-                        <a:t>$56.465</a:t>
+                        <a:t>56.465</a:t>
                       </a:r>
                       <a:endParaRPr lang="en-US" sz="1200" dirty="0">
                         <a:latin typeface="Calibri" charset="0"/>
@@ -4691,7 +4785,7 @@
                           <a:ea typeface="Calibri" pitchFamily="34" charset="-122"/>
                           <a:cs typeface="Calibri" pitchFamily="34" charset="-120"/>
                         </a:rPr>
-                        <a:t>$45.264</a:t>
+                        <a:t>45.264</a:t>
                       </a:r>
                       <a:endParaRPr lang="en-US" sz="1200" dirty="0">
                         <a:latin typeface="Calibri" charset="0"/>
@@ -4823,7 +4917,7 @@
                           <a:ea typeface="Calibri" pitchFamily="34" charset="-122"/>
                           <a:cs typeface="Calibri" pitchFamily="34" charset="-120"/>
                         </a:rPr>
-                        <a:t>$40.953</a:t>
+                        <a:t>40.953</a:t>
                       </a:r>
                       <a:endParaRPr lang="en-US" sz="1200" dirty="0">
                         <a:latin typeface="Calibri" charset="0"/>
@@ -5169,7 +5263,7 @@
                   <a:schemeClr val="tx1"/>
                 </a:solidFill>
               </a:rPr>
-              <a:t>Ilustración, no resultado: 2024 y 2025 repetidas con horas reales</a:t>
+              <a:t>Campañas reales 2024 y 2025 repetidas con horas reales</a:t>
             </a:r>
             <a:endParaRPr lang="en-US" sz="1400" dirty="0"/>
           </a:p>
@@ -5417,7 +5511,7 @@
                           <a:ea typeface="Calibri" pitchFamily="34" charset="-122"/>
                           <a:cs typeface="Calibri" pitchFamily="34" charset="-120"/>
                         </a:rPr>
-                        <a:t>Petro Star normal</a:t>
+                        <a:t>Petro Star tarifa normal</a:t>
                       </a:r>
                       <a:endParaRPr lang="en-US" sz="1200" dirty="0">
                         <a:latin typeface="Calibri" charset="0"/>
@@ -5811,7 +5905,7 @@
                           <a:ea typeface="Calibri" pitchFamily="34" charset="-122"/>
                           <a:cs typeface="Calibri" pitchFamily="34" charset="-120"/>
                         </a:rPr>
-                        <a:t>Lump Sum</a:t>
+                        <a:t>Petro Star Lump Sum</a:t>
                       </a:r>
                       <a:endParaRPr lang="en-US" sz="1200" dirty="0">
                         <a:latin typeface="Calibri" charset="0"/>
@@ -6195,11 +6289,11 @@
             <a:tbl>
               <a:tblPr/>
               <a:tblGrid>
-                <a:gridCol w="3291840"/>
-                <a:gridCol w="1005840"/>
-                <a:gridCol w="1005840"/>
-                <a:gridCol w="1005840"/>
-                <a:gridCol w="1005840"/>
+                <a:gridCol w="2926080"/>
+                <a:gridCol w="1097280"/>
+                <a:gridCol w="1097280"/>
+                <a:gridCol w="1097280"/>
+                <a:gridCol w="1097280"/>
               </a:tblGrid>
               <a:tr h="384048">
                 <a:tc>
@@ -6211,7 +6305,7 @@
                         <a:buNone/>
                       </a:pPr>
                       <a:r>
-                        <a:rPr lang="en-US" sz="1200" b="1" dirty="0">
+                        <a:rPr lang="en-US" sz="1100" b="1" dirty="0">
                           <a:solidFill>
                             <a:srgbClr val="1F2A36"/>
                           </a:solidFill>
@@ -6221,7 +6315,7 @@
                         </a:rPr>
                         <a:t>Qué borra el ahorro</a:t>
                       </a:r>
-                      <a:endParaRPr lang="en-US" sz="1200" dirty="0">
+                      <a:endParaRPr lang="en-US" sz="1100" dirty="0">
                         <a:latin typeface="Calibri" charset="0"/>
                         <a:ea typeface="Calibri" charset="0"/>
                         <a:cs typeface="Calibri" charset="0"/>
@@ -6276,7 +6370,7 @@
                         <a:buNone/>
                       </a:pPr>
                       <a:r>
-                        <a:rPr lang="en-US" sz="1200" b="1" dirty="0">
+                        <a:rPr lang="en-US" sz="1100" b="1" dirty="0">
                           <a:solidFill>
                             <a:srgbClr val="1F2A36"/>
                           </a:solidFill>
@@ -6284,9 +6378,9 @@
                           <a:ea typeface="Calibri" pitchFamily="34" charset="-122"/>
                           <a:cs typeface="Calibri" pitchFamily="34" charset="-120"/>
                         </a:rPr>
-                        <a:t>PS · 5/mes</a:t>
+                        <a:t>Petro Star · 5/mes</a:t>
                       </a:r>
-                      <a:endParaRPr lang="en-US" sz="1200" dirty="0">
+                      <a:endParaRPr lang="en-US" sz="1100" dirty="0">
                         <a:latin typeface="Calibri" charset="0"/>
                         <a:ea typeface="Calibri" charset="0"/>
                         <a:cs typeface="Calibri" charset="0"/>
@@ -6341,7 +6435,7 @@
                         <a:buNone/>
                       </a:pPr>
                       <a:r>
-                        <a:rPr lang="en-US" sz="1200" b="1" dirty="0">
+                        <a:rPr lang="en-US" sz="1100" b="1" dirty="0">
                           <a:solidFill>
                             <a:srgbClr val="1F2A36"/>
                           </a:solidFill>
@@ -6349,9 +6443,9 @@
                           <a:ea typeface="Calibri" pitchFamily="34" charset="-122"/>
                           <a:cs typeface="Calibri" pitchFamily="34" charset="-120"/>
                         </a:rPr>
-                        <a:t>PS · 6/mes</a:t>
+                        <a:t>Petro Star · 6/mes</a:t>
                       </a:r>
-                      <a:endParaRPr lang="en-US" sz="1200" dirty="0">
+                      <a:endParaRPr lang="en-US" sz="1100" dirty="0">
                         <a:latin typeface="Calibri" charset="0"/>
                         <a:ea typeface="Calibri" charset="0"/>
                         <a:cs typeface="Calibri" charset="0"/>
@@ -6406,7 +6500,7 @@
                         <a:buNone/>
                       </a:pPr>
                       <a:r>
-                        <a:rPr lang="en-US" sz="1200" b="1" dirty="0">
+                        <a:rPr lang="en-US" sz="1100" b="1" dirty="0">
                           <a:solidFill>
                             <a:srgbClr val="1F2A36"/>
                           </a:solidFill>
@@ -6414,9 +6508,9 @@
                           <a:ea typeface="Calibri" pitchFamily="34" charset="-122"/>
                           <a:cs typeface="Calibri" pitchFamily="34" charset="-120"/>
                         </a:rPr>
-                        <a:t>Eco · 5/mes</a:t>
+                        <a:t>Ecotransur · 5/mes</a:t>
                       </a:r>
-                      <a:endParaRPr lang="en-US" sz="1200" dirty="0">
+                      <a:endParaRPr lang="en-US" sz="1100" dirty="0">
                         <a:latin typeface="Calibri" charset="0"/>
                         <a:ea typeface="Calibri" charset="0"/>
                         <a:cs typeface="Calibri" charset="0"/>
@@ -6471,7 +6565,7 @@
                         <a:buNone/>
                       </a:pPr>
                       <a:r>
-                        <a:rPr lang="en-US" sz="1200" b="1" dirty="0">
+                        <a:rPr lang="en-US" sz="1100" b="1" dirty="0">
                           <a:solidFill>
                             <a:srgbClr val="1F2A36"/>
                           </a:solidFill>
@@ -6479,9 +6573,9 @@
                           <a:ea typeface="Calibri" pitchFamily="34" charset="-122"/>
                           <a:cs typeface="Calibri" pitchFamily="34" charset="-120"/>
                         </a:rPr>
-                        <a:t>Eco · 6/mes</a:t>
+                        <a:t>Ecotransur · 6/mes</a:t>
                       </a:r>
-                      <a:endParaRPr lang="en-US" sz="1200" dirty="0">
+                      <a:endParaRPr lang="en-US" sz="1100" dirty="0">
                         <a:latin typeface="Calibri" charset="0"/>
                         <a:ea typeface="Calibri" charset="0"/>
                         <a:cs typeface="Calibri" charset="0"/>
@@ -6538,7 +6632,7 @@
                         <a:buNone/>
                       </a:pPr>
                       <a:r>
-                        <a:rPr lang="en-US" sz="1200" dirty="0">
+                        <a:rPr lang="en-US" sz="1100" dirty="0">
                           <a:solidFill>
                             <a:srgbClr val="1F2A36"/>
                           </a:solidFill>
@@ -6548,7 +6642,7 @@
                         </a:rPr>
                         <a:t>Ahorro de la campaña (USD)</a:t>
                       </a:r>
-                      <a:endParaRPr lang="en-US" sz="1200" dirty="0">
+                      <a:endParaRPr lang="en-US" sz="1100" dirty="0">
                         <a:latin typeface="Calibri" charset="0"/>
                         <a:ea typeface="Calibri" charset="0"/>
                         <a:cs typeface="Calibri" charset="0"/>
@@ -6603,7 +6697,7 @@
                         <a:buNone/>
                       </a:pPr>
                       <a:r>
-                        <a:rPr lang="en-US" sz="1200" dirty="0">
+                        <a:rPr lang="en-US" sz="1100" dirty="0">
                           <a:solidFill>
                             <a:srgbClr val="1F2A36"/>
                           </a:solidFill>
@@ -6613,7 +6707,7 @@
                         </a:rPr>
                         <a:t>+0,13 M</a:t>
                       </a:r>
-                      <a:endParaRPr lang="en-US" sz="1200" dirty="0">
+                      <a:endParaRPr lang="en-US" sz="1100" dirty="0">
                         <a:latin typeface="Calibri" charset="0"/>
                         <a:ea typeface="Calibri" charset="0"/>
                         <a:cs typeface="Calibri" charset="0"/>
@@ -6668,7 +6762,7 @@
                         <a:buNone/>
                       </a:pPr>
                       <a:r>
-                        <a:rPr lang="en-US" sz="1200" dirty="0">
+                        <a:rPr lang="en-US" sz="1100" dirty="0">
                           <a:solidFill>
                             <a:srgbClr val="1F2A36"/>
                           </a:solidFill>
@@ -6678,7 +6772,7 @@
                         </a:rPr>
                         <a:t>+0,52 M</a:t>
                       </a:r>
-                      <a:endParaRPr lang="en-US" sz="1200" dirty="0">
+                      <a:endParaRPr lang="en-US" sz="1100" dirty="0">
                         <a:latin typeface="Calibri" charset="0"/>
                         <a:ea typeface="Calibri" charset="0"/>
                         <a:cs typeface="Calibri" charset="0"/>
@@ -6733,7 +6827,7 @@
                         <a:buNone/>
                       </a:pPr>
                       <a:r>
-                        <a:rPr lang="en-US" sz="1200" dirty="0">
+                        <a:rPr lang="en-US" sz="1100" dirty="0">
                           <a:solidFill>
                             <a:srgbClr val="1F2A36"/>
                           </a:solidFill>
@@ -6743,7 +6837,7 @@
                         </a:rPr>
                         <a:t>+0,49 M</a:t>
                       </a:r>
-                      <a:endParaRPr lang="en-US" sz="1200" dirty="0">
+                      <a:endParaRPr lang="en-US" sz="1100" dirty="0">
                         <a:latin typeface="Calibri" charset="0"/>
                         <a:ea typeface="Calibri" charset="0"/>
                         <a:cs typeface="Calibri" charset="0"/>
@@ -6798,7 +6892,7 @@
                         <a:buNone/>
                       </a:pPr>
                       <a:r>
-                        <a:rPr lang="en-US" sz="1200" dirty="0">
+                        <a:rPr lang="en-US" sz="1100" dirty="0">
                           <a:solidFill>
                             <a:srgbClr val="1F2A36"/>
                           </a:solidFill>
@@ -6808,7 +6902,7 @@
                         </a:rPr>
                         <a:t>+0,58 M</a:t>
                       </a:r>
-                      <a:endParaRPr lang="en-US" sz="1200" dirty="0">
+                      <a:endParaRPr lang="en-US" sz="1100" dirty="0">
                         <a:latin typeface="Calibri" charset="0"/>
                         <a:ea typeface="Calibri" charset="0"/>
                         <a:cs typeface="Calibri" charset="0"/>
@@ -6865,7 +6959,7 @@
                         <a:buNone/>
                       </a:pPr>
                       <a:r>
-                        <a:rPr lang="en-US" sz="1200" dirty="0">
+                        <a:rPr lang="en-US" sz="1100" dirty="0">
                           <a:solidFill>
                             <a:srgbClr val="1F2A36"/>
                           </a:solidFill>
@@ -6875,7 +6969,7 @@
                         </a:rPr>
                         <a:t>Ahorro por pozo (% de un pozo de 600 k)</a:t>
                       </a:r>
-                      <a:endParaRPr lang="en-US" sz="1200" dirty="0">
+                      <a:endParaRPr lang="en-US" sz="1100" dirty="0">
                         <a:latin typeface="Calibri" charset="0"/>
                         <a:ea typeface="Calibri" charset="0"/>
                         <a:cs typeface="Calibri" charset="0"/>
@@ -6930,7 +7024,7 @@
                         <a:buNone/>
                       </a:pPr>
                       <a:r>
-                        <a:rPr lang="en-US" sz="1200" dirty="0">
+                        <a:rPr lang="en-US" sz="1100" dirty="0">
                           <a:solidFill>
                             <a:srgbClr val="1F2A36"/>
                           </a:solidFill>
@@ -6940,7 +7034,7 @@
                         </a:rPr>
                         <a:t>0,6 %</a:t>
                       </a:r>
-                      <a:endParaRPr lang="en-US" sz="1200" dirty="0">
+                      <a:endParaRPr lang="en-US" sz="1100" dirty="0">
                         <a:latin typeface="Calibri" charset="0"/>
                         <a:ea typeface="Calibri" charset="0"/>
                         <a:cs typeface="Calibri" charset="0"/>
@@ -6995,7 +7089,7 @@
                         <a:buNone/>
                       </a:pPr>
                       <a:r>
-                        <a:rPr lang="en-US" sz="1200" dirty="0">
+                        <a:rPr lang="en-US" sz="1100" dirty="0">
                           <a:solidFill>
                             <a:srgbClr val="1F2A36"/>
                           </a:solidFill>
@@ -7005,7 +7099,7 @@
                         </a:rPr>
                         <a:t>2,5 %</a:t>
                       </a:r>
-                      <a:endParaRPr lang="en-US" sz="1200" dirty="0">
+                      <a:endParaRPr lang="en-US" sz="1100" dirty="0">
                         <a:latin typeface="Calibri" charset="0"/>
                         <a:ea typeface="Calibri" charset="0"/>
                         <a:cs typeface="Calibri" charset="0"/>
@@ -7060,7 +7154,7 @@
                         <a:buNone/>
                       </a:pPr>
                       <a:r>
-                        <a:rPr lang="en-US" sz="1200" dirty="0">
+                        <a:rPr lang="en-US" sz="1100" dirty="0">
                           <a:solidFill>
                             <a:srgbClr val="1F2A36"/>
                           </a:solidFill>
@@ -7070,7 +7164,7 @@
                         </a:rPr>
                         <a:t>2,3 %</a:t>
                       </a:r>
-                      <a:endParaRPr lang="en-US" sz="1200" dirty="0">
+                      <a:endParaRPr lang="en-US" sz="1100" dirty="0">
                         <a:latin typeface="Calibri" charset="0"/>
                         <a:ea typeface="Calibri" charset="0"/>
                         <a:cs typeface="Calibri" charset="0"/>
@@ -7125,7 +7219,7 @@
                         <a:buNone/>
                       </a:pPr>
                       <a:r>
-                        <a:rPr lang="en-US" sz="1200" dirty="0">
+                        <a:rPr lang="en-US" sz="1100" dirty="0">
                           <a:solidFill>
                             <a:srgbClr val="1F2A36"/>
                           </a:solidFill>
@@ -7135,7 +7229,7 @@
                         </a:rPr>
                         <a:t>2,8 %</a:t>
                       </a:r>
-                      <a:endParaRPr lang="en-US" sz="1200" dirty="0">
+                      <a:endParaRPr lang="en-US" sz="1100" dirty="0">
                         <a:latin typeface="Calibri" charset="0"/>
                         <a:ea typeface="Calibri" charset="0"/>
                         <a:cs typeface="Calibri" charset="0"/>
@@ -7192,7 +7286,7 @@
                         <a:buNone/>
                       </a:pPr>
                       <a:r>
-                        <a:rPr lang="en-US" sz="1200" dirty="0">
+                        <a:rPr lang="en-US" sz="1100" dirty="0">
                           <a:solidFill>
                             <a:srgbClr val="1F2A36"/>
                           </a:solidFill>
@@ -7202,7 +7296,7 @@
                         </a:rPr>
                         <a:t>Horas extra de taladro por movilización</a:t>
                       </a:r>
-                      <a:endParaRPr lang="en-US" sz="1200" dirty="0">
+                      <a:endParaRPr lang="en-US" sz="1100" dirty="0">
                         <a:latin typeface="Calibri" charset="0"/>
                         <a:ea typeface="Calibri" charset="0"/>
                         <a:cs typeface="Calibri" charset="0"/>
@@ -7257,7 +7351,7 @@
                         <a:buNone/>
                       </a:pPr>
                       <a:r>
-                        <a:rPr lang="en-US" sz="1200" dirty="0">
+                        <a:rPr lang="en-US" sz="1100" dirty="0">
                           <a:solidFill>
                             <a:srgbClr val="1F2A36"/>
                           </a:solidFill>
@@ -7267,7 +7361,7 @@
                         </a:rPr>
                         <a:t>2,6 h</a:t>
                       </a:r>
-                      <a:endParaRPr lang="en-US" sz="1200" dirty="0">
+                      <a:endParaRPr lang="en-US" sz="1100" dirty="0">
                         <a:latin typeface="Calibri" charset="0"/>
                         <a:ea typeface="Calibri" charset="0"/>
                         <a:cs typeface="Calibri" charset="0"/>
@@ -7322,7 +7416,7 @@
                         <a:buNone/>
                       </a:pPr>
                       <a:r>
-                        <a:rPr lang="en-US" sz="1200" dirty="0">
+                        <a:rPr lang="en-US" sz="1100" dirty="0">
                           <a:solidFill>
                             <a:srgbClr val="1F2A36"/>
                           </a:solidFill>
@@ -7332,7 +7426,7 @@
                         </a:rPr>
                         <a:t>10,2 h</a:t>
                       </a:r>
-                      <a:endParaRPr lang="en-US" sz="1200" dirty="0">
+                      <a:endParaRPr lang="en-US" sz="1100" dirty="0">
                         <a:latin typeface="Calibri" charset="0"/>
                         <a:ea typeface="Calibri" charset="0"/>
                         <a:cs typeface="Calibri" charset="0"/>
@@ -7387,7 +7481,7 @@
                         <a:buNone/>
                       </a:pPr>
                       <a:r>
-                        <a:rPr lang="en-US" sz="1200" dirty="0">
+                        <a:rPr lang="en-US" sz="1100" dirty="0">
                           <a:solidFill>
                             <a:srgbClr val="1F2A36"/>
                           </a:solidFill>
@@ -7397,7 +7491,7 @@
                         </a:rPr>
                         <a:t>9,6 h</a:t>
                       </a:r>
-                      <a:endParaRPr lang="en-US" sz="1200" dirty="0">
+                      <a:endParaRPr lang="en-US" sz="1100" dirty="0">
                         <a:latin typeface="Calibri" charset="0"/>
                         <a:ea typeface="Calibri" charset="0"/>
                         <a:cs typeface="Calibri" charset="0"/>
@@ -7452,7 +7546,7 @@
                         <a:buNone/>
                       </a:pPr>
                       <a:r>
-                        <a:rPr lang="en-US" sz="1200" dirty="0">
+                        <a:rPr lang="en-US" sz="1100" dirty="0">
                           <a:solidFill>
                             <a:srgbClr val="1F2A36"/>
                           </a:solidFill>
@@ -7462,7 +7556,7 @@
                         </a:rPr>
                         <a:t>11,5 h</a:t>
                       </a:r>
-                      <a:endParaRPr lang="en-US" sz="1200" dirty="0">
+                      <a:endParaRPr lang="en-US" sz="1100" dirty="0">
                         <a:latin typeface="Calibri" charset="0"/>
                         <a:ea typeface="Calibri" charset="0"/>
                         <a:cs typeface="Calibri" charset="0"/>
@@ -7519,7 +7613,7 @@
                         <a:buNone/>
                       </a:pPr>
                       <a:r>
-                        <a:rPr lang="en-US" sz="1200" dirty="0">
+                        <a:rPr lang="en-US" sz="1100" dirty="0">
                           <a:solidFill>
                             <a:srgbClr val="1F2A36"/>
                           </a:solidFill>
@@ -7529,7 +7623,7 @@
                         </a:rPr>
                         <a:t>Horas sobre el tiempo cotizado (taladro + equipos)</a:t>
                       </a:r>
-                      <a:endParaRPr lang="en-US" sz="1200" dirty="0">
+                      <a:endParaRPr lang="en-US" sz="1100" dirty="0">
                         <a:latin typeface="Calibri" charset="0"/>
                         <a:ea typeface="Calibri" charset="0"/>
                         <a:cs typeface="Calibri" charset="0"/>
@@ -7584,7 +7678,7 @@
                         <a:buNone/>
                       </a:pPr>
                       <a:r>
-                        <a:rPr lang="en-US" sz="1200" dirty="0">
+                        <a:rPr lang="en-US" sz="1100" dirty="0">
                           <a:solidFill>
                             <a:srgbClr val="1F2A36"/>
                           </a:solidFill>
@@ -7594,7 +7688,7 @@
                         </a:rPr>
                         <a:t>1,3 h</a:t>
                       </a:r>
-                      <a:endParaRPr lang="en-US" sz="1200" dirty="0">
+                      <a:endParaRPr lang="en-US" sz="1100" dirty="0">
                         <a:latin typeface="Calibri" charset="0"/>
                         <a:ea typeface="Calibri" charset="0"/>
                         <a:cs typeface="Calibri" charset="0"/>
@@ -7649,7 +7743,7 @@
                         <a:buNone/>
                       </a:pPr>
                       <a:r>
-                        <a:rPr lang="en-US" sz="1200" dirty="0">
+                        <a:rPr lang="en-US" sz="1100" dirty="0">
                           <a:solidFill>
                             <a:srgbClr val="1F2A36"/>
                           </a:solidFill>
@@ -7659,7 +7753,7 @@
                         </a:rPr>
                         <a:t>5,3 h</a:t>
                       </a:r>
-                      <a:endParaRPr lang="en-US" sz="1200" dirty="0">
+                      <a:endParaRPr lang="en-US" sz="1100" dirty="0">
                         <a:latin typeface="Calibri" charset="0"/>
                         <a:ea typeface="Calibri" charset="0"/>
                         <a:cs typeface="Calibri" charset="0"/>
@@ -7714,7 +7808,7 @@
                         <a:buNone/>
                       </a:pPr>
                       <a:r>
-                        <a:rPr lang="en-US" sz="1200" dirty="0">
+                        <a:rPr lang="en-US" sz="1100" dirty="0">
                           <a:solidFill>
                             <a:srgbClr val="1F2A36"/>
                           </a:solidFill>
@@ -7724,7 +7818,7 @@
                         </a:rPr>
                         <a:t>5,0 h</a:t>
                       </a:r>
-                      <a:endParaRPr lang="en-US" sz="1200" dirty="0">
+                      <a:endParaRPr lang="en-US" sz="1100" dirty="0">
                         <a:latin typeface="Calibri" charset="0"/>
                         <a:ea typeface="Calibri" charset="0"/>
                         <a:cs typeface="Calibri" charset="0"/>
@@ -7779,7 +7873,7 @@
                         <a:buNone/>
                       </a:pPr>
                       <a:r>
-                        <a:rPr lang="en-US" sz="1200" dirty="0">
+                        <a:rPr lang="en-US" sz="1100" dirty="0">
                           <a:solidFill>
                             <a:srgbClr val="1F2A36"/>
                           </a:solidFill>
@@ -7789,7 +7883,7 @@
                         </a:rPr>
                         <a:t>5,9 h</a:t>
                       </a:r>
-                      <a:endParaRPr lang="en-US" sz="1200" dirty="0">
+                      <a:endParaRPr lang="en-US" sz="1100" dirty="0">
                         <a:latin typeface="Calibri" charset="0"/>
                         <a:ea typeface="Calibri" charset="0"/>
                         <a:cs typeface="Calibri" charset="0"/>
@@ -7846,7 +7940,7 @@
                         <a:buNone/>
                       </a:pPr>
                       <a:r>
-                        <a:rPr lang="en-US" sz="1200" dirty="0">
+                        <a:rPr lang="en-US" sz="1100" dirty="0">
                           <a:solidFill>
                             <a:srgbClr val="1F2A36"/>
                           </a:solidFill>
@@ -7856,7 +7950,7 @@
                         </a:rPr>
                         <a:t>Días de taladro de demora en toda la campaña</a:t>
                       </a:r>
-                      <a:endParaRPr lang="en-US" sz="1200" dirty="0">
+                      <a:endParaRPr lang="en-US" sz="1100" dirty="0">
                         <a:latin typeface="Calibri" charset="0"/>
                         <a:ea typeface="Calibri" charset="0"/>
                         <a:cs typeface="Calibri" charset="0"/>
@@ -7911,7 +8005,7 @@
                         <a:buNone/>
                       </a:pPr>
                       <a:r>
-                        <a:rPr lang="en-US" sz="1200" dirty="0">
+                        <a:rPr lang="en-US" sz="1100" dirty="0">
                           <a:solidFill>
                             <a:srgbClr val="1F2A36"/>
                           </a:solidFill>
@@ -7921,7 +8015,7 @@
                         </a:rPr>
                         <a:t>3,8 d</a:t>
                       </a:r>
-                      <a:endParaRPr lang="en-US" sz="1200" dirty="0">
+                      <a:endParaRPr lang="en-US" sz="1100" dirty="0">
                         <a:latin typeface="Calibri" charset="0"/>
                         <a:ea typeface="Calibri" charset="0"/>
                         <a:cs typeface="Calibri" charset="0"/>
@@ -7976,7 +8070,7 @@
                         <a:buNone/>
                       </a:pPr>
                       <a:r>
-                        <a:rPr lang="en-US" sz="1200" dirty="0">
+                        <a:rPr lang="en-US" sz="1100" dirty="0">
                           <a:solidFill>
                             <a:srgbClr val="1F2A36"/>
                           </a:solidFill>
@@ -7986,7 +8080,7 @@
                         </a:rPr>
                         <a:t>14,9 d</a:t>
                       </a:r>
-                      <a:endParaRPr lang="en-US" sz="1200" dirty="0">
+                      <a:endParaRPr lang="en-US" sz="1100" dirty="0">
                         <a:latin typeface="Calibri" charset="0"/>
                         <a:ea typeface="Calibri" charset="0"/>
                         <a:cs typeface="Calibri" charset="0"/>
@@ -8041,7 +8135,7 @@
                         <a:buNone/>
                       </a:pPr>
                       <a:r>
-                        <a:rPr lang="en-US" sz="1200" dirty="0">
+                        <a:rPr lang="en-US" sz="1100" dirty="0">
                           <a:solidFill>
                             <a:srgbClr val="1F2A36"/>
                           </a:solidFill>
@@ -8051,7 +8145,7 @@
                         </a:rPr>
                         <a:t>14,0 d</a:t>
                       </a:r>
-                      <a:endParaRPr lang="en-US" sz="1200" dirty="0">
+                      <a:endParaRPr lang="en-US" sz="1100" dirty="0">
                         <a:latin typeface="Calibri" charset="0"/>
                         <a:ea typeface="Calibri" charset="0"/>
                         <a:cs typeface="Calibri" charset="0"/>
@@ -8106,7 +8200,7 @@
                         <a:buNone/>
                       </a:pPr>
                       <a:r>
-                        <a:rPr lang="en-US" sz="1200" dirty="0">
+                        <a:rPr lang="en-US" sz="1100" dirty="0">
                           <a:solidFill>
                             <a:srgbClr val="1F2A36"/>
                           </a:solidFill>
@@ -8116,7 +8210,7 @@
                         </a:rPr>
                         <a:t>16,7 d</a:t>
                       </a:r>
-                      <a:endParaRPr lang="en-US" sz="1200" dirty="0">
+                      <a:endParaRPr lang="en-US" sz="1100" dirty="0">
                         <a:latin typeface="Calibri" charset="0"/>
                         <a:ea typeface="Calibri" charset="0"/>
                         <a:cs typeface="Calibri" charset="0"/>
@@ -8173,7 +8267,7 @@
                         <a:buNone/>
                       </a:pPr>
                       <a:r>
-                        <a:rPr lang="en-US" sz="1200" dirty="0">
+                        <a:rPr lang="en-US" sz="1100" dirty="0">
                           <a:solidFill>
                             <a:srgbClr val="1F2A36"/>
                           </a:solidFill>
@@ -8183,7 +8277,7 @@
                         </a:rPr>
                         <a:t>Meses bloqueados con contrato vigente</a:t>
                       </a:r>
-                      <a:endParaRPr lang="en-US" sz="1200" dirty="0">
+                      <a:endParaRPr lang="en-US" sz="1100" dirty="0">
                         <a:latin typeface="Calibri" charset="0"/>
                         <a:ea typeface="Calibri" charset="0"/>
                         <a:cs typeface="Calibri" charset="0"/>
@@ -8238,7 +8332,7 @@
                         <a:buNone/>
                       </a:pPr>
                       <a:r>
-                        <a:rPr lang="en-US" sz="1200" dirty="0">
+                        <a:rPr lang="en-US" sz="1100" dirty="0">
                           <a:solidFill>
                             <a:srgbClr val="1F2A36"/>
                           </a:solidFill>
@@ -8246,9 +8340,9 @@
                           <a:ea typeface="Calibri" pitchFamily="34" charset="-122"/>
                           <a:cs typeface="Calibri" pitchFamily="34" charset="-120"/>
                         </a:rPr>
-                        <a:t>0,8</a:t>
+                        <a:t>0,7</a:t>
                       </a:r>
-                      <a:endParaRPr lang="en-US" sz="1200" dirty="0">
+                      <a:endParaRPr lang="en-US" sz="1100" dirty="0">
                         <a:latin typeface="Calibri" charset="0"/>
                         <a:ea typeface="Calibri" charset="0"/>
                         <a:cs typeface="Calibri" charset="0"/>
@@ -8303,7 +8397,7 @@
                         <a:buNone/>
                       </a:pPr>
                       <a:r>
-                        <a:rPr lang="en-US" sz="1200" dirty="0">
+                        <a:rPr lang="en-US" sz="1100" dirty="0">
                           <a:solidFill>
                             <a:srgbClr val="1F2A36"/>
                           </a:solidFill>
@@ -8311,9 +8405,9 @@
                           <a:ea typeface="Calibri" pitchFamily="34" charset="-122"/>
                           <a:cs typeface="Calibri" pitchFamily="34" charset="-120"/>
                         </a:rPr>
-                        <a:t>3,2</a:t>
+                        <a:t>2,9</a:t>
                       </a:r>
-                      <a:endParaRPr lang="en-US" sz="1200" dirty="0">
+                      <a:endParaRPr lang="en-US" sz="1100" dirty="0">
                         <a:latin typeface="Calibri" charset="0"/>
                         <a:ea typeface="Calibri" charset="0"/>
                         <a:cs typeface="Calibri" charset="0"/>
@@ -8368,7 +8462,7 @@
                         <a:buNone/>
                       </a:pPr>
                       <a:r>
-                        <a:rPr lang="en-US" sz="1200" dirty="0">
+                        <a:rPr lang="en-US" sz="1100" dirty="0">
                           <a:solidFill>
                             <a:srgbClr val="1F2A36"/>
                           </a:solidFill>
@@ -8376,9 +8470,9 @@
                           <a:ea typeface="Calibri" pitchFamily="34" charset="-122"/>
                           <a:cs typeface="Calibri" pitchFamily="34" charset="-120"/>
                         </a:rPr>
-                        <a:t>2,2</a:t>
+                        <a:t>2,0</a:t>
                       </a:r>
-                      <a:endParaRPr lang="en-US" sz="1200" dirty="0">
+                      <a:endParaRPr lang="en-US" sz="1100" dirty="0">
                         <a:latin typeface="Calibri" charset="0"/>
                         <a:ea typeface="Calibri" charset="0"/>
                         <a:cs typeface="Calibri" charset="0"/>
@@ -8433,7 +8527,7 @@
                         <a:buNone/>
                       </a:pPr>
                       <a:r>
-                        <a:rPr lang="en-US" sz="1200" dirty="0">
+                        <a:rPr lang="en-US" sz="1100" dirty="0">
                           <a:solidFill>
                             <a:srgbClr val="1F2A36"/>
                           </a:solidFill>
@@ -8441,9 +8535,9 @@
                           <a:ea typeface="Calibri" pitchFamily="34" charset="-122"/>
                           <a:cs typeface="Calibri" pitchFamily="34" charset="-120"/>
                         </a:rPr>
-                        <a:t>2,6</a:t>
+                        <a:t>2,4</a:t>
                       </a:r>
-                      <a:endParaRPr lang="en-US" sz="1200" dirty="0">
+                      <a:endParaRPr lang="en-US" sz="1100" dirty="0">
                         <a:latin typeface="Calibri" charset="0"/>
                         <a:ea typeface="Calibri" charset="0"/>
                         <a:cs typeface="Calibri" charset="0"/>
@@ -8535,7 +8629,7 @@
                   <a:schemeClr val="tx2"/>
                 </a:solidFill>
               </a:rPr>
-              <a:t>en el Work Order una demora, un bloqueo o un mes sin mover no cuesta nada. En el tercerizado cada hora sobre el tiempo cotizado cuesta unos 2.813 USD (taladro 1.456 + equipos y señalizadores 1.357) y un mes bloqueado paga el cargo fijo completo (Petro Star 161 k, Ecotransur 226 k).</a:t>
+              <a:t>en el Work Order una demora, un bloqueo o un mes sin mover no cuesta nada. En el tercerizado cada hora sobre el tiempo cotizado cuesta unos 2.813 USD (taladro 1.456 + equipos y señalizadores 1.357) y un mes bloqueado paga el cargo fijo más el Truck Manager (Petro Star 177 k, Ecotransur 243 k).</a:t>
             </a:r>
             <a:endParaRPr lang="en-US" sz="1200" dirty="0"/>
           </a:p>
@@ -8655,7 +8749,25 @@
                   <a:schemeClr val="bg1"/>
                 </a:solidFill>
               </a:rPr>
-              <a:t>Precios del Lump Sum: el Excel está por encima de la cotización 1255 (+0,44 M).</a:t>
+              <a:t>Precios del Lump Sum: el Excel está por encima de la cotización 1255 (+0,44 M). Lo aclara Compras.</a:t>
+            </a:r>
+            <a:endParaRPr lang="en-US" sz="1200" dirty="0"/>
+          </a:p>
+          <a:p>
+            <a:pPr marL="342900" indent="-342900">
+              <a:spcAft>
+                <a:spcPts val="600"/>
+              </a:spcAft>
+              <a:buSzPct val="100000"/>
+              <a:buChar char="•"/>
+            </a:pPr>
+            <a:r>
+              <a:rPr lang="en-US" sz="1200" dirty="0">
+                <a:solidFill>
+                  <a:schemeClr val="bg1"/>
+                </a:solidFill>
+              </a:rPr>
+              <a:t>Si Petro Star no cobra cargo fijo con 5 movilizaciones, su ahorro sube unos 0,29 M con 5 movs/mes.</a:t>
             </a:r>
             <a:endParaRPr lang="en-US" sz="1200" dirty="0"/>
           </a:p>
@@ -8716,6 +8828,380 @@
             <a:fld id="{F7021451-1387-4CA6-816F-3879F97B5CBC}" type="slidenum">
               <a:rPr b="0" lang="en-US"/>
               <a:t>4</a:t>
+            </a:fld>
+            <a:endParaRPr lang="en-US"/>
+          </a:p>
+        </p:txBody>
+      </p:sp>
+    </p:spTree>
+  </p:cSld>
+  <p:clrMapOvr>
+    <a:masterClrMapping/>
+  </p:clrMapOvr>
+</p:sld>
+</file>
+
+<file path=ppt/slides/slide5.xml><?xml version="1.0" encoding="utf-8"?>
+<p:sld xmlns:a="http://schemas.openxmlformats.org/drawingml/2006/main" xmlns:r="http://schemas.openxmlformats.org/officeDocument/2006/relationships" xmlns:p="http://schemas.openxmlformats.org/presentationml/2006/main">
+  <p:cSld name="Slide 5">
+    <p:spTree>
+      <p:nvGrpSpPr>
+        <p:cNvPr id="1" name=""/>
+        <p:cNvGrpSpPr/>
+        <p:nvPr/>
+      </p:nvGrpSpPr>
+      <p:grpSpPr>
+        <a:xfrm>
+          <a:off x="0" y="0"/>
+          <a:ext cx="0" cy="0"/>
+          <a:chOff x="0" y="0"/>
+          <a:chExt cx="0" cy="0"/>
+        </a:xfrm>
+      </p:grpSpPr>
+      <p:sp>
+        <p:nvSpPr>
+          <p:cNvPr id="2" name="Text 0"/>
+          <p:cNvSpPr/>
+          <p:nvPr>
+            <p:ph idx="100" type="title" hasCustomPrompt="1"/>
+          </p:nvPr>
+        </p:nvSpPr>
+        <p:spPr>
+          <a:xfrm>
+            <a:off x="548640" y="320040"/>
+            <a:ext cx="11064240" cy="868680"/>
+          </a:xfrm>
+          <a:prstGeom prst="rect">
+            <a:avLst/>
+          </a:prstGeom>
+          <a:noFill/>
+          <a:ln/>
+        </p:spPr>
+        <p:txBody>
+          <a:bodyPr wrap="square" lIns="0" tIns="0" rIns="0" bIns="0" rtlCol="0" anchor="t"/>
+          <a:lstStyle/>
+          <a:p>
+            <a:pPr algn="l" indent="0" marL="0">
+              <a:buNone/>
+            </a:pPr>
+            <a:r>
+              <a:rPr lang="en-US" sz="2400" b="1" dirty="0">
+                <a:solidFill>
+                  <a:schemeClr val="tx1"/>
+                </a:solidFill>
+              </a:rPr>
+              <a:t>Recomendación: mantener el Work Order</a:t>
+            </a:r>
+            <a:endParaRPr lang="en-US" sz="2400" dirty="0"/>
+          </a:p>
+        </p:txBody>
+      </p:sp>
+      <p:sp>
+        <p:nvSpPr>
+          <p:cNvPr id="3" name="Text 1"/>
+          <p:cNvSpPr txBox="1"/>
+          <p:nvPr/>
+        </p:nvSpPr>
+        <p:spPr>
+          <a:xfrm>
+            <a:off x="548640" y="1280160"/>
+            <a:ext cx="6766560" cy="4846320"/>
+          </a:xfrm>
+          <a:prstGeom prst="rect">
+            <a:avLst/>
+          </a:prstGeom>
+          <a:noFill/>
+          <a:ln/>
+        </p:spPr>
+        <p:txBody>
+          <a:bodyPr wrap="square" lIns="0" tIns="0" rIns="0" bIns="0" rtlCol="0" anchor="t"/>
+          <a:lstStyle/>
+          <a:p>
+            <a:pPr indent="0" marL="0">
+              <a:spcAft>
+                <a:spcPts val="400"/>
+              </a:spcAft>
+              <a:buNone/>
+            </a:pPr>
+            <a:r>
+              <a:rPr lang="en-US" sz="1600" b="1" dirty="0">
+                <a:solidFill>
+                  <a:schemeClr val="accent1"/>
+                </a:solidFill>
+              </a:rPr>
+              <a:t>Conclusión</a:t>
+            </a:r>
+            <a:endParaRPr lang="en-US" sz="1300" dirty="0"/>
+          </a:p>
+          <a:p>
+            <a:pPr marL="342900" indent="-342900">
+              <a:spcAft>
+                <a:spcPts val="800"/>
+              </a:spcAft>
+              <a:buSzPct val="100000"/>
+              <a:buChar char="•"/>
+            </a:pPr>
+            <a:r>
+              <a:rPr lang="en-US" sz="1300" dirty="0">
+                <a:solidFill>
+                  <a:schemeClr val="tx1"/>
+                </a:solidFill>
+              </a:rPr>
+              <a:t>El tercerizado solo ahorra si se sostienen 5 a 6 movilizaciones todos los meses y cada movilización cumple el tiempo cotizado: +0,13 M a +0,52 M con Petro Star tarifa normal y +0,49 M a +0,58 M con Ecotransur, en una campaña de unos 21 M (menos del 3 %).</a:t>
+            </a:r>
+            <a:endParaRPr lang="en-US" sz="1300" dirty="0"/>
+          </a:p>
+          <a:p>
+            <a:pPr marL="342900" indent="-342900">
+              <a:spcAft>
+                <a:spcPts val="800"/>
+              </a:spcAft>
+              <a:buSzPct val="100000"/>
+              <a:buChar char="•"/>
+            </a:pPr>
+            <a:r>
+              <a:rPr lang="en-US" sz="1300" dirty="0">
+                <a:solidFill>
+                  <a:schemeClr val="tx1"/>
+                </a:solidFill>
+              </a:rPr>
+              <a:t>El margen es delgado: con 5 movs/mes, Petro Star lo pierde con 1,3 h de más por movilización o con un mes bloqueado; Ecotransur con 5,0 h o 2,0 meses bloqueados.</a:t>
+            </a:r>
+            <a:endParaRPr lang="en-US" sz="1300" dirty="0"/>
+          </a:p>
+          <a:p>
+            <a:pPr marL="342900" indent="-342900">
+              <a:spcAft>
+                <a:spcPts val="800"/>
+              </a:spcAft>
+              <a:buSzPct val="100000"/>
+              <a:buChar char="•"/>
+            </a:pPr>
+            <a:r>
+              <a:rPr lang="en-US" sz="1300" dirty="0">
+                <a:solidFill>
+                  <a:schemeClr val="tx1"/>
+                </a:solidFill>
+              </a:rPr>
+              <a:t>La campaña real 2025 habría costado más con el tercerizado (Petro Star −71 k, Ecotransur −79 k); la de 2024, con 9 de 11 meses en 6 o más, habría ahorrado +1,14 M y +1,00 M.</a:t>
+            </a:r>
+            <a:endParaRPr lang="en-US" sz="1300" dirty="0"/>
+          </a:p>
+          <a:p>
+            <a:pPr marL="342900" indent="-342900">
+              <a:spcAft>
+                <a:spcPts val="800"/>
+              </a:spcAft>
+              <a:buSzPct val="100000"/>
+              <a:buChar char="•"/>
+            </a:pPr>
+            <a:r>
+              <a:rPr lang="en-US" sz="1300" dirty="0">
+                <a:solidFill>
+                  <a:schemeClr val="tx1"/>
+                </a:solidFill>
+              </a:rPr>
+              <a:t>El Lump Sum de Petro Star pierde en todos los escenarios con los precios del Excel.</a:t>
+            </a:r>
+            <a:endParaRPr lang="en-US" sz="1300" dirty="0"/>
+          </a:p>
+          <a:p>
+            <a:pPr marL="342900" indent="-342900">
+              <a:spcAft>
+                <a:spcPts val="800"/>
+              </a:spcAft>
+              <a:buSzPct val="100000"/>
+              <a:buChar char="•"/>
+            </a:pPr>
+            <a:r>
+              <a:rPr lang="en-US" sz="1300" dirty="0">
+                <a:solidFill>
+                  <a:schemeClr val="tx1"/>
+                </a:solidFill>
+              </a:rPr>
+              <a:t>El Work Order tiene tarifa tope y absorbe demoras, bloqueos y meses lentos; el tercerizado traslada ese riesgo a SierraCol.</a:t>
+            </a:r>
+            <a:endParaRPr lang="en-US" sz="1300" dirty="0"/>
+          </a:p>
+        </p:txBody>
+      </p:sp>
+      <p:sp>
+        <p:nvSpPr>
+          <p:cNvPr id="4" name="card7"/>
+          <p:cNvSpPr/>
+          <p:nvPr/>
+        </p:nvSpPr>
+        <p:spPr>
+          <a:xfrm>
+            <a:off x="7680960" y="1280160"/>
+            <a:ext cx="3931920" cy="3291840"/>
+          </a:xfrm>
+          <a:prstGeom prst="roundRect">
+            <a:avLst>
+              <a:gd name="adj" fmla="val 2222"/>
+            </a:avLst>
+          </a:prstGeom>
+          <a:solidFill>
+            <a:srgbClr val="1F2A36"/>
+          </a:solidFill>
+          <a:ln w="12700">
+            <a:solidFill>
+              <a:srgbClr val="1F2A36"/>
+            </a:solidFill>
+            <a:prstDash val="solid"/>
+          </a:ln>
+        </p:spPr>
+      </p:sp>
+      <p:sp>
+        <p:nvSpPr>
+          <p:cNvPr id="5" name="Text 3"/>
+          <p:cNvSpPr txBox="1"/>
+          <p:nvPr/>
+        </p:nvSpPr>
+        <p:spPr>
+          <a:xfrm>
+            <a:off x="7863840" y="1463040"/>
+            <a:ext cx="3566160" cy="3017520"/>
+          </a:xfrm>
+          <a:prstGeom prst="rect">
+            <a:avLst/>
+          </a:prstGeom>
+          <a:noFill/>
+          <a:ln/>
+        </p:spPr>
+        <p:txBody>
+          <a:bodyPr wrap="square" lIns="0" tIns="0" rIns="0" bIns="0" rtlCol="0" anchor="t"/>
+          <a:lstStyle/>
+          <a:p>
+            <a:pPr indent="0" marL="0">
+              <a:spcAft>
+                <a:spcPts val="600"/>
+              </a:spcAft>
+              <a:buNone/>
+            </a:pPr>
+            <a:r>
+              <a:rPr lang="en-US" sz="1500" b="1" dirty="0">
+                <a:solidFill>
+                  <a:schemeClr val="accent1"/>
+                </a:solidFill>
+              </a:rPr>
+              <a:t>Se reconsidera el tercerizado solo si:</a:t>
+            </a:r>
+            <a:endParaRPr lang="en-US" sz="1300" dirty="0"/>
+          </a:p>
+          <a:p>
+            <a:pPr marL="342900" indent="-342900">
+              <a:spcAft>
+                <a:spcPts val="600"/>
+              </a:spcAft>
+              <a:buSzPct val="100000"/>
+              <a:buFont typeface="+mj-lt"/>
+              <a:buAutoNum type="arabicPeriod" startAt="1"/>
+            </a:pPr>
+            <a:r>
+              <a:rPr lang="en-US" sz="1300" dirty="0">
+                <a:solidFill>
+                  <a:schemeClr val="bg1"/>
+                </a:solidFill>
+              </a:rPr>
+              <a:t>Hay un plan de pozos con 6 o más movilizaciones todos los meses.</a:t>
+            </a:r>
+            <a:endParaRPr lang="en-US" sz="1300" dirty="0"/>
+          </a:p>
+          <a:p>
+            <a:pPr marL="342900" indent="-342900">
+              <a:spcAft>
+                <a:spcPts val="600"/>
+              </a:spcAft>
+              <a:buSzPct val="100000"/>
+              <a:buFont typeface="+mj-lt"/>
+              <a:buAutoNum type="arabicPeriod" startAt="1"/>
+            </a:pPr>
+            <a:r>
+              <a:rPr lang="en-US" sz="1300" dirty="0">
+                <a:solidFill>
+                  <a:schemeClr val="bg1"/>
+                </a:solidFill>
+              </a:rPr>
+              <a:t>El contrato pone tope de horas o penalidad al transportador por pasarse del tiempo cotizado.</a:t>
+            </a:r>
+            <a:endParaRPr lang="en-US" sz="1300" dirty="0"/>
+          </a:p>
+          <a:p>
+            <a:pPr marL="342900" indent="-342900">
+              <a:spcAft>
+                <a:spcPts val="1200"/>
+              </a:spcAft>
+              <a:buSzPct val="100000"/>
+              <a:buFont typeface="+mj-lt"/>
+              <a:buAutoNum type="arabicPeriod" startAt="1"/>
+            </a:pPr>
+            <a:r>
+              <a:rPr lang="en-US" sz="1300" dirty="0">
+                <a:solidFill>
+                  <a:schemeClr val="bg1"/>
+                </a:solidFill>
+              </a:rPr>
+              <a:t>Una cláusula suspende el cargo fijo en meses con bloqueos o problemas operativos.</a:t>
+            </a:r>
+            <a:endParaRPr lang="en-US" sz="1300" dirty="0"/>
+          </a:p>
+          <a:p>
+            <a:pPr indent="0" marL="0">
+              <a:buNone/>
+            </a:pPr>
+            <a:r>
+              <a:rPr lang="en-US" sz="1200" dirty="0">
+                <a:solidFill>
+                  <a:schemeClr val="bg1"/>
+                </a:solidFill>
+              </a:rPr>
+              <a:t>Antes de negociar: Compras aclara los precios del Lump Sum y Petro Star confirma si cobra cargo fijo con 5 movilizaciones.</a:t>
+            </a:r>
+            <a:endParaRPr lang="en-US" sz="1300" dirty="0"/>
+          </a:p>
+        </p:txBody>
+      </p:sp>
+      <p:sp>
+        <p:nvSpPr>
+          <p:cNvPr id="25" name="Slide Number Placeholder 0"/>
+          <p:cNvSpPr>
+            <a:spLocks noGrp="1"/>
+          </p:cNvSpPr>
+          <p:nvPr>
+            <p:ph type="sldNum" sz="quarter" idx="4294967295"/>
+          </p:nvPr>
+        </p:nvSpPr>
+        <p:spPr>
+          <a:xfrm>
+            <a:off x="11247120" y="6400800"/>
+            <a:ext cx="457200" cy="274320"/>
+          </a:xfrm>
+          <a:prstGeom prst="rect">
+            <a:avLst/>
+          </a:prstGeom>
+          <a:extLst>
+            <a:ext uri="{C572A759-6A51-4108-AA02-DFA0A04FC94B}">
+              <ma14:wrappingTextBoxFlag xmlns:ma14="http://schemas.microsoft.com/office/mac/drawingml/2011/main" val="0"/>
+            </a:ext>
+          </a:extLst>
+        </p:spPr>
+        <p:txBody>
+          <a:bodyPr/>
+          <a:lstStyle>
+            <a:lvl1pPr>
+              <a:defRPr sz="900">
+                <a:solidFill>
+                  <a:schemeClr val="tx2"/>
+                </a:solidFill>
+              </a:defRPr>
+            </a:lvl1pPr>
+          </a:lstStyle>
+          <a:p>
+            <a:pPr algn="l"/>
+            <a:fld id="{F7021451-1387-4CA6-816F-3879F97B5CBC}" type="slidenum">
+              <a:rPr b="0" lang="en-US"/>
+              <a:t>5</a:t>
             </a:fld>
             <a:endParaRPr lang="en-US"/>
           </a:p>

</xml_diff>